<commit_message>
API tests: assert required behaviour and mark known defects
- The collection asserts the required behaviour; known defects are
  labelled [DEFECT #n] and fail on purpose (5 assertions), mirroring
  @defect in the E2E suite
- Update README, findings deck and the local Newman report
</commit_message>
<xml_diff>
--- a/api-tests/road-overview-api-findings.pptx
+++ b/api-tests/road-overview-api-findings.pptx
@@ -1759,7 +1759,7 @@
                 <a:ea typeface="Cambria" pitchFamily="34" charset="-122"/>
                 <a:cs typeface="Cambria" pitchFamily="34" charset="-120"/>
               </a:rPr>
-              <a:t>34</a:t>
+              <a:t>32</a:t>
             </a:r>
             <a:endParaRPr lang="en-US" sz="4400" dirty="0"/>
           </a:p>
@@ -1837,7 +1837,7 @@
                 <a:ea typeface="Cambria" pitchFamily="34" charset="-122"/>
                 <a:cs typeface="Cambria" pitchFamily="34" charset="-120"/>
               </a:rPr>
-              <a:t>80</a:t>
+              <a:t>77</a:t>
             </a:r>
             <a:endParaRPr lang="en-US" sz="4400" dirty="0"/>
           </a:p>
@@ -1915,7 +1915,7 @@
                 <a:ea typeface="Cambria" pitchFamily="34" charset="-122"/>
                 <a:cs typeface="Cambria" pitchFamily="34" charset="-120"/>
               </a:rPr>
-              <a:t>6</a:t>
+              <a:t>7</a:t>
             </a:r>
             <a:endParaRPr lang="en-US" sz="4400" dirty="0"/>
           </a:p>
@@ -1987,13 +1987,13 @@
             <a:r>
               <a:rPr lang="en-US" sz="4400" b="1" dirty="0">
                 <a:solidFill>
-                  <a:srgbClr val="27AE60"/>
+                  <a:srgbClr val="E74C3C"/>
                 </a:solidFill>
                 <a:latin typeface="Cambria" pitchFamily="34" charset="0"/>
                 <a:ea typeface="Cambria" pitchFamily="34" charset="-122"/>
                 <a:cs typeface="Cambria" pitchFamily="34" charset="-120"/>
               </a:rPr>
-              <a:t>0</a:t>
+              <a:t>5</a:t>
             </a:r>
             <a:endParaRPr lang="en-US" sz="4400" dirty="0"/>
           </a:p>
@@ -2032,7 +2032,7 @@
                 <a:ea typeface="Calibri" pitchFamily="34" charset="-122"/>
                 <a:cs typeface="Calibri" pitchFamily="34" charset="-120"/>
               </a:rPr>
-              <a:t>Failed</a:t>
+              <a:t>Failed = bekannte Defekte</a:t>
             </a:r>
             <a:endParaRPr lang="en-US" sz="1300" dirty="0"/>
           </a:p>
@@ -2071,7 +2071,7 @@
                 <a:ea typeface="Calibri" pitchFamily="34" charset="-122"/>
                 <a:cs typeface="Calibri" pitchFamily="34" charset="-120"/>
               </a:rPr>
-              <a:t>Newman-verifiziert · empirisch gegen json-server@0.17.4 · self-cleaning / idempotent</a:t>
+              <a:t>Newman-verifiziert gegen json-server@0.17.4 · Soll-Assertions, Defekte bewusst rot · self-cleaning</a:t>
             </a:r>
             <a:endParaRPr lang="en-US" sz="1200" dirty="0"/>
           </a:p>
@@ -2181,7 +2181,7 @@
                 <a:ea typeface="Calibri" pitchFamily="34" charset="-122"/>
                 <a:cs typeface="Calibri" pitchFamily="34" charset="-120"/>
               </a:rPr>
-              <a:t>Erwartungswerte nicht angenommen – jedes Verhalten real beobachtet</a:t>
+              <a:t>Ist-Verhalten real beobachtet – Assertions prüfen das Soll</a:t>
             </a:r>
             <a:endParaRPr lang="en-US" sz="1400" dirty="0"/>
           </a:p>
@@ -2318,7 +2318,7 @@
                 <a:ea typeface="Calibri" pitchFamily="34" charset="-122"/>
                 <a:cs typeface="Calibri" pitchFamily="34" charset="-120"/>
               </a:rPr>
-              <a:t>json-server@0.17.4 auf :3000 – identisch zur SUT-Version (Docker-pinned).</a:t>
+              <a:t>json-server@0.17.4 als isolierte Instanz – identisch zur SUT-Version (Docker-pinned).</a:t>
             </a:r>
             <a:endParaRPr lang="en-US" sz="1350" dirty="0"/>
           </a:p>
@@ -2553,7 +2553,7 @@
                 <a:ea typeface="Calibri" pitchFamily="34" charset="-122"/>
                 <a:cs typeface="Calibri" pitchFamily="34" charset="-120"/>
               </a:rPr>
-              <a:t>Assertions geschrieben</a:t>
+              <a:t>Soll-Assertions geschrieben</a:t>
             </a:r>
             <a:endParaRPr lang="en-US" sz="1800" dirty="0"/>
           </a:p>
@@ -2592,7 +2592,7 @@
                 <a:ea typeface="Calibri" pitchFamily="34" charset="-122"/>
                 <a:cs typeface="Calibri" pitchFamily="34" charset="-120"/>
               </a:rPr>
-              <a:t>Postman v2.1-Collection, pm.test gegen das beobachtete Verhalten.</a:t>
+              <a:t>pm.test prüft das korrekte Verhalten; Abweichungen als [DEFECT #n] markiert.</a:t>
             </a:r>
             <a:endParaRPr lang="en-US" sz="1350" dirty="0"/>
           </a:p>
@@ -2729,7 +2729,7 @@
                 <a:ea typeface="Calibri" pitchFamily="34" charset="-122"/>
                 <a:cs typeface="Calibri" pitchFamily="34" charset="-120"/>
               </a:rPr>
-              <a:t>Newman-Lauf grün (34/80/0). Self-cleaning bestätigt (2× Lauf, DB sauber).</a:t>
+              <a:t>Newman: 32 Requests / 77 Assertions / 5 rot = bekannte Defekte. Self-cleaning bestätigt.</a:t>
             </a:r>
             <a:endParaRPr lang="en-US" sz="1350" dirty="0"/>
           </a:p>
@@ -3095,7 +3095,7 @@
                 <a:ea typeface="Calibri" pitchFamily="34" charset="-122"/>
                 <a:cs typeface="Calibri" pitchFamily="34" charset="-120"/>
               </a:rPr>
-              <a:t>Über die API entdeckt, nach Schweregrad priorisiert</a:t>
+              <a:t>Nach Schweregrad priorisiert · rechts: Status im Newman-Lauf ([DEFECT #n] = bewusst rot)</a:t>
             </a:r>
             <a:endParaRPr lang="en-US" sz="1400" dirty="0"/>
           </a:p>
@@ -3110,7 +3110,7 @@
         <p:spPr>
           <a:xfrm>
             <a:off x="548640" y="1600200"/>
-            <a:ext cx="11064240" cy="658368"/>
+            <a:ext cx="11064240" cy="585216"/>
           </a:xfrm>
           <a:prstGeom prst="roundRect">
             <a:avLst>
@@ -3137,7 +3137,7 @@
         <p:spPr>
           <a:xfrm>
             <a:off x="713232" y="1600200"/>
-            <a:ext cx="548640" cy="658368"/>
+            <a:ext cx="548640" cy="585216"/>
           </a:xfrm>
           <a:prstGeom prst="rect">
             <a:avLst/>
@@ -3176,7 +3176,7 @@
         <p:spPr>
           <a:xfrm>
             <a:off x="1417320" y="1600200"/>
-            <a:ext cx="8229600" cy="658368"/>
+            <a:ext cx="6583680" cy="585216"/>
           </a:xfrm>
           <a:prstGeom prst="rect">
             <a:avLst/>
@@ -3208,13 +3208,52 @@
       </p:sp>
       <p:sp>
         <p:nvSpPr>
-          <p:cNvPr id="7" name="Shape 5"/>
-          <p:cNvSpPr/>
-          <p:nvPr/>
-        </p:nvSpPr>
-        <p:spPr>
-          <a:xfrm>
-            <a:off x="10104120" y="1773936"/>
+          <p:cNvPr id="7" name="Text 4"/>
+          <p:cNvSpPr/>
+          <p:nvPr/>
+        </p:nvSpPr>
+        <p:spPr>
+          <a:xfrm>
+            <a:off x="8092440" y="1600200"/>
+            <a:ext cx="1920240" cy="585216"/>
+          </a:xfrm>
+          <a:prstGeom prst="rect">
+            <a:avLst/>
+          </a:prstGeom>
+          <a:noFill/>
+          <a:ln/>
+        </p:spPr>
+        <p:txBody>
+          <a:bodyPr wrap="square" lIns="0" tIns="0" rIns="0" bIns="0" rtlCol="0" anchor="ctr"/>
+          <a:lstStyle/>
+          <a:p>
+            <a:pPr indent="0" marL="0">
+              <a:buNone/>
+            </a:pPr>
+            <a:r>
+              <a:rPr lang="en-US" sz="1100" i="1" dirty="0">
+                <a:solidFill>
+                  <a:srgbClr val="5A6483"/>
+                </a:solidFill>
+                <a:latin typeface="Calibri" pitchFamily="34" charset="0"/>
+                <a:ea typeface="Calibri" pitchFamily="34" charset="-122"/>
+                <a:cs typeface="Calibri" pitchFamily="34" charset="-120"/>
+              </a:rPr>
+              <a:t>manuell (destruktiv)</a:t>
+            </a:r>
+            <a:endParaRPr lang="en-US" sz="1100" dirty="0"/>
+          </a:p>
+        </p:txBody>
+      </p:sp>
+      <p:sp>
+        <p:nvSpPr>
+          <p:cNvPr id="8" name="Shape 5"/>
+          <p:cNvSpPr/>
+          <p:nvPr/>
+        </p:nvSpPr>
+        <p:spPr>
+          <a:xfrm>
+            <a:off x="10104120" y="1737360"/>
             <a:ext cx="1371600" cy="310896"/>
           </a:xfrm>
           <a:prstGeom prst="roundRect">
@@ -3230,13 +3269,13 @@
       </p:sp>
       <p:sp>
         <p:nvSpPr>
-          <p:cNvPr id="8" name="Text 6"/>
-          <p:cNvSpPr/>
-          <p:nvPr/>
-        </p:nvSpPr>
-        <p:spPr>
-          <a:xfrm>
-            <a:off x="10104120" y="1773936"/>
+          <p:cNvPr id="9" name="Text 6"/>
+          <p:cNvSpPr/>
+          <p:nvPr/>
+        </p:nvSpPr>
+        <p:spPr>
+          <a:xfrm>
+            <a:off x="10104120" y="1737360"/>
             <a:ext cx="1371600" cy="310896"/>
           </a:xfrm>
           <a:prstGeom prst="rect">
@@ -3269,14 +3308,14 @@
       </p:sp>
       <p:sp>
         <p:nvSpPr>
-          <p:cNvPr id="9" name="Shape 7"/>
-          <p:cNvSpPr/>
-          <p:nvPr/>
-        </p:nvSpPr>
-        <p:spPr>
-          <a:xfrm>
-            <a:off x="548640" y="2359152"/>
-            <a:ext cx="11064240" cy="658368"/>
+          <p:cNvPr id="10" name="Shape 2"/>
+          <p:cNvSpPr/>
+          <p:nvPr/>
+        </p:nvSpPr>
+        <p:spPr>
+          <a:xfrm>
+            <a:off x="548640" y="2276856"/>
+            <a:ext cx="11064240" cy="585216"/>
           </a:xfrm>
           <a:prstGeom prst="roundRect">
             <a:avLst>
@@ -3296,14 +3335,14 @@
       </p:sp>
       <p:sp>
         <p:nvSpPr>
-          <p:cNvPr id="10" name="Text 8"/>
-          <p:cNvSpPr/>
-          <p:nvPr/>
-        </p:nvSpPr>
-        <p:spPr>
-          <a:xfrm>
-            <a:off x="713232" y="2359152"/>
-            <a:ext cx="548640" cy="658368"/>
+          <p:cNvPr id="11" name="Text 3"/>
+          <p:cNvSpPr/>
+          <p:nvPr/>
+        </p:nvSpPr>
+        <p:spPr>
+          <a:xfrm>
+            <a:off x="713232" y="2276856"/>
+            <a:ext cx="548640" cy="585216"/>
           </a:xfrm>
           <a:prstGeom prst="rect">
             <a:avLst/>
@@ -3335,14 +3374,14 @@
       </p:sp>
       <p:sp>
         <p:nvSpPr>
-          <p:cNvPr id="11" name="Text 9"/>
-          <p:cNvSpPr/>
-          <p:nvPr/>
-        </p:nvSpPr>
-        <p:spPr>
-          <a:xfrm>
-            <a:off x="1417320" y="2359152"/>
-            <a:ext cx="8229600" cy="658368"/>
+          <p:cNvPr id="12" name="Text 4"/>
+          <p:cNvSpPr/>
+          <p:nvPr/>
+        </p:nvSpPr>
+        <p:spPr>
+          <a:xfrm>
+            <a:off x="1417320" y="2276856"/>
+            <a:ext cx="6583680" cy="585216"/>
           </a:xfrm>
           <a:prstGeom prst="rect">
             <a:avLst/>
@@ -3374,13 +3413,52 @@
       </p:sp>
       <p:sp>
         <p:nvSpPr>
-          <p:cNvPr id="12" name="Shape 10"/>
-          <p:cNvSpPr/>
-          <p:nvPr/>
-        </p:nvSpPr>
-        <p:spPr>
-          <a:xfrm>
-            <a:off x="10104120" y="2532888"/>
+          <p:cNvPr id="13" name="Text 4"/>
+          <p:cNvSpPr/>
+          <p:nvPr/>
+        </p:nvSpPr>
+        <p:spPr>
+          <a:xfrm>
+            <a:off x="8092440" y="2276856"/>
+            <a:ext cx="1920240" cy="585216"/>
+          </a:xfrm>
+          <a:prstGeom prst="rect">
+            <a:avLst/>
+          </a:prstGeom>
+          <a:noFill/>
+          <a:ln/>
+        </p:spPr>
+        <p:txBody>
+          <a:bodyPr wrap="square" lIns="0" tIns="0" rIns="0" bIns="0" rtlCol="0" anchor="ctr"/>
+          <a:lstStyle/>
+          <a:p>
+            <a:pPr indent="0" marL="0">
+              <a:buNone/>
+            </a:pPr>
+            <a:r>
+              <a:rPr lang="en-US" sz="1100" b="1" dirty="0">
+                <a:solidFill>
+                  <a:srgbClr val="C0392B"/>
+                </a:solidFill>
+                <a:latin typeface="Calibri" pitchFamily="34" charset="0"/>
+                <a:ea typeface="Calibri" pitchFamily="34" charset="-122"/>
+                <a:cs typeface="Calibri" pitchFamily="34" charset="-120"/>
+              </a:rPr>
+              <a:t>Test rot</a:t>
+            </a:r>
+            <a:endParaRPr lang="en-US" sz="1100" dirty="0"/>
+          </a:p>
+        </p:txBody>
+      </p:sp>
+      <p:sp>
+        <p:nvSpPr>
+          <p:cNvPr id="14" name="Shape 5"/>
+          <p:cNvSpPr/>
+          <p:nvPr/>
+        </p:nvSpPr>
+        <p:spPr>
+          <a:xfrm>
+            <a:off x="10104120" y="2414016"/>
             <a:ext cx="1371600" cy="310896"/>
           </a:xfrm>
           <a:prstGeom prst="roundRect">
@@ -3396,13 +3474,13 @@
       </p:sp>
       <p:sp>
         <p:nvSpPr>
-          <p:cNvPr id="13" name="Text 11"/>
-          <p:cNvSpPr/>
-          <p:nvPr/>
-        </p:nvSpPr>
-        <p:spPr>
-          <a:xfrm>
-            <a:off x="10104120" y="2532888"/>
+          <p:cNvPr id="15" name="Text 6"/>
+          <p:cNvSpPr/>
+          <p:nvPr/>
+        </p:nvSpPr>
+        <p:spPr>
+          <a:xfrm>
+            <a:off x="10104120" y="2414016"/>
             <a:ext cx="1371600" cy="310896"/>
           </a:xfrm>
           <a:prstGeom prst="rect">
@@ -3435,14 +3513,14 @@
       </p:sp>
       <p:sp>
         <p:nvSpPr>
-          <p:cNvPr id="14" name="Shape 12"/>
-          <p:cNvSpPr/>
-          <p:nvPr/>
-        </p:nvSpPr>
-        <p:spPr>
-          <a:xfrm>
-            <a:off x="548640" y="3118104"/>
-            <a:ext cx="11064240" cy="658368"/>
+          <p:cNvPr id="16" name="Shape 2"/>
+          <p:cNvSpPr/>
+          <p:nvPr/>
+        </p:nvSpPr>
+        <p:spPr>
+          <a:xfrm>
+            <a:off x="548640" y="2953512"/>
+            <a:ext cx="11064240" cy="585216"/>
           </a:xfrm>
           <a:prstGeom prst="roundRect">
             <a:avLst>
@@ -3462,14 +3540,14 @@
       </p:sp>
       <p:sp>
         <p:nvSpPr>
-          <p:cNvPr id="15" name="Text 13"/>
-          <p:cNvSpPr/>
-          <p:nvPr/>
-        </p:nvSpPr>
-        <p:spPr>
-          <a:xfrm>
-            <a:off x="713232" y="3118104"/>
-            <a:ext cx="548640" cy="658368"/>
+          <p:cNvPr id="17" name="Text 3"/>
+          <p:cNvSpPr/>
+          <p:nvPr/>
+        </p:nvSpPr>
+        <p:spPr>
+          <a:xfrm>
+            <a:off x="713232" y="2953512"/>
+            <a:ext cx="548640" cy="585216"/>
           </a:xfrm>
           <a:prstGeom prst="rect">
             <a:avLst/>
@@ -3501,14 +3579,14 @@
       </p:sp>
       <p:sp>
         <p:nvSpPr>
-          <p:cNvPr id="16" name="Text 14"/>
-          <p:cNvSpPr/>
-          <p:nvPr/>
-        </p:nvSpPr>
-        <p:spPr>
-          <a:xfrm>
-            <a:off x="1417320" y="3118104"/>
-            <a:ext cx="8229600" cy="658368"/>
+          <p:cNvPr id="18" name="Text 4"/>
+          <p:cNvSpPr/>
+          <p:nvPr/>
+        </p:nvSpPr>
+        <p:spPr>
+          <a:xfrm>
+            <a:off x="1417320" y="2953512"/>
+            <a:ext cx="6583680" cy="585216"/>
           </a:xfrm>
           <a:prstGeom prst="rect">
             <a:avLst/>
@@ -3532,7 +3610,7 @@
                 <a:ea typeface="Calibri" pitchFamily="34" charset="-122"/>
                 <a:cs typeface="Calibri" pitchFamily="34" charset="-120"/>
               </a:rPr>
-              <a:t>Falscher Content-Type → Body still verworfen</a:t>
+              <a:t>CORS erlaubt jede Origin (inkl. Credentials)</a:t>
             </a:r>
             <a:endParaRPr lang="en-US" sz="1550" dirty="0"/>
           </a:p>
@@ -3540,13 +3618,52 @@
       </p:sp>
       <p:sp>
         <p:nvSpPr>
-          <p:cNvPr id="17" name="Shape 15"/>
-          <p:cNvSpPr/>
-          <p:nvPr/>
-        </p:nvSpPr>
-        <p:spPr>
-          <a:xfrm>
-            <a:off x="10104120" y="3291840"/>
+          <p:cNvPr id="19" name="Text 4"/>
+          <p:cNvSpPr/>
+          <p:nvPr/>
+        </p:nvSpPr>
+        <p:spPr>
+          <a:xfrm>
+            <a:off x="8092440" y="2953512"/>
+            <a:ext cx="1920240" cy="585216"/>
+          </a:xfrm>
+          <a:prstGeom prst="rect">
+            <a:avLst/>
+          </a:prstGeom>
+          <a:noFill/>
+          <a:ln/>
+        </p:spPr>
+        <p:txBody>
+          <a:bodyPr wrap="square" lIns="0" tIns="0" rIns="0" bIns="0" rtlCol="0" anchor="ctr"/>
+          <a:lstStyle/>
+          <a:p>
+            <a:pPr indent="0" marL="0">
+              <a:buNone/>
+            </a:pPr>
+            <a:r>
+              <a:rPr lang="en-US" sz="1100" b="1" dirty="0">
+                <a:solidFill>
+                  <a:srgbClr val="C0392B"/>
+                </a:solidFill>
+                <a:latin typeface="Calibri" pitchFamily="34" charset="0"/>
+                <a:ea typeface="Calibri" pitchFamily="34" charset="-122"/>
+                <a:cs typeface="Calibri" pitchFamily="34" charset="-120"/>
+              </a:rPr>
+              <a:t>Test rot</a:t>
+            </a:r>
+            <a:endParaRPr lang="en-US" sz="1100" dirty="0"/>
+          </a:p>
+        </p:txBody>
+      </p:sp>
+      <p:sp>
+        <p:nvSpPr>
+          <p:cNvPr id="20" name="Shape 5"/>
+          <p:cNvSpPr/>
+          <p:nvPr/>
+        </p:nvSpPr>
+        <p:spPr>
+          <a:xfrm>
+            <a:off x="10104120" y="3090672"/>
             <a:ext cx="1371600" cy="310896"/>
           </a:xfrm>
           <a:prstGeom prst="roundRect">
@@ -3562,13 +3679,13 @@
       </p:sp>
       <p:sp>
         <p:nvSpPr>
-          <p:cNvPr id="18" name="Text 16"/>
-          <p:cNvSpPr/>
-          <p:nvPr/>
-        </p:nvSpPr>
-        <p:spPr>
-          <a:xfrm>
-            <a:off x="10104120" y="3291840"/>
+          <p:cNvPr id="21" name="Text 6"/>
+          <p:cNvSpPr/>
+          <p:nvPr/>
+        </p:nvSpPr>
+        <p:spPr>
+          <a:xfrm>
+            <a:off x="10104120" y="3090672"/>
             <a:ext cx="1371600" cy="310896"/>
           </a:xfrm>
           <a:prstGeom prst="rect">
@@ -3601,14 +3718,14 @@
       </p:sp>
       <p:sp>
         <p:nvSpPr>
-          <p:cNvPr id="19" name="Shape 17"/>
-          <p:cNvSpPr/>
-          <p:nvPr/>
-        </p:nvSpPr>
-        <p:spPr>
-          <a:xfrm>
-            <a:off x="548640" y="3877056"/>
-            <a:ext cx="11064240" cy="658368"/>
+          <p:cNvPr id="22" name="Shape 2"/>
+          <p:cNvSpPr/>
+          <p:nvPr/>
+        </p:nvSpPr>
+        <p:spPr>
+          <a:xfrm>
+            <a:off x="548640" y="3630168"/>
+            <a:ext cx="11064240" cy="585216"/>
           </a:xfrm>
           <a:prstGeom prst="roundRect">
             <a:avLst>
@@ -3628,14 +3745,14 @@
       </p:sp>
       <p:sp>
         <p:nvSpPr>
-          <p:cNvPr id="20" name="Text 18"/>
-          <p:cNvSpPr/>
-          <p:nvPr/>
-        </p:nvSpPr>
-        <p:spPr>
-          <a:xfrm>
-            <a:off x="713232" y="3877056"/>
-            <a:ext cx="548640" cy="658368"/>
+          <p:cNvPr id="23" name="Text 3"/>
+          <p:cNvSpPr/>
+          <p:nvPr/>
+        </p:nvSpPr>
+        <p:spPr>
+          <a:xfrm>
+            <a:off x="713232" y="3630168"/>
+            <a:ext cx="548640" cy="585216"/>
           </a:xfrm>
           <a:prstGeom prst="rect">
             <a:avLst/>
@@ -3653,7 +3770,7 @@
             <a:r>
               <a:rPr lang="en-US" sz="2200" b="1" dirty="0">
                 <a:solidFill>
-                  <a:srgbClr val="5D6D7E"/>
+                  <a:srgbClr val="F1C40F"/>
                 </a:solidFill>
                 <a:latin typeface="Cambria" pitchFamily="34" charset="0"/>
                 <a:ea typeface="Cambria" pitchFamily="34" charset="-122"/>
@@ -3667,14 +3784,14 @@
       </p:sp>
       <p:sp>
         <p:nvSpPr>
-          <p:cNvPr id="21" name="Text 19"/>
-          <p:cNvSpPr/>
-          <p:nvPr/>
-        </p:nvSpPr>
-        <p:spPr>
-          <a:xfrm>
-            <a:off x="1417320" y="3877056"/>
-            <a:ext cx="8229600" cy="658368"/>
+          <p:cNvPr id="24" name="Text 4"/>
+          <p:cNvSpPr/>
+          <p:nvPr/>
+        </p:nvSpPr>
+        <p:spPr>
+          <a:xfrm>
+            <a:off x="1417320" y="3630168"/>
+            <a:ext cx="6583680" cy="585216"/>
           </a:xfrm>
           <a:prstGeom prst="rect">
             <a:avLst/>
@@ -3698,7 +3815,7 @@
                 <a:ea typeface="Calibri" pitchFamily="34" charset="-122"/>
                 <a:cs typeface="Calibri" pitchFamily="34" charset="-120"/>
               </a:rPr>
-              <a:t>PUT / PATCH / DELETE verfügbar, aber undokumentiert</a:t>
+              <a:t>Falscher Content-Type → Body still verworfen</a:t>
             </a:r>
             <a:endParaRPr lang="en-US" sz="1550" dirty="0"/>
           </a:p>
@@ -3706,13 +3823,52 @@
       </p:sp>
       <p:sp>
         <p:nvSpPr>
-          <p:cNvPr id="22" name="Shape 20"/>
-          <p:cNvSpPr/>
-          <p:nvPr/>
-        </p:nvSpPr>
-        <p:spPr>
-          <a:xfrm>
-            <a:off x="10104120" y="4050792"/>
+          <p:cNvPr id="25" name="Text 4"/>
+          <p:cNvSpPr/>
+          <p:nvPr/>
+        </p:nvSpPr>
+        <p:spPr>
+          <a:xfrm>
+            <a:off x="8092440" y="3630168"/>
+            <a:ext cx="1920240" cy="585216"/>
+          </a:xfrm>
+          <a:prstGeom prst="rect">
+            <a:avLst/>
+          </a:prstGeom>
+          <a:noFill/>
+          <a:ln/>
+        </p:spPr>
+        <p:txBody>
+          <a:bodyPr wrap="square" lIns="0" tIns="0" rIns="0" bIns="0" rtlCol="0" anchor="ctr"/>
+          <a:lstStyle/>
+          <a:p>
+            <a:pPr indent="0" marL="0">
+              <a:buNone/>
+            </a:pPr>
+            <a:r>
+              <a:rPr lang="en-US" sz="1100" b="1" dirty="0">
+                <a:solidFill>
+                  <a:srgbClr val="C0392B"/>
+                </a:solidFill>
+                <a:latin typeface="Calibri" pitchFamily="34" charset="0"/>
+                <a:ea typeface="Calibri" pitchFamily="34" charset="-122"/>
+                <a:cs typeface="Calibri" pitchFamily="34" charset="-120"/>
+              </a:rPr>
+              <a:t>Test rot</a:t>
+            </a:r>
+            <a:endParaRPr lang="en-US" sz="1100" dirty="0"/>
+          </a:p>
+        </p:txBody>
+      </p:sp>
+      <p:sp>
+        <p:nvSpPr>
+          <p:cNvPr id="26" name="Shape 5"/>
+          <p:cNvSpPr/>
+          <p:nvPr/>
+        </p:nvSpPr>
+        <p:spPr>
+          <a:xfrm>
+            <a:off x="10104120" y="3767328"/>
             <a:ext cx="1371600" cy="310896"/>
           </a:xfrm>
           <a:prstGeom prst="roundRect">
@@ -3721,20 +3877,20 @@
             </a:avLst>
           </a:prstGeom>
           <a:solidFill>
-            <a:srgbClr val="5D6D7E"/>
+            <a:srgbClr val="F1C40F"/>
           </a:solidFill>
           <a:ln/>
         </p:spPr>
       </p:sp>
       <p:sp>
         <p:nvSpPr>
-          <p:cNvPr id="23" name="Text 21"/>
-          <p:cNvSpPr/>
-          <p:nvPr/>
-        </p:nvSpPr>
-        <p:spPr>
-          <a:xfrm>
-            <a:off x="10104120" y="4050792"/>
+          <p:cNvPr id="27" name="Text 6"/>
+          <p:cNvSpPr/>
+          <p:nvPr/>
+        </p:nvSpPr>
+        <p:spPr>
+          <a:xfrm>
+            <a:off x="10104120" y="3767328"/>
             <a:ext cx="1371600" cy="310896"/>
           </a:xfrm>
           <a:prstGeom prst="rect">
@@ -3759,7 +3915,7 @@
                 <a:ea typeface="Calibri" pitchFamily="34" charset="-122"/>
                 <a:cs typeface="Calibri" pitchFamily="34" charset="-120"/>
               </a:rPr>
-              <a:t>Niedrig</a:t>
+              <a:t>Mittel</a:t>
             </a:r>
             <a:endParaRPr lang="en-US" sz="1100" dirty="0"/>
           </a:p>
@@ -3767,14 +3923,14 @@
       </p:sp>
       <p:sp>
         <p:nvSpPr>
-          <p:cNvPr id="24" name="Shape 22"/>
-          <p:cNvSpPr/>
-          <p:nvPr/>
-        </p:nvSpPr>
-        <p:spPr>
-          <a:xfrm>
-            <a:off x="548640" y="4636008"/>
-            <a:ext cx="11064240" cy="658368"/>
+          <p:cNvPr id="28" name="Shape 2"/>
+          <p:cNvSpPr/>
+          <p:nvPr/>
+        </p:nvSpPr>
+        <p:spPr>
+          <a:xfrm>
+            <a:off x="548640" y="4306824"/>
+            <a:ext cx="11064240" cy="585216"/>
           </a:xfrm>
           <a:prstGeom prst="roundRect">
             <a:avLst>
@@ -3794,14 +3950,14 @@
       </p:sp>
       <p:sp>
         <p:nvSpPr>
-          <p:cNvPr id="25" name="Text 23"/>
-          <p:cNvSpPr/>
-          <p:nvPr/>
-        </p:nvSpPr>
-        <p:spPr>
-          <a:xfrm>
-            <a:off x="713232" y="4636008"/>
-            <a:ext cx="548640" cy="658368"/>
+          <p:cNvPr id="29" name="Text 3"/>
+          <p:cNvSpPr/>
+          <p:nvPr/>
+        </p:nvSpPr>
+        <p:spPr>
+          <a:xfrm>
+            <a:off x="713232" y="4306824"/>
+            <a:ext cx="548640" cy="585216"/>
           </a:xfrm>
           <a:prstGeom prst="rect">
             <a:avLst/>
@@ -3833,14 +3989,14 @@
       </p:sp>
       <p:sp>
         <p:nvSpPr>
-          <p:cNvPr id="26" name="Text 24"/>
-          <p:cNvSpPr/>
-          <p:nvPr/>
-        </p:nvSpPr>
-        <p:spPr>
-          <a:xfrm>
-            <a:off x="1417320" y="4636008"/>
-            <a:ext cx="8229600" cy="658368"/>
+          <p:cNvPr id="30" name="Text 4"/>
+          <p:cNvSpPr/>
+          <p:nvPr/>
+        </p:nvSpPr>
+        <p:spPr>
+          <a:xfrm>
+            <a:off x="1417320" y="4306824"/>
+            <a:ext cx="6583680" cy="585216"/>
           </a:xfrm>
           <a:prstGeom prst="rect">
             <a:avLst/>
@@ -3864,7 +4020,7 @@
                 <a:ea typeface="Calibri" pitchFamily="34" charset="-122"/>
                 <a:cs typeface="Calibri" pitchFamily="34" charset="-120"/>
               </a:rPr>
-              <a:t>/roads: Filter/Sort/Pagination wirkungslos</a:t>
+              <a:t>Schwache Fehlersemantik (500 statt 409, HTML statt JSON)</a:t>
             </a:r>
             <a:endParaRPr lang="en-US" sz="1550" dirty="0"/>
           </a:p>
@@ -3872,13 +4028,52 @@
       </p:sp>
       <p:sp>
         <p:nvSpPr>
-          <p:cNvPr id="27" name="Shape 25"/>
-          <p:cNvSpPr/>
-          <p:nvPr/>
-        </p:nvSpPr>
-        <p:spPr>
-          <a:xfrm>
-            <a:off x="10104120" y="4809744"/>
+          <p:cNvPr id="31" name="Text 4"/>
+          <p:cNvSpPr/>
+          <p:nvPr/>
+        </p:nvSpPr>
+        <p:spPr>
+          <a:xfrm>
+            <a:off x="8092440" y="4306824"/>
+            <a:ext cx="1920240" cy="585216"/>
+          </a:xfrm>
+          <a:prstGeom prst="rect">
+            <a:avLst/>
+          </a:prstGeom>
+          <a:noFill/>
+          <a:ln/>
+        </p:spPr>
+        <p:txBody>
+          <a:bodyPr wrap="square" lIns="0" tIns="0" rIns="0" bIns="0" rtlCol="0" anchor="ctr"/>
+          <a:lstStyle/>
+          <a:p>
+            <a:pPr indent="0" marL="0">
+              <a:buNone/>
+            </a:pPr>
+            <a:r>
+              <a:rPr lang="en-US" sz="1100" b="1" dirty="0">
+                <a:solidFill>
+                  <a:srgbClr val="C0392B"/>
+                </a:solidFill>
+                <a:latin typeface="Calibri" pitchFamily="34" charset="0"/>
+                <a:ea typeface="Calibri" pitchFamily="34" charset="-122"/>
+                <a:cs typeface="Calibri" pitchFamily="34" charset="-120"/>
+              </a:rPr>
+              <a:t>Test rot (2×)</a:t>
+            </a:r>
+            <a:endParaRPr lang="en-US" sz="1100" dirty="0"/>
+          </a:p>
+        </p:txBody>
+      </p:sp>
+      <p:sp>
+        <p:nvSpPr>
+          <p:cNvPr id="32" name="Shape 5"/>
+          <p:cNvSpPr/>
+          <p:nvPr/>
+        </p:nvSpPr>
+        <p:spPr>
+          <a:xfrm>
+            <a:off x="10104120" y="4443984"/>
             <a:ext cx="1371600" cy="310896"/>
           </a:xfrm>
           <a:prstGeom prst="roundRect">
@@ -3894,13 +4089,13 @@
       </p:sp>
       <p:sp>
         <p:nvSpPr>
-          <p:cNvPr id="28" name="Text 26"/>
-          <p:cNvSpPr/>
-          <p:nvPr/>
-        </p:nvSpPr>
-        <p:spPr>
-          <a:xfrm>
-            <a:off x="10104120" y="4809744"/>
+          <p:cNvPr id="33" name="Text 6"/>
+          <p:cNvSpPr/>
+          <p:nvPr/>
+        </p:nvSpPr>
+        <p:spPr>
+          <a:xfrm>
+            <a:off x="10104120" y="4443984"/>
             <a:ext cx="1371600" cy="310896"/>
           </a:xfrm>
           <a:prstGeom prst="rect">
@@ -3925,7 +4120,7 @@
                 <a:ea typeface="Calibri" pitchFamily="34" charset="-122"/>
                 <a:cs typeface="Calibri" pitchFamily="34" charset="-120"/>
               </a:rPr>
-              <a:t>Info</a:t>
+              <a:t>Niedrig</a:t>
             </a:r>
             <a:endParaRPr lang="en-US" sz="1100" dirty="0"/>
           </a:p>
@@ -3933,14 +4128,14 @@
       </p:sp>
       <p:sp>
         <p:nvSpPr>
-          <p:cNvPr id="29" name="Shape 27"/>
-          <p:cNvSpPr/>
-          <p:nvPr/>
-        </p:nvSpPr>
-        <p:spPr>
-          <a:xfrm>
-            <a:off x="548640" y="5394960"/>
-            <a:ext cx="11064240" cy="658368"/>
+          <p:cNvPr id="34" name="Shape 2"/>
+          <p:cNvSpPr/>
+          <p:nvPr/>
+        </p:nvSpPr>
+        <p:spPr>
+          <a:xfrm>
+            <a:off x="548640" y="4983480"/>
+            <a:ext cx="11064240" cy="585216"/>
           </a:xfrm>
           <a:prstGeom prst="roundRect">
             <a:avLst>
@@ -3960,14 +4155,14 @@
       </p:sp>
       <p:sp>
         <p:nvSpPr>
-          <p:cNvPr id="30" name="Text 28"/>
-          <p:cNvSpPr/>
-          <p:nvPr/>
-        </p:nvSpPr>
-        <p:spPr>
-          <a:xfrm>
-            <a:off x="713232" y="5394960"/>
-            <a:ext cx="548640" cy="658368"/>
+          <p:cNvPr id="35" name="Text 3"/>
+          <p:cNvSpPr/>
+          <p:nvPr/>
+        </p:nvSpPr>
+        <p:spPr>
+          <a:xfrm>
+            <a:off x="713232" y="4983480"/>
+            <a:ext cx="548640" cy="585216"/>
           </a:xfrm>
           <a:prstGeom prst="rect">
             <a:avLst/>
@@ -3999,14 +4194,14 @@
       </p:sp>
       <p:sp>
         <p:nvSpPr>
-          <p:cNvPr id="31" name="Text 29"/>
-          <p:cNvSpPr/>
-          <p:nvPr/>
-        </p:nvSpPr>
-        <p:spPr>
-          <a:xfrm>
-            <a:off x="1417320" y="5394960"/>
-            <a:ext cx="8229600" cy="658368"/>
+          <p:cNvPr id="36" name="Text 4"/>
+          <p:cNvSpPr/>
+          <p:nvPr/>
+        </p:nvSpPr>
+        <p:spPr>
+          <a:xfrm>
+            <a:off x="1417320" y="4983480"/>
+            <a:ext cx="6583680" cy="585216"/>
           </a:xfrm>
           <a:prstGeom prst="rect">
             <a:avLst/>
@@ -4030,7 +4225,7 @@
                 <a:ea typeface="Calibri" pitchFamily="34" charset="-122"/>
                 <a:cs typeface="Calibri" pitchFamily="34" charset="-120"/>
               </a:rPr>
-              <a:t>Schwache Fehlersemantik (500 statt 409, HTML-400)</a:t>
+              <a:t>PUT / PATCH / DELETE verfügbar, aber undokumentiert</a:t>
             </a:r>
             <a:endParaRPr lang="en-US" sz="1550" dirty="0"/>
           </a:p>
@@ -4038,13 +4233,52 @@
       </p:sp>
       <p:sp>
         <p:nvSpPr>
-          <p:cNvPr id="32" name="Shape 30"/>
-          <p:cNvSpPr/>
-          <p:nvPr/>
-        </p:nvSpPr>
-        <p:spPr>
-          <a:xfrm>
-            <a:off x="10104120" y="5568696"/>
+          <p:cNvPr id="37" name="Text 4"/>
+          <p:cNvSpPr/>
+          <p:nvPr/>
+        </p:nvSpPr>
+        <p:spPr>
+          <a:xfrm>
+            <a:off x="8092440" y="4983480"/>
+            <a:ext cx="1920240" cy="585216"/>
+          </a:xfrm>
+          <a:prstGeom prst="rect">
+            <a:avLst/>
+          </a:prstGeom>
+          <a:noFill/>
+          <a:ln/>
+        </p:spPr>
+        <p:txBody>
+          <a:bodyPr wrap="square" lIns="0" tIns="0" rIns="0" bIns="0" rtlCol="0" anchor="ctr"/>
+          <a:lstStyle/>
+          <a:p>
+            <a:pPr indent="0" marL="0">
+              <a:buNone/>
+            </a:pPr>
+            <a:r>
+              <a:rPr lang="en-US" sz="1100" i="1" dirty="0">
+                <a:solidFill>
+                  <a:srgbClr val="5A6483"/>
+                </a:solidFill>
+                <a:latin typeface="Calibri" pitchFamily="34" charset="0"/>
+                <a:ea typeface="Calibri" pitchFamily="34" charset="-122"/>
+                <a:cs typeface="Calibri" pitchFamily="34" charset="-120"/>
+              </a:rPr>
+              <a:t>Doku-Lücke · grün</a:t>
+            </a:r>
+            <a:endParaRPr lang="en-US" sz="1100" dirty="0"/>
+          </a:p>
+        </p:txBody>
+      </p:sp>
+      <p:sp>
+        <p:nvSpPr>
+          <p:cNvPr id="38" name="Shape 5"/>
+          <p:cNvSpPr/>
+          <p:nvPr/>
+        </p:nvSpPr>
+        <p:spPr>
+          <a:xfrm>
+            <a:off x="10104120" y="5120640"/>
             <a:ext cx="1371600" cy="310896"/>
           </a:xfrm>
           <a:prstGeom prst="roundRect">
@@ -4060,13 +4294,218 @@
       </p:sp>
       <p:sp>
         <p:nvSpPr>
-          <p:cNvPr id="33" name="Text 31"/>
-          <p:cNvSpPr/>
-          <p:nvPr/>
-        </p:nvSpPr>
-        <p:spPr>
-          <a:xfrm>
-            <a:off x="10104120" y="5568696"/>
+          <p:cNvPr id="39" name="Text 6"/>
+          <p:cNvSpPr/>
+          <p:nvPr/>
+        </p:nvSpPr>
+        <p:spPr>
+          <a:xfrm>
+            <a:off x="10104120" y="5120640"/>
+            <a:ext cx="1371600" cy="310896"/>
+          </a:xfrm>
+          <a:prstGeom prst="rect">
+            <a:avLst/>
+          </a:prstGeom>
+          <a:noFill/>
+          <a:ln/>
+        </p:spPr>
+        <p:txBody>
+          <a:bodyPr wrap="square" lIns="0" tIns="0" rIns="0" bIns="0" rtlCol="0" anchor="ctr"/>
+          <a:lstStyle/>
+          <a:p>
+            <a:pPr algn="ctr" indent="0" marL="0">
+              <a:buNone/>
+            </a:pPr>
+            <a:r>
+              <a:rPr lang="en-US" sz="1100" b="1" dirty="0">
+                <a:solidFill>
+                  <a:srgbClr val="FFFFFF"/>
+                </a:solidFill>
+                <a:latin typeface="Calibri" pitchFamily="34" charset="0"/>
+                <a:ea typeface="Calibri" pitchFamily="34" charset="-122"/>
+                <a:cs typeface="Calibri" pitchFamily="34" charset="-120"/>
+              </a:rPr>
+              <a:t>Niedrig</a:t>
+            </a:r>
+            <a:endParaRPr lang="en-US" sz="1100" dirty="0"/>
+          </a:p>
+        </p:txBody>
+      </p:sp>
+      <p:sp>
+        <p:nvSpPr>
+          <p:cNvPr id="40" name="Shape 2"/>
+          <p:cNvSpPr/>
+          <p:nvPr/>
+        </p:nvSpPr>
+        <p:spPr>
+          <a:xfrm>
+            <a:off x="548640" y="5660136"/>
+            <a:ext cx="11064240" cy="585216"/>
+          </a:xfrm>
+          <a:prstGeom prst="roundRect">
+            <a:avLst>
+              <a:gd name="adj" fmla="val 8333"/>
+            </a:avLst>
+          </a:prstGeom>
+          <a:solidFill>
+            <a:srgbClr val="F4F6FC"/>
+          </a:solidFill>
+          <a:ln w="12700">
+            <a:solidFill>
+              <a:srgbClr val="E3E8F5"/>
+            </a:solidFill>
+            <a:prstDash val="solid"/>
+          </a:ln>
+        </p:spPr>
+      </p:sp>
+      <p:sp>
+        <p:nvSpPr>
+          <p:cNvPr id="41" name="Text 3"/>
+          <p:cNvSpPr/>
+          <p:nvPr/>
+        </p:nvSpPr>
+        <p:spPr>
+          <a:xfrm>
+            <a:off x="713232" y="5660136"/>
+            <a:ext cx="548640" cy="585216"/>
+          </a:xfrm>
+          <a:prstGeom prst="rect">
+            <a:avLst/>
+          </a:prstGeom>
+          <a:noFill/>
+          <a:ln/>
+        </p:spPr>
+        <p:txBody>
+          <a:bodyPr wrap="square" lIns="0" tIns="0" rIns="0" bIns="0" rtlCol="0" anchor="ctr"/>
+          <a:lstStyle/>
+          <a:p>
+            <a:pPr algn="ctr" indent="0" marL="0">
+              <a:buNone/>
+            </a:pPr>
+            <a:r>
+              <a:rPr lang="en-US" sz="2200" b="1" dirty="0">
+                <a:solidFill>
+                  <a:srgbClr val="5D6D7E"/>
+                </a:solidFill>
+                <a:latin typeface="Cambria" pitchFamily="34" charset="0"/>
+                <a:ea typeface="Cambria" pitchFamily="34" charset="-122"/>
+                <a:cs typeface="Cambria" pitchFamily="34" charset="-120"/>
+              </a:rPr>
+              <a:t>7</a:t>
+            </a:r>
+            <a:endParaRPr lang="en-US" sz="2200" dirty="0"/>
+          </a:p>
+        </p:txBody>
+      </p:sp>
+      <p:sp>
+        <p:nvSpPr>
+          <p:cNvPr id="42" name="Text 4"/>
+          <p:cNvSpPr/>
+          <p:nvPr/>
+        </p:nvSpPr>
+        <p:spPr>
+          <a:xfrm>
+            <a:off x="1417320" y="5660136"/>
+            <a:ext cx="6583680" cy="585216"/>
+          </a:xfrm>
+          <a:prstGeom prst="rect">
+            <a:avLst/>
+          </a:prstGeom>
+          <a:noFill/>
+          <a:ln/>
+        </p:spPr>
+        <p:txBody>
+          <a:bodyPr wrap="square" lIns="0" tIns="0" rIns="0" bIns="0" rtlCol="0" anchor="ctr"/>
+          <a:lstStyle/>
+          <a:p>
+            <a:pPr indent="0" marL="0">
+              <a:buNone/>
+            </a:pPr>
+            <a:r>
+              <a:rPr lang="en-US" sz="1550" dirty="0">
+                <a:solidFill>
+                  <a:srgbClr val="1B2340"/>
+                </a:solidFill>
+                <a:latin typeface="Calibri" pitchFamily="34" charset="0"/>
+                <a:ea typeface="Calibri" pitchFamily="34" charset="-122"/>
+                <a:cs typeface="Calibri" pitchFamily="34" charset="-120"/>
+              </a:rPr>
+              <a:t>/roads: Filter/Sort/Pagination wirkungslos</a:t>
+            </a:r>
+            <a:endParaRPr lang="en-US" sz="1550" dirty="0"/>
+          </a:p>
+        </p:txBody>
+      </p:sp>
+      <p:sp>
+        <p:nvSpPr>
+          <p:cNvPr id="43" name="Text 4"/>
+          <p:cNvSpPr/>
+          <p:nvPr/>
+        </p:nvSpPr>
+        <p:spPr>
+          <a:xfrm>
+            <a:off x="8092440" y="5660136"/>
+            <a:ext cx="1920240" cy="585216"/>
+          </a:xfrm>
+          <a:prstGeom prst="rect">
+            <a:avLst/>
+          </a:prstGeom>
+          <a:noFill/>
+          <a:ln/>
+        </p:spPr>
+        <p:txBody>
+          <a:bodyPr wrap="square" lIns="0" tIns="0" rIns="0" bIns="0" rtlCol="0" anchor="ctr"/>
+          <a:lstStyle/>
+          <a:p>
+            <a:pPr indent="0" marL="0">
+              <a:buNone/>
+            </a:pPr>
+            <a:r>
+              <a:rPr lang="en-US" sz="1100" i="1" dirty="0">
+                <a:solidFill>
+                  <a:srgbClr val="5A6483"/>
+                </a:solidFill>
+                <a:latin typeface="Calibri" pitchFamily="34" charset="0"/>
+                <a:ea typeface="Calibri" pitchFamily="34" charset="-122"/>
+                <a:cs typeface="Calibri" pitchFamily="34" charset="-120"/>
+              </a:rPr>
+              <a:t>Limitierung · grün</a:t>
+            </a:r>
+            <a:endParaRPr lang="en-US" sz="1100" dirty="0"/>
+          </a:p>
+        </p:txBody>
+      </p:sp>
+      <p:sp>
+        <p:nvSpPr>
+          <p:cNvPr id="44" name="Shape 5"/>
+          <p:cNvSpPr/>
+          <p:nvPr/>
+        </p:nvSpPr>
+        <p:spPr>
+          <a:xfrm>
+            <a:off x="10104120" y="5797296"/>
+            <a:ext cx="1371600" cy="310896"/>
+          </a:xfrm>
+          <a:prstGeom prst="roundRect">
+            <a:avLst>
+              <a:gd name="adj" fmla="val 50000"/>
+            </a:avLst>
+          </a:prstGeom>
+          <a:solidFill>
+            <a:srgbClr val="5D6D7E"/>
+          </a:solidFill>
+          <a:ln/>
+        </p:spPr>
+      </p:sp>
+      <p:sp>
+        <p:nvSpPr>
+          <p:cNvPr id="45" name="Text 6"/>
+          <p:cNvSpPr/>
+          <p:nvPr/>
+        </p:nvSpPr>
+        <p:spPr>
+          <a:xfrm>
+            <a:off x="10104120" y="5797296"/>
             <a:ext cx="1371600" cy="310896"/>
           </a:xfrm>
           <a:prstGeom prst="rect">
@@ -4298,8 +4737,8 @@
         </p:nvSpPr>
         <p:spPr>
           <a:xfrm>
-            <a:off x="731520" y="2103120"/>
-            <a:ext cx="5029200" cy="320040"/>
+            <a:off x="731520" y="2084832"/>
+            <a:ext cx="5029200" cy="292608"/>
           </a:xfrm>
           <a:prstGeom prst="rect">
             <a:avLst/>
@@ -4337,24 +4776,24 @@
         </p:nvSpPr>
         <p:spPr>
           <a:xfrm>
-            <a:off x="731520" y="2450592"/>
-            <a:ext cx="5029200" cy="640080"/>
-          </a:xfrm>
-          <a:prstGeom prst="rect">
-            <a:avLst/>
-          </a:prstGeom>
-          <a:noFill/>
-          <a:ln/>
-        </p:spPr>
-        <p:txBody>
-          <a:bodyPr wrap="square" rtlCol="0" anchor="ctr"/>
-          <a:lstStyle/>
-          <a:p>
-            <a:pPr indent="0" marL="0">
-              <a:buNone/>
-            </a:pPr>
-            <a:r>
-              <a:rPr lang="en-US" sz="1500" dirty="0">
+            <a:off x="731520" y="2395728"/>
+            <a:ext cx="5029200" cy="713232"/>
+          </a:xfrm>
+          <a:prstGeom prst="rect">
+            <a:avLst/>
+          </a:prstGeom>
+          <a:noFill/>
+          <a:ln/>
+        </p:spPr>
+        <p:txBody>
+          <a:bodyPr wrap="square" rtlCol="0" anchor="t"/>
+          <a:lstStyle/>
+          <a:p>
+            <a:pPr indent="0" marL="0">
+              <a:buNone/>
+            </a:pPr>
+            <a:r>
+              <a:rPr lang="en-US" sz="1300" dirty="0">
                 <a:solidFill>
                   <a:srgbClr val="FFFFFF"/>
                 </a:solidFill>
@@ -4362,9 +4801,9 @@
                 <a:ea typeface="Calibri" pitchFamily="34" charset="-122"/>
                 <a:cs typeface="Calibri" pitchFamily="34" charset="-120"/>
               </a:rPr>
-              <a:t>404 / 405 – /roads ist read-only (Objekt-Ressource)</a:t>
-            </a:r>
-            <a:endParaRPr lang="en-US" sz="1500" dirty="0"/>
+              <a:t>405 abgelehnt (read-only) – oder, falls Schreiben gewollt, EINE Straße angehängt (201)</a:t>
+            </a:r>
+            <a:endParaRPr lang="en-US" sz="1300" dirty="0"/>
           </a:p>
         </p:txBody>
       </p:sp>
@@ -4398,8 +4837,8 @@
         </p:nvSpPr>
         <p:spPr>
           <a:xfrm>
-            <a:off x="6400800" y="2103120"/>
-            <a:ext cx="5029200" cy="320040"/>
+            <a:off x="6400800" y="2084832"/>
+            <a:ext cx="5029200" cy="292608"/>
           </a:xfrm>
           <a:prstGeom prst="rect">
             <a:avLst/>
@@ -4437,24 +4876,24 @@
         </p:nvSpPr>
         <p:spPr>
           <a:xfrm>
-            <a:off x="6400800" y="2450592"/>
-            <a:ext cx="5029200" cy="640080"/>
-          </a:xfrm>
-          <a:prstGeom prst="rect">
-            <a:avLst/>
-          </a:prstGeom>
-          <a:noFill/>
-          <a:ln/>
-        </p:spPr>
-        <p:txBody>
-          <a:bodyPr wrap="square" rtlCol="0" anchor="ctr"/>
-          <a:lstStyle/>
-          <a:p>
-            <a:pPr indent="0" marL="0">
-              <a:buNone/>
-            </a:pPr>
-            <a:r>
-              <a:rPr lang="en-US" sz="1500" dirty="0">
+            <a:off x="6400800" y="2395728"/>
+            <a:ext cx="5029200" cy="713232"/>
+          </a:xfrm>
+          <a:prstGeom prst="rect">
+            <a:avLst/>
+          </a:prstGeom>
+          <a:noFill/>
+          <a:ln/>
+        </p:spPr>
+        <p:txBody>
+          <a:bodyPr wrap="square" rtlCol="0" anchor="t"/>
+          <a:lstStyle/>
+          <a:p>
+            <a:pPr indent="0" marL="0">
+              <a:buNone/>
+            </a:pPr>
+            <a:r>
+              <a:rPr lang="en-US" sz="1300" dirty="0">
                 <a:solidFill>
                   <a:srgbClr val="FFFFFF"/>
                 </a:solidFill>
@@ -4462,9 +4901,9 @@
                 <a:ea typeface="Calibri" pitchFamily="34" charset="-122"/>
                 <a:cs typeface="Calibri" pitchFamily="34" charset="-120"/>
               </a:rPr>
-              <a:t>201 Created – FeatureCollection wird durch Body ersetzt</a:t>
-            </a:r>
-            <a:endParaRPr lang="en-US" sz="1500" dirty="0"/>
+              <a:t>201 – gesamte FeatureCollection überschrieben, alle 773 Straßen weg (kein Append, kein Merge)</a:t>
+            </a:r>
+            <a:endParaRPr lang="en-US" sz="1300" dirty="0"/>
           </a:p>
         </p:txBody>
       </p:sp>
@@ -4600,8 +5039,8 @@
         </p:nvSpPr>
         <p:spPr>
           <a:xfrm>
-            <a:off x="548640" y="5074920"/>
-            <a:ext cx="11064240" cy="731520"/>
+            <a:off x="548640" y="5029200"/>
+            <a:ext cx="11064240" cy="868680"/>
           </a:xfrm>
           <a:prstGeom prst="rect">
             <a:avLst/>
@@ -4617,7 +5056,7 @@
               <a:buNone/>
             </a:pPr>
             <a:r>
-              <a:rPr lang="en-US" sz="1450" i="1" dirty="0">
+              <a:rPr lang="en-US" sz="1400" i="1" dirty="0">
                 <a:solidFill>
                   <a:srgbClr val="CADCFC"/>
                 </a:solidFill>
@@ -4625,9 +5064,9 @@
                 <a:ea typeface="Calibri" pitchFamily="34" charset="-122"/>
                 <a:cs typeface="Calibri" pitchFamily="34" charset="-120"/>
               </a:rPr>
-              <a:t>Wirkung: kompletter Datenverlust bis API-Neustart. Nicht per API wiederherstellbar – daher bewusst NICHT im automatischen Lauf.</a:t>
-            </a:r>
-            <a:endParaRPr lang="en-US" sz="1450" dirty="0"/>
+              <a:t>Unter jeder Vertragsauslegung falsch: entweder ablehnen oder anhängen – niemals alles ersetzen. Kompletter Datenverlust bis API-Neustart, nicht per API wiederherstellbar – daher bewusst NICHT im automatischen Lauf.</a:t>
+            </a:r>
+            <a:endParaRPr lang="en-US" sz="1400" dirty="0"/>
           </a:p>
         </p:txBody>
       </p:sp>
@@ -4986,7 +5425,7 @@
                 <a:ea typeface="Calibri" pitchFamily="34" charset="-122"/>
                 <a:cs typeface="Calibri" pitchFamily="34" charset="-120"/>
               </a:rPr>
-              <a:t>Auch akzeptiert</a:t>
+              <a:t>Befund &amp; Test</a:t>
             </a:r>
             <a:endParaRPr lang="en-US" sz="1300" dirty="0"/>
           </a:p>
@@ -5029,7 +5468,7 @@
                 <a:ea typeface="Calibri" pitchFamily="34" charset="-122"/>
                 <a:cs typeface="Calibri" pitchFamily="34" charset="-120"/>
               </a:rPr>
-              <a:t>leerer Body {}</a:t>
+              <a:t>kein title, kein road_fid – trotzdem 201</a:t>
             </a:r>
             <a:endParaRPr lang="en-US" sz="1350" dirty="0"/>
           </a:p>
@@ -5050,7 +5489,7 @@
                 <a:ea typeface="Calibri" pitchFamily="34" charset="-122"/>
                 <a:cs typeface="Calibri" pitchFamily="34" charset="-120"/>
               </a:rPr>
-              <a:t>Todo ohne road_fid (Pflichtbezug!)</a:t>
+              <a:t>road_fid ist Pflichtbezug (Anforderung 7)</a:t>
             </a:r>
             <a:endParaRPr lang="en-US" sz="1350" dirty="0"/>
           </a:p>
@@ -5068,7 +5507,7 @@
                 <a:ea typeface="Calibri" pitchFamily="34" charset="-122"/>
                 <a:cs typeface="Calibri" pitchFamily="34" charset="-120"/>
               </a:rPr>
-              <a:t>beliebige Fremdfelder</a:t>
+              <a:t>[DEFECT #2]: Soll 400 → Test rot</a:t>
             </a:r>
             <a:endParaRPr lang="en-US" sz="1350" dirty="0"/>
           </a:p>
@@ -5299,7 +5738,7 @@
                 <a:ea typeface="Calibri" pitchFamily="34" charset="-122"/>
                 <a:cs typeface="Calibri" pitchFamily="34" charset="-120"/>
               </a:rPr>
-              <a:t>Content-Type-Handling und undokumentierte Endpunkte</a:t>
+              <a:t>CORS-Konfiguration und Content-Type-Handling</a:t>
             </a:r>
             <a:endParaRPr lang="en-US" sz="1400" dirty="0"/>
           </a:p>
@@ -5426,7 +5865,7 @@
                 <a:ea typeface="Cambria" pitchFamily="34" charset="-122"/>
                 <a:cs typeface="Cambria" pitchFamily="34" charset="-120"/>
               </a:rPr>
-              <a:t>Content-Type verwirft Body still</a:t>
+              <a:t>CORS erlaubt jede Origin</a:t>
             </a:r>
             <a:endParaRPr lang="en-US" sz="1800" dirty="0"/>
           </a:p>
@@ -5490,7 +5929,7 @@
                 <a:ea typeface="Courier New" pitchFamily="34" charset="-122"/>
                 <a:cs typeface="Courier New" pitchFamily="34" charset="-120"/>
               </a:rPr>
-              <a:t>Content-Type: text/plain</a:t>
+              <a:t>OPTIONS /todos (Request-Method: POST)</a:t>
             </a:r>
             <a:endParaRPr lang="en-US" sz="1150" dirty="0"/>
           </a:p>
@@ -5510,7 +5949,7 @@
                 <a:ea typeface="Courier New" pitchFamily="34" charset="-122"/>
                 <a:cs typeface="Courier New" pitchFamily="34" charset="-120"/>
               </a:rPr>
-              <a:t>{ "title":"x", "road_fid":42 }</a:t>
+              <a:t>Origin: http://evil.example</a:t>
             </a:r>
             <a:endParaRPr lang="en-US" sz="1150" dirty="0"/>
           </a:p>
@@ -5530,7 +5969,7 @@
                 <a:ea typeface="Courier New" pitchFamily="34" charset="-122"/>
                 <a:cs typeface="Courier New" pitchFamily="34" charset="-120"/>
               </a:rPr>
-              <a:t>→ 201 Created</a:t>
+              <a:t>→ 204 · Allow-Origin: http://evil.example</a:t>
             </a:r>
             <a:endParaRPr lang="en-US" sz="1150" dirty="0"/>
           </a:p>
@@ -5550,7 +5989,7 @@
                 <a:ea typeface="Courier New" pitchFamily="34" charset="-122"/>
                 <a:cs typeface="Courier New" pitchFamily="34" charset="-120"/>
               </a:rPr>
-              <a:t>→ { "id": 15 }  // Body weg</a:t>
+              <a:t>→ Allow-Credentials: true</a:t>
             </a:r>
             <a:endParaRPr lang="en-US" sz="1150" dirty="0"/>
           </a:p>
@@ -5593,7 +6032,7 @@
                 <a:ea typeface="Calibri" pitchFamily="34" charset="-122"/>
                 <a:cs typeface="Calibri" pitchFamily="34" charset="-120"/>
               </a:rPr>
-              <a:t>Payload wird stillschweigend ignoriert, leerer Datensatz entsteht.</a:t>
+              <a:t>Jede Webseite kann per Browser lesen und schreiben – auch POST /roads (#1).</a:t>
             </a:r>
             <a:endParaRPr lang="en-US" sz="1350" dirty="0"/>
           </a:p>
@@ -5611,7 +6050,7 @@
                 <a:ea typeface="Calibri" pitchFamily="34" charset="-122"/>
                 <a:cs typeface="Calibri" pitchFamily="34" charset="-120"/>
               </a:rPr>
-              <a:t>Erwartet: 415 Unsupported Media Type oder 400.</a:t>
+              <a:t>Erwartet: nur App-Origin :5173. [DEFECT #3] → Test rot.</a:t>
             </a:r>
             <a:endParaRPr lang="en-US" sz="1350" dirty="0"/>
           </a:p>
@@ -5661,7 +6100,7 @@
             </a:avLst>
           </a:prstGeom>
           <a:solidFill>
-            <a:srgbClr val="5D6D7E"/>
+            <a:srgbClr val="F1C40F"/>
           </a:solidFill>
           <a:ln/>
         </p:spPr>
@@ -5699,7 +6138,7 @@
                 <a:ea typeface="Calibri" pitchFamily="34" charset="-122"/>
                 <a:cs typeface="Calibri" pitchFamily="34" charset="-120"/>
               </a:rPr>
-              <a:t>NIEDRIG</a:t>
+              <a:t>MITTEL</a:t>
             </a:r>
             <a:endParaRPr lang="en-US" sz="1100" dirty="0"/>
           </a:p>
@@ -5738,7 +6177,7 @@
                 <a:ea typeface="Cambria" pitchFamily="34" charset="-122"/>
                 <a:cs typeface="Cambria" pitchFamily="34" charset="-120"/>
               </a:rPr>
-              <a:t>Undokumentierte Schreib-Methoden</a:t>
+              <a:t>Content-Type verwirft Body still</a:t>
             </a:r>
             <a:endParaRPr lang="en-US" sz="1800" dirty="0"/>
           </a:p>
@@ -5777,7 +6216,7 @@
                 <a:ea typeface="Courier New" pitchFamily="34" charset="-122"/>
                 <a:cs typeface="Courier New" pitchFamily="34" charset="-120"/>
               </a:rPr>
-              <a:t>PUT /todos/:id</a:t>
+              <a:t>POST · Content-Type: text/plain</a:t>
             </a:r>
             <a:endParaRPr lang="en-US" sz="1400" dirty="0"/>
           </a:p>
@@ -5797,7 +6236,7 @@
                 <a:ea typeface="Courier New" pitchFamily="34" charset="-122"/>
                 <a:cs typeface="Courier New" pitchFamily="34" charset="-120"/>
               </a:rPr>
-              <a:t>200 – ersetzt Datensatz vollständig</a:t>
+              <a:t>{ "title":"x", "road_fid":42 }</a:t>
             </a:r>
             <a:endParaRPr lang="en-US" sz="1400" dirty="0"/>
           </a:p>
@@ -5814,7 +6253,7 @@
                 <a:ea typeface="Courier New" pitchFamily="34" charset="-122"/>
                 <a:cs typeface="Courier New" pitchFamily="34" charset="-120"/>
               </a:rPr>
-              <a:t>PATCH /todos/:id</a:t>
+              <a:t>Antwort</a:t>
             </a:r>
             <a:endParaRPr lang="en-US" sz="1400" dirty="0"/>
           </a:p>
@@ -5834,7 +6273,7 @@
                 <a:ea typeface="Courier New" pitchFamily="34" charset="-122"/>
                 <a:cs typeface="Courier New" pitchFamily="34" charset="-120"/>
               </a:rPr>
-              <a:t>200 – partielles Update (merge)</a:t>
+              <a:t>201 · { "id": 15 } – Body weg</a:t>
             </a:r>
             <a:endParaRPr lang="en-US" sz="1400" dirty="0"/>
           </a:p>
@@ -5851,7 +6290,7 @@
                 <a:ea typeface="Courier New" pitchFamily="34" charset="-122"/>
                 <a:cs typeface="Courier New" pitchFamily="34" charset="-120"/>
               </a:rPr>
-              <a:t>DELETE /todos/:id</a:t>
+              <a:t>Erwartet</a:t>
             </a:r>
             <a:endParaRPr lang="en-US" sz="1400" dirty="0"/>
           </a:p>
@@ -5871,7 +6310,7 @@
                 <a:ea typeface="Courier New" pitchFamily="34" charset="-122"/>
                 <a:cs typeface="Courier New" pitchFamily="34" charset="-120"/>
               </a:rPr>
-              <a:t>200 – löscht Datensatz</a:t>
+              <a:t>415 Unsupported Media Type / 400</a:t>
             </a:r>
             <a:endParaRPr lang="en-US" sz="1400" dirty="0"/>
           </a:p>
@@ -5910,7 +6349,7 @@
                 <a:ea typeface="Calibri" pitchFamily="34" charset="-122"/>
                 <a:cs typeface="Calibri" pitchFamily="34" charset="-120"/>
               </a:rPr>
-              <a:t>Doku nennt nur GET / POST – die Todos-Seite des Frontends hängt aber an diesen undokumentierten Endpunkten.</a:t>
+              <a:t>Payload still ignoriert, leerer Datensatz entsteht. [DEFECT #4] → Test rot.</a:t>
             </a:r>
             <a:endParaRPr lang="en-US" sz="1300" dirty="0"/>
           </a:p>
@@ -6020,7 +6459,7 @@
                 <a:ea typeface="Calibri" pitchFamily="34" charset="-122"/>
                 <a:cs typeface="Calibri" pitchFamily="34" charset="-120"/>
               </a:rPr>
-              <a:t>Ressourcen-Limitierung und Fehlersemantik (Info)</a:t>
+              <a:t>Fehlersemantik und undokumentierte Methoden</a:t>
             </a:r>
             <a:endParaRPr lang="en-US" sz="1400" dirty="0"/>
           </a:p>
@@ -6062,7 +6501,7 @@
         <p:spPr>
           <a:xfrm>
             <a:off x="777240" y="1828800"/>
-            <a:ext cx="1097280" cy="310896"/>
+            <a:ext cx="1371600" cy="310896"/>
           </a:xfrm>
           <a:prstGeom prst="roundRect">
             <a:avLst>
@@ -6084,7 +6523,7 @@
         <p:spPr>
           <a:xfrm>
             <a:off x="777240" y="1828800"/>
-            <a:ext cx="1097280" cy="310896"/>
+            <a:ext cx="1371600" cy="310896"/>
           </a:xfrm>
           <a:prstGeom prst="rect">
             <a:avLst/>
@@ -6108,7 +6547,7 @@
                 <a:ea typeface="Calibri" pitchFamily="34" charset="-122"/>
                 <a:cs typeface="Calibri" pitchFamily="34" charset="-120"/>
               </a:rPr>
-              <a:t>INFO</a:t>
+              <a:t>NIEDRIG</a:t>
             </a:r>
             <a:endParaRPr lang="en-US" sz="1100" dirty="0"/>
           </a:p>
@@ -6147,7 +6586,7 @@
                 <a:ea typeface="Cambria" pitchFamily="34" charset="-122"/>
                 <a:cs typeface="Cambria" pitchFamily="34" charset="-120"/>
               </a:rPr>
-              <a:t>/roads nicht filter-/sortierbar</a:t>
+              <a:t>Schwache Fehlersemantik</a:t>
             </a:r>
             <a:endParaRPr lang="en-US" sz="1800" dirty="0"/>
           </a:p>
@@ -6190,7 +6629,7 @@
                 <a:ea typeface="Calibri" pitchFamily="34" charset="-122"/>
                 <a:cs typeface="Calibri" pitchFamily="34" charset="-120"/>
               </a:rPr>
-              <a:t>/roads ist ein Objekt (FeatureCollection), keine Array-Ressource.</a:t>
+              <a:t>Doppelte id → 500 „duplicate id" statt 409 Conflict.</a:t>
             </a:r>
             <a:endParaRPr lang="en-US" sz="1400" dirty="0"/>
           </a:p>
@@ -6211,7 +6650,7 @@
                 <a:ea typeface="Calibri" pitchFamily="34" charset="-122"/>
                 <a:cs typeface="Calibri" pitchFamily="34" charset="-120"/>
               </a:rPr>
-              <a:t>?_page / _limit / _sort / Filter → wirkungslos, immer volle 2,3 MB.</a:t>
+              <a:t>Kaputtes JSON → 400 als HTML-Fehlerseite – Client kann es kaum parsen.</a:t>
             </a:r>
             <a:endParaRPr lang="en-US" sz="1400" dirty="0"/>
           </a:p>
@@ -6232,7 +6671,7 @@
                 <a:ea typeface="Calibri" pitchFamily="34" charset="-122"/>
                 <a:cs typeface="Calibri" pitchFamily="34" charset="-120"/>
               </a:rPr>
-              <a:t>Kein X-Total-Count. GET /roads/:id → 404.</a:t>
+              <a:t>Beide Fehler kommen als text/html statt JSON.</a:t>
             </a:r>
             <a:endParaRPr lang="en-US" sz="1400" dirty="0"/>
           </a:p>
@@ -6250,7 +6689,7 @@
                 <a:ea typeface="Calibri" pitchFamily="34" charset="-122"/>
                 <a:cs typeface="Calibri" pitchFamily="34" charset="-120"/>
               </a:rPr>
-              <a:t>Folge: Frontend lädt jedes Mal alle Straßen komplett.</a:t>
+              <a:t>[DEFECT #5]: Soll 409 bzw. JSON-Fehler → 2 Tests rot.</a:t>
             </a:r>
             <a:endParaRPr lang="en-US" sz="1400" dirty="0"/>
           </a:p>
@@ -6292,7 +6731,7 @@
         <p:spPr>
           <a:xfrm>
             <a:off x="6537960" y="1828800"/>
-            <a:ext cx="1097280" cy="310896"/>
+            <a:ext cx="1371600" cy="310896"/>
           </a:xfrm>
           <a:prstGeom prst="roundRect">
             <a:avLst>
@@ -6314,7 +6753,7 @@
         <p:spPr>
           <a:xfrm>
             <a:off x="6537960" y="1828800"/>
-            <a:ext cx="1097280" cy="310896"/>
+            <a:ext cx="1371600" cy="310896"/>
           </a:xfrm>
           <a:prstGeom prst="rect">
             <a:avLst/>
@@ -6338,7 +6777,7 @@
                 <a:ea typeface="Calibri" pitchFamily="34" charset="-122"/>
                 <a:cs typeface="Calibri" pitchFamily="34" charset="-120"/>
               </a:rPr>
-              <a:t>INFO</a:t>
+              <a:t>NIEDRIG</a:t>
             </a:r>
             <a:endParaRPr lang="en-US" sz="1100" dirty="0"/>
           </a:p>
@@ -6377,7 +6816,7 @@
                 <a:ea typeface="Cambria" pitchFamily="34" charset="-122"/>
                 <a:cs typeface="Cambria" pitchFamily="34" charset="-120"/>
               </a:rPr>
-              <a:t>Schwache Fehlersemantik</a:t>
+              <a:t>Undokumentierte Schreib-Methoden</a:t>
             </a:r>
             <a:endParaRPr lang="en-US" sz="1800" dirty="0"/>
           </a:p>
@@ -6420,7 +6859,7 @@
                 <a:ea typeface="Calibri" pitchFamily="34" charset="-122"/>
                 <a:cs typeface="Calibri" pitchFamily="34" charset="-120"/>
               </a:rPr>
-              <a:t>Doppelte id → 500 „duplicate id" statt 409 Conflict.</a:t>
+              <a:t>PUT / PATCH / DELETE /todos/:id → 200, funktionieren korrekt.</a:t>
             </a:r>
             <a:endParaRPr lang="en-US" sz="1400" dirty="0"/>
           </a:p>
@@ -6441,7 +6880,7 @@
                 <a:ea typeface="Calibri" pitchFamily="34" charset="-122"/>
                 <a:cs typeface="Calibri" pitchFamily="34" charset="-120"/>
               </a:rPr>
-              <a:t>Kaputtes JSON → 400 als HTML-Fehlerseite (nicht JSON) – Client kann es kaum parsen.</a:t>
+              <a:t>Doku nennt nur GET / POST – das Frontend nutzt aber PUT und DELETE.</a:t>
             </a:r>
             <a:endParaRPr lang="en-US" sz="1400" dirty="0"/>
           </a:p>
@@ -6459,7 +6898,7 @@
                 <a:ea typeface="Calibri" pitchFamily="34" charset="-122"/>
                 <a:cs typeface="Calibri" pitchFamily="34" charset="-120"/>
               </a:rPr>
-              <a:t>Nicht existente / nicht numerische ID → 404 mit leerem {} (kein Fehlerobjekt).</a:t>
+              <a:t>Doku-Lücke, kein API-Fehler → Tests bleiben grün.</a:t>
             </a:r>
             <a:endParaRPr lang="en-US" sz="1400" dirty="0"/>
           </a:p>
@@ -6733,7 +7172,7 @@
                 <a:ea typeface="Calibri" pitchFamily="34" charset="-122"/>
                 <a:cs typeface="Calibri" pitchFamily="34" charset="-120"/>
               </a:rPr>
-              <a:t>?feld=, _gte, _ne, _like – exakt &amp; korrekt</a:t>
+              <a:t>?feld=, _gte, _like – exakt &amp; korrekt</a:t>
             </a:r>
             <a:endParaRPr lang="en-US" sz="1250" dirty="0"/>
           </a:p>
@@ -7553,7 +7992,7 @@
                 <a:ea typeface="Calibri" pitchFamily="34" charset="-122"/>
                 <a:cs typeface="Calibri" pitchFamily="34" charset="-120"/>
               </a:rPr>
-              <a:t>ACAO spiegelt Origin, OPTIONS-Preflight 204</a:t>
+              <a:t>App-Origin :5173: Preflight 204, POST erlaubt</a:t>
             </a:r>
             <a:endParaRPr lang="en-US" sz="1250" dirty="0"/>
           </a:p>
@@ -7744,7 +8183,7 @@
                 <a:ea typeface="Calibri" pitchFamily="34" charset="-122"/>
                 <a:cs typeface="Calibri" pitchFamily="34" charset="-120"/>
               </a:rPr>
-              <a:t>Schreibzugriff sperren</a:t>
+              <a:t>Zugriff absichern</a:t>
             </a:r>
             <a:endParaRPr lang="en-US" sz="1800" dirty="0"/>
           </a:p>
@@ -7783,7 +8222,7 @@
                 <a:ea typeface="Calibri" pitchFamily="34" charset="-122"/>
                 <a:cs typeface="Calibri" pitchFamily="34" charset="-120"/>
               </a:rPr>
-              <a:t>POST/PUT/PATCH/DELETE auf /roads unterbinden (Finding #1).</a:t>
+              <a:t>Schreiben auf /roads sperren, CORS auf App-Origin begrenzen (#1, #3).</a:t>
             </a:r>
             <a:endParaRPr lang="en-US" sz="1450" dirty="0"/>
           </a:p>
@@ -7903,7 +8342,7 @@
                 <a:ea typeface="Calibri" pitchFamily="34" charset="-122"/>
                 <a:cs typeface="Calibri" pitchFamily="34" charset="-120"/>
               </a:rPr>
-              <a:t>Pflichtfelder &amp; Schema serverseitig erzwingen (#2, #3).</a:t>
+              <a:t>Pflichtfelder &amp; Schema serverseitig erzwingen (#2, #4).</a:t>
             </a:r>
             <a:endParaRPr lang="en-US" sz="1450" dirty="0"/>
           </a:p>
@@ -8023,7 +8462,7 @@
                 <a:ea typeface="Calibri" pitchFamily="34" charset="-122"/>
                 <a:cs typeface="Calibri" pitchFamily="34" charset="-120"/>
               </a:rPr>
-              <a:t>Alle Methoden dokumentieren, saubere Statuscodes (#4, #6).</a:t>
+              <a:t>Alle Methoden dokumentieren, saubere Statuscodes (#5, #6).</a:t>
             </a:r>
             <a:endParaRPr lang="en-US" sz="1450" dirty="0"/>
           </a:p>
@@ -8143,7 +8582,7 @@
                 <a:ea typeface="Calibri" pitchFamily="34" charset="-122"/>
                 <a:cs typeface="Calibri" pitchFamily="34" charset="-120"/>
               </a:rPr>
-              <a:t>Serverseitige Filterung statt Voll-Download von /roads (#5).</a:t>
+              <a:t>Serverseitige Filterung statt Voll-Download von /roads (#7).</a:t>
             </a:r>
             <a:endParaRPr lang="en-US" sz="1450" dirty="0"/>
           </a:p>

</xml_diff>

<commit_message>
API tests: drop CORS checks, renumber findings, sync deck
The permissive CORS config was listed as finding #3, but the claim behind it
was wrong: a cross-site POST with Content-Type text/plain is a simple request,
needs no preflight and still wipes /roads. CORS only gates reading the
response, so it no longer earns its own finding or its own requests.

- remove both CORS requests (folder 7 is now "Errors & methods")
- renumber findings: Content-Type #4 -> #3, undocumented methods #6 -> #4,
  /roads limitation #7 -> #6; error semantics keeps #5
- 30 requests / 73 assertions, 4 of them [DEFECT #n] and red on purpose
- document the no-preflight repro under finding #1 (README + slide 4)
- regenerate the Newman htmlextra report and the findings deck

Co-Authored-By: Claude Opus 5 (1M context) <noreply@anthropic.com>
</commit_message>
<xml_diff>
--- a/api-tests/road-overview-api-findings.pptx
+++ b/api-tests/road-overview-api-findings.pptx
@@ -1759,7 +1759,7 @@
                 <a:ea typeface="Cambria" pitchFamily="34" charset="-122"/>
                 <a:cs typeface="Cambria" pitchFamily="34" charset="-120"/>
               </a:rPr>
-              <a:t>32</a:t>
+              <a:t>30</a:t>
             </a:r>
             <a:endParaRPr lang="en-US" sz="4400" dirty="0"/>
           </a:p>
@@ -1837,7 +1837,7 @@
                 <a:ea typeface="Cambria" pitchFamily="34" charset="-122"/>
                 <a:cs typeface="Cambria" pitchFamily="34" charset="-120"/>
               </a:rPr>
-              <a:t>77</a:t>
+              <a:t>73</a:t>
             </a:r>
             <a:endParaRPr lang="en-US" sz="4400" dirty="0"/>
           </a:p>
@@ -1915,7 +1915,7 @@
                 <a:ea typeface="Cambria" pitchFamily="34" charset="-122"/>
                 <a:cs typeface="Cambria" pitchFamily="34" charset="-120"/>
               </a:rPr>
-              <a:t>7</a:t>
+              <a:t>6</a:t>
             </a:r>
             <a:endParaRPr lang="en-US" sz="4400" dirty="0"/>
           </a:p>
@@ -1993,7 +1993,7 @@
                 <a:ea typeface="Cambria" pitchFamily="34" charset="-122"/>
                 <a:cs typeface="Cambria" pitchFamily="34" charset="-120"/>
               </a:rPr>
-              <a:t>5</a:t>
+              <a:t>4</a:t>
             </a:r>
             <a:endParaRPr lang="en-US" sz="4400" dirty="0"/>
           </a:p>
@@ -2729,7 +2729,7 @@
                 <a:ea typeface="Calibri" pitchFamily="34" charset="-122"/>
                 <a:cs typeface="Calibri" pitchFamily="34" charset="-120"/>
               </a:rPr>
-              <a:t>Newman: 32 Requests / 77 Assertions / 5 rot = bekannte Defekte. Self-cleaning bestätigt.</a:t>
+              <a:t>Newman: 30 Requests / 73 Assertions / 4 rot = bekannte Defekte. Self-cleaning bestätigt.</a:t>
             </a:r>
             <a:endParaRPr lang="en-US" sz="1350" dirty="0"/>
           </a:p>
@@ -2985,7 +2985,7 @@
                 <a:ea typeface="Calibri" pitchFamily="34" charset="-122"/>
                 <a:cs typeface="Calibri" pitchFamily="34" charset="-120"/>
               </a:rPr>
-              <a:t>Fehler-Routen · Methoden · CORS</a:t>
+              <a:t>Fehler-Routen &amp; Methoden</a:t>
             </a:r>
             <a:endParaRPr lang="en-US" sz="1350" dirty="0"/>
           </a:p>
@@ -3110,7 +3110,7 @@
         <p:spPr>
           <a:xfrm>
             <a:off x="548640" y="1600200"/>
-            <a:ext cx="11064240" cy="585216"/>
+            <a:ext cx="11064240" cy="658368"/>
           </a:xfrm>
           <a:prstGeom prst="roundRect">
             <a:avLst>
@@ -3137,7 +3137,7 @@
         <p:spPr>
           <a:xfrm>
             <a:off x="713232" y="1600200"/>
-            <a:ext cx="548640" cy="585216"/>
+            <a:ext cx="548640" cy="658368"/>
           </a:xfrm>
           <a:prstGeom prst="rect">
             <a:avLst/>
@@ -3176,7 +3176,7 @@
         <p:spPr>
           <a:xfrm>
             <a:off x="1417320" y="1600200"/>
-            <a:ext cx="6583680" cy="585216"/>
+            <a:ext cx="6583680" cy="658368"/>
           </a:xfrm>
           <a:prstGeom prst="rect">
             <a:avLst/>
@@ -3215,7 +3215,7 @@
         <p:spPr>
           <a:xfrm>
             <a:off x="8092440" y="1600200"/>
-            <a:ext cx="1920240" cy="585216"/>
+            <a:ext cx="1920240" cy="658368"/>
           </a:xfrm>
           <a:prstGeom prst="rect">
             <a:avLst/>
@@ -3253,7 +3253,7 @@
         </p:nvSpPr>
         <p:spPr>
           <a:xfrm>
-            <a:off x="10104120" y="1737360"/>
+            <a:off x="10104120" y="1773936"/>
             <a:ext cx="1371600" cy="310896"/>
           </a:xfrm>
           <a:prstGeom prst="roundRect">
@@ -3275,7 +3275,7 @@
         </p:nvSpPr>
         <p:spPr>
           <a:xfrm>
-            <a:off x="10104120" y="1737360"/>
+            <a:off x="10104120" y="1773936"/>
             <a:ext cx="1371600" cy="310896"/>
           </a:xfrm>
           <a:prstGeom prst="rect">
@@ -3314,8 +3314,8 @@
         </p:nvSpPr>
         <p:spPr>
           <a:xfrm>
-            <a:off x="548640" y="2276856"/>
-            <a:ext cx="11064240" cy="585216"/>
+            <a:off x="548640" y="2359152"/>
+            <a:ext cx="11064240" cy="658368"/>
           </a:xfrm>
           <a:prstGeom prst="roundRect">
             <a:avLst>
@@ -3341,8 +3341,8 @@
         </p:nvSpPr>
         <p:spPr>
           <a:xfrm>
-            <a:off x="713232" y="2276856"/>
-            <a:ext cx="548640" cy="585216"/>
+            <a:off x="713232" y="2359152"/>
+            <a:ext cx="548640" cy="658368"/>
           </a:xfrm>
           <a:prstGeom prst="rect">
             <a:avLst/>
@@ -3380,8 +3380,8 @@
         </p:nvSpPr>
         <p:spPr>
           <a:xfrm>
-            <a:off x="1417320" y="2276856"/>
-            <a:ext cx="6583680" cy="585216"/>
+            <a:off x="1417320" y="2359152"/>
+            <a:ext cx="6583680" cy="658368"/>
           </a:xfrm>
           <a:prstGeom prst="rect">
             <a:avLst/>
@@ -3419,8 +3419,8 @@
         </p:nvSpPr>
         <p:spPr>
           <a:xfrm>
-            <a:off x="8092440" y="2276856"/>
-            <a:ext cx="1920240" cy="585216"/>
+            <a:off x="8092440" y="2359152"/>
+            <a:ext cx="1920240" cy="658368"/>
           </a:xfrm>
           <a:prstGeom prst="rect">
             <a:avLst/>
@@ -3458,7 +3458,7 @@
         </p:nvSpPr>
         <p:spPr>
           <a:xfrm>
-            <a:off x="10104120" y="2414016"/>
+            <a:off x="10104120" y="2532888"/>
             <a:ext cx="1371600" cy="310896"/>
           </a:xfrm>
           <a:prstGeom prst="roundRect">
@@ -3480,7 +3480,7 @@
         </p:nvSpPr>
         <p:spPr>
           <a:xfrm>
-            <a:off x="10104120" y="2414016"/>
+            <a:off x="10104120" y="2532888"/>
             <a:ext cx="1371600" cy="310896"/>
           </a:xfrm>
           <a:prstGeom prst="rect">
@@ -3519,8 +3519,8 @@
         </p:nvSpPr>
         <p:spPr>
           <a:xfrm>
-            <a:off x="548640" y="2953512"/>
-            <a:ext cx="11064240" cy="585216"/>
+            <a:off x="548640" y="3118104"/>
+            <a:ext cx="11064240" cy="658368"/>
           </a:xfrm>
           <a:prstGeom prst="roundRect">
             <a:avLst>
@@ -3546,8 +3546,8 @@
         </p:nvSpPr>
         <p:spPr>
           <a:xfrm>
-            <a:off x="713232" y="2953512"/>
-            <a:ext cx="548640" cy="585216"/>
+            <a:off x="713232" y="3118104"/>
+            <a:ext cx="548640" cy="658368"/>
           </a:xfrm>
           <a:prstGeom prst="rect">
             <a:avLst/>
@@ -3585,8 +3585,8 @@
         </p:nvSpPr>
         <p:spPr>
           <a:xfrm>
-            <a:off x="1417320" y="2953512"/>
-            <a:ext cx="6583680" cy="585216"/>
+            <a:off x="1417320" y="3118104"/>
+            <a:ext cx="6583680" cy="658368"/>
           </a:xfrm>
           <a:prstGeom prst="rect">
             <a:avLst/>
@@ -3610,7 +3610,7 @@
                 <a:ea typeface="Calibri" pitchFamily="34" charset="-122"/>
                 <a:cs typeface="Calibri" pitchFamily="34" charset="-120"/>
               </a:rPr>
-              <a:t>CORS erlaubt jede Origin (inkl. Credentials)</a:t>
+              <a:t>Falscher Content-Type → Body still verworfen</a:t>
             </a:r>
             <a:endParaRPr lang="en-US" sz="1550" dirty="0"/>
           </a:p>
@@ -3624,8 +3624,8 @@
         </p:nvSpPr>
         <p:spPr>
           <a:xfrm>
-            <a:off x="8092440" y="2953512"/>
-            <a:ext cx="1920240" cy="585216"/>
+            <a:off x="8092440" y="3118104"/>
+            <a:ext cx="1920240" cy="658368"/>
           </a:xfrm>
           <a:prstGeom prst="rect">
             <a:avLst/>
@@ -3663,7 +3663,7 @@
         </p:nvSpPr>
         <p:spPr>
           <a:xfrm>
-            <a:off x="10104120" y="3090672"/>
+            <a:off x="10104120" y="3291840"/>
             <a:ext cx="1371600" cy="310896"/>
           </a:xfrm>
           <a:prstGeom prst="roundRect">
@@ -3685,7 +3685,7 @@
         </p:nvSpPr>
         <p:spPr>
           <a:xfrm>
-            <a:off x="10104120" y="3090672"/>
+            <a:off x="10104120" y="3291840"/>
             <a:ext cx="1371600" cy="310896"/>
           </a:xfrm>
           <a:prstGeom prst="rect">
@@ -3724,8 +3724,8 @@
         </p:nvSpPr>
         <p:spPr>
           <a:xfrm>
-            <a:off x="548640" y="3630168"/>
-            <a:ext cx="11064240" cy="585216"/>
+            <a:off x="548640" y="3877056"/>
+            <a:ext cx="11064240" cy="658368"/>
           </a:xfrm>
           <a:prstGeom prst="roundRect">
             <a:avLst>
@@ -3751,8 +3751,8 @@
         </p:nvSpPr>
         <p:spPr>
           <a:xfrm>
-            <a:off x="713232" y="3630168"/>
-            <a:ext cx="548640" cy="585216"/>
+            <a:off x="713232" y="3877056"/>
+            <a:ext cx="548640" cy="658368"/>
           </a:xfrm>
           <a:prstGeom prst="rect">
             <a:avLst/>
@@ -3770,7 +3770,7 @@
             <a:r>
               <a:rPr lang="en-US" sz="2200" b="1" dirty="0">
                 <a:solidFill>
-                  <a:srgbClr val="F1C40F"/>
+                  <a:srgbClr val="5D6D7E"/>
                 </a:solidFill>
                 <a:latin typeface="Cambria" pitchFamily="34" charset="0"/>
                 <a:ea typeface="Cambria" pitchFamily="34" charset="-122"/>
@@ -3790,8 +3790,8 @@
         </p:nvSpPr>
         <p:spPr>
           <a:xfrm>
-            <a:off x="1417320" y="3630168"/>
-            <a:ext cx="6583680" cy="585216"/>
+            <a:off x="1417320" y="3877056"/>
+            <a:ext cx="6583680" cy="658368"/>
           </a:xfrm>
           <a:prstGeom prst="rect">
             <a:avLst/>
@@ -3815,7 +3815,7 @@
                 <a:ea typeface="Calibri" pitchFamily="34" charset="-122"/>
                 <a:cs typeface="Calibri" pitchFamily="34" charset="-120"/>
               </a:rPr>
-              <a:t>Falscher Content-Type → Body still verworfen</a:t>
+              <a:t>PUT / PATCH / DELETE verfügbar, aber undokumentiert</a:t>
             </a:r>
             <a:endParaRPr lang="en-US" sz="1550" dirty="0"/>
           </a:p>
@@ -3829,8 +3829,8 @@
         </p:nvSpPr>
         <p:spPr>
           <a:xfrm>
-            <a:off x="8092440" y="3630168"/>
-            <a:ext cx="1920240" cy="585216"/>
+            <a:off x="8092440" y="3877056"/>
+            <a:ext cx="1920240" cy="658368"/>
           </a:xfrm>
           <a:prstGeom prst="rect">
             <a:avLst/>
@@ -3846,15 +3846,15 @@
               <a:buNone/>
             </a:pPr>
             <a:r>
-              <a:rPr lang="en-US" sz="1100" b="1" dirty="0">
-                <a:solidFill>
-                  <a:srgbClr val="C0392B"/>
-                </a:solidFill>
-                <a:latin typeface="Calibri" pitchFamily="34" charset="0"/>
-                <a:ea typeface="Calibri" pitchFamily="34" charset="-122"/>
-                <a:cs typeface="Calibri" pitchFamily="34" charset="-120"/>
-              </a:rPr>
-              <a:t>Test rot</a:t>
+              <a:rPr lang="en-US" sz="1100" i="1" dirty="0">
+                <a:solidFill>
+                  <a:srgbClr val="5A6483"/>
+                </a:solidFill>
+                <a:latin typeface="Calibri" pitchFamily="34" charset="0"/>
+                <a:ea typeface="Calibri" pitchFamily="34" charset="-122"/>
+                <a:cs typeface="Calibri" pitchFamily="34" charset="-120"/>
+              </a:rPr>
+              <a:t>Doku-Lücke · grün</a:t>
             </a:r>
             <a:endParaRPr lang="en-US" sz="1100" dirty="0"/>
           </a:p>
@@ -3868,7 +3868,7 @@
         </p:nvSpPr>
         <p:spPr>
           <a:xfrm>
-            <a:off x="10104120" y="3767328"/>
+            <a:off x="10104120" y="4050792"/>
             <a:ext cx="1371600" cy="310896"/>
           </a:xfrm>
           <a:prstGeom prst="roundRect">
@@ -3877,7 +3877,7 @@
             </a:avLst>
           </a:prstGeom>
           <a:solidFill>
-            <a:srgbClr val="F1C40F"/>
+            <a:srgbClr val="5D6D7E"/>
           </a:solidFill>
           <a:ln/>
         </p:spPr>
@@ -3890,7 +3890,7 @@
         </p:nvSpPr>
         <p:spPr>
           <a:xfrm>
-            <a:off x="10104120" y="3767328"/>
+            <a:off x="10104120" y="4050792"/>
             <a:ext cx="1371600" cy="310896"/>
           </a:xfrm>
           <a:prstGeom prst="rect">
@@ -3915,7 +3915,7 @@
                 <a:ea typeface="Calibri" pitchFamily="34" charset="-122"/>
                 <a:cs typeface="Calibri" pitchFamily="34" charset="-120"/>
               </a:rPr>
-              <a:t>Mittel</a:t>
+              <a:t>Niedrig</a:t>
             </a:r>
             <a:endParaRPr lang="en-US" sz="1100" dirty="0"/>
           </a:p>
@@ -3929,8 +3929,8 @@
         </p:nvSpPr>
         <p:spPr>
           <a:xfrm>
-            <a:off x="548640" y="4306824"/>
-            <a:ext cx="11064240" cy="585216"/>
+            <a:off x="548640" y="4636008"/>
+            <a:ext cx="11064240" cy="658368"/>
           </a:xfrm>
           <a:prstGeom prst="roundRect">
             <a:avLst>
@@ -3956,8 +3956,8 @@
         </p:nvSpPr>
         <p:spPr>
           <a:xfrm>
-            <a:off x="713232" y="4306824"/>
-            <a:ext cx="548640" cy="585216"/>
+            <a:off x="713232" y="4636008"/>
+            <a:ext cx="548640" cy="658368"/>
           </a:xfrm>
           <a:prstGeom prst="rect">
             <a:avLst/>
@@ -3995,8 +3995,8 @@
         </p:nvSpPr>
         <p:spPr>
           <a:xfrm>
-            <a:off x="1417320" y="4306824"/>
-            <a:ext cx="6583680" cy="585216"/>
+            <a:off x="1417320" y="4636008"/>
+            <a:ext cx="6583680" cy="658368"/>
           </a:xfrm>
           <a:prstGeom prst="rect">
             <a:avLst/>
@@ -4034,8 +4034,8 @@
         </p:nvSpPr>
         <p:spPr>
           <a:xfrm>
-            <a:off x="8092440" y="4306824"/>
-            <a:ext cx="1920240" cy="585216"/>
+            <a:off x="8092440" y="4636008"/>
+            <a:ext cx="1920240" cy="658368"/>
           </a:xfrm>
           <a:prstGeom prst="rect">
             <a:avLst/>
@@ -4073,7 +4073,7 @@
         </p:nvSpPr>
         <p:spPr>
           <a:xfrm>
-            <a:off x="10104120" y="4443984"/>
+            <a:off x="10104120" y="4809744"/>
             <a:ext cx="1371600" cy="310896"/>
           </a:xfrm>
           <a:prstGeom prst="roundRect">
@@ -4095,7 +4095,7 @@
         </p:nvSpPr>
         <p:spPr>
           <a:xfrm>
-            <a:off x="10104120" y="4443984"/>
+            <a:off x="10104120" y="4809744"/>
             <a:ext cx="1371600" cy="310896"/>
           </a:xfrm>
           <a:prstGeom prst="rect">
@@ -4134,8 +4134,8 @@
         </p:nvSpPr>
         <p:spPr>
           <a:xfrm>
-            <a:off x="548640" y="4983480"/>
-            <a:ext cx="11064240" cy="585216"/>
+            <a:off x="548640" y="5394960"/>
+            <a:ext cx="11064240" cy="658368"/>
           </a:xfrm>
           <a:prstGeom prst="roundRect">
             <a:avLst>
@@ -4161,8 +4161,8 @@
         </p:nvSpPr>
         <p:spPr>
           <a:xfrm>
-            <a:off x="713232" y="4983480"/>
-            <a:ext cx="548640" cy="585216"/>
+            <a:off x="713232" y="5394960"/>
+            <a:ext cx="548640" cy="658368"/>
           </a:xfrm>
           <a:prstGeom prst="rect">
             <a:avLst/>
@@ -4200,8 +4200,8 @@
         </p:nvSpPr>
         <p:spPr>
           <a:xfrm>
-            <a:off x="1417320" y="4983480"/>
-            <a:ext cx="6583680" cy="585216"/>
+            <a:off x="1417320" y="5394960"/>
+            <a:ext cx="6583680" cy="658368"/>
           </a:xfrm>
           <a:prstGeom prst="rect">
             <a:avLst/>
@@ -4225,7 +4225,7 @@
                 <a:ea typeface="Calibri" pitchFamily="34" charset="-122"/>
                 <a:cs typeface="Calibri" pitchFamily="34" charset="-120"/>
               </a:rPr>
-              <a:t>PUT / PATCH / DELETE verfügbar, aber undokumentiert</a:t>
+              <a:t>/roads: Filter/Sort/Pagination wirkungslos</a:t>
             </a:r>
             <a:endParaRPr lang="en-US" sz="1550" dirty="0"/>
           </a:p>
@@ -4239,8 +4239,8 @@
         </p:nvSpPr>
         <p:spPr>
           <a:xfrm>
-            <a:off x="8092440" y="4983480"/>
-            <a:ext cx="1920240" cy="585216"/>
+            <a:off x="8092440" y="5394960"/>
+            <a:ext cx="1920240" cy="658368"/>
           </a:xfrm>
           <a:prstGeom prst="rect">
             <a:avLst/>
@@ -4264,7 +4264,7 @@
                 <a:ea typeface="Calibri" pitchFamily="34" charset="-122"/>
                 <a:cs typeface="Calibri" pitchFamily="34" charset="-120"/>
               </a:rPr>
-              <a:t>Doku-Lücke · grün</a:t>
+              <a:t>Limitierung · grün</a:t>
             </a:r>
             <a:endParaRPr lang="en-US" sz="1100" dirty="0"/>
           </a:p>
@@ -4278,7 +4278,7 @@
         </p:nvSpPr>
         <p:spPr>
           <a:xfrm>
-            <a:off x="10104120" y="5120640"/>
+            <a:off x="10104120" y="5568696"/>
             <a:ext cx="1371600" cy="310896"/>
           </a:xfrm>
           <a:prstGeom prst="roundRect">
@@ -4300,212 +4300,7 @@
         </p:nvSpPr>
         <p:spPr>
           <a:xfrm>
-            <a:off x="10104120" y="5120640"/>
-            <a:ext cx="1371600" cy="310896"/>
-          </a:xfrm>
-          <a:prstGeom prst="rect">
-            <a:avLst/>
-          </a:prstGeom>
-          <a:noFill/>
-          <a:ln/>
-        </p:spPr>
-        <p:txBody>
-          <a:bodyPr wrap="square" lIns="0" tIns="0" rIns="0" bIns="0" rtlCol="0" anchor="ctr"/>
-          <a:lstStyle/>
-          <a:p>
-            <a:pPr algn="ctr" indent="0" marL="0">
-              <a:buNone/>
-            </a:pPr>
-            <a:r>
-              <a:rPr lang="en-US" sz="1100" b="1" dirty="0">
-                <a:solidFill>
-                  <a:srgbClr val="FFFFFF"/>
-                </a:solidFill>
-                <a:latin typeface="Calibri" pitchFamily="34" charset="0"/>
-                <a:ea typeface="Calibri" pitchFamily="34" charset="-122"/>
-                <a:cs typeface="Calibri" pitchFamily="34" charset="-120"/>
-              </a:rPr>
-              <a:t>Niedrig</a:t>
-            </a:r>
-            <a:endParaRPr lang="en-US" sz="1100" dirty="0"/>
-          </a:p>
-        </p:txBody>
-      </p:sp>
-      <p:sp>
-        <p:nvSpPr>
-          <p:cNvPr id="40" name="Shape 2"/>
-          <p:cNvSpPr/>
-          <p:nvPr/>
-        </p:nvSpPr>
-        <p:spPr>
-          <a:xfrm>
-            <a:off x="548640" y="5660136"/>
-            <a:ext cx="11064240" cy="585216"/>
-          </a:xfrm>
-          <a:prstGeom prst="roundRect">
-            <a:avLst>
-              <a:gd name="adj" fmla="val 8333"/>
-            </a:avLst>
-          </a:prstGeom>
-          <a:solidFill>
-            <a:srgbClr val="F4F6FC"/>
-          </a:solidFill>
-          <a:ln w="12700">
-            <a:solidFill>
-              <a:srgbClr val="E3E8F5"/>
-            </a:solidFill>
-            <a:prstDash val="solid"/>
-          </a:ln>
-        </p:spPr>
-      </p:sp>
-      <p:sp>
-        <p:nvSpPr>
-          <p:cNvPr id="41" name="Text 3"/>
-          <p:cNvSpPr/>
-          <p:nvPr/>
-        </p:nvSpPr>
-        <p:spPr>
-          <a:xfrm>
-            <a:off x="713232" y="5660136"/>
-            <a:ext cx="548640" cy="585216"/>
-          </a:xfrm>
-          <a:prstGeom prst="rect">
-            <a:avLst/>
-          </a:prstGeom>
-          <a:noFill/>
-          <a:ln/>
-        </p:spPr>
-        <p:txBody>
-          <a:bodyPr wrap="square" lIns="0" tIns="0" rIns="0" bIns="0" rtlCol="0" anchor="ctr"/>
-          <a:lstStyle/>
-          <a:p>
-            <a:pPr algn="ctr" indent="0" marL="0">
-              <a:buNone/>
-            </a:pPr>
-            <a:r>
-              <a:rPr lang="en-US" sz="2200" b="1" dirty="0">
-                <a:solidFill>
-                  <a:srgbClr val="5D6D7E"/>
-                </a:solidFill>
-                <a:latin typeface="Cambria" pitchFamily="34" charset="0"/>
-                <a:ea typeface="Cambria" pitchFamily="34" charset="-122"/>
-                <a:cs typeface="Cambria" pitchFamily="34" charset="-120"/>
-              </a:rPr>
-              <a:t>7</a:t>
-            </a:r>
-            <a:endParaRPr lang="en-US" sz="2200" dirty="0"/>
-          </a:p>
-        </p:txBody>
-      </p:sp>
-      <p:sp>
-        <p:nvSpPr>
-          <p:cNvPr id="42" name="Text 4"/>
-          <p:cNvSpPr/>
-          <p:nvPr/>
-        </p:nvSpPr>
-        <p:spPr>
-          <a:xfrm>
-            <a:off x="1417320" y="5660136"/>
-            <a:ext cx="6583680" cy="585216"/>
-          </a:xfrm>
-          <a:prstGeom prst="rect">
-            <a:avLst/>
-          </a:prstGeom>
-          <a:noFill/>
-          <a:ln/>
-        </p:spPr>
-        <p:txBody>
-          <a:bodyPr wrap="square" lIns="0" tIns="0" rIns="0" bIns="0" rtlCol="0" anchor="ctr"/>
-          <a:lstStyle/>
-          <a:p>
-            <a:pPr indent="0" marL="0">
-              <a:buNone/>
-            </a:pPr>
-            <a:r>
-              <a:rPr lang="en-US" sz="1550" dirty="0">
-                <a:solidFill>
-                  <a:srgbClr val="1B2340"/>
-                </a:solidFill>
-                <a:latin typeface="Calibri" pitchFamily="34" charset="0"/>
-                <a:ea typeface="Calibri" pitchFamily="34" charset="-122"/>
-                <a:cs typeface="Calibri" pitchFamily="34" charset="-120"/>
-              </a:rPr>
-              <a:t>/roads: Filter/Sort/Pagination wirkungslos</a:t>
-            </a:r>
-            <a:endParaRPr lang="en-US" sz="1550" dirty="0"/>
-          </a:p>
-        </p:txBody>
-      </p:sp>
-      <p:sp>
-        <p:nvSpPr>
-          <p:cNvPr id="43" name="Text 4"/>
-          <p:cNvSpPr/>
-          <p:nvPr/>
-        </p:nvSpPr>
-        <p:spPr>
-          <a:xfrm>
-            <a:off x="8092440" y="5660136"/>
-            <a:ext cx="1920240" cy="585216"/>
-          </a:xfrm>
-          <a:prstGeom prst="rect">
-            <a:avLst/>
-          </a:prstGeom>
-          <a:noFill/>
-          <a:ln/>
-        </p:spPr>
-        <p:txBody>
-          <a:bodyPr wrap="square" lIns="0" tIns="0" rIns="0" bIns="0" rtlCol="0" anchor="ctr"/>
-          <a:lstStyle/>
-          <a:p>
-            <a:pPr indent="0" marL="0">
-              <a:buNone/>
-            </a:pPr>
-            <a:r>
-              <a:rPr lang="en-US" sz="1100" i="1" dirty="0">
-                <a:solidFill>
-                  <a:srgbClr val="5A6483"/>
-                </a:solidFill>
-                <a:latin typeface="Calibri" pitchFamily="34" charset="0"/>
-                <a:ea typeface="Calibri" pitchFamily="34" charset="-122"/>
-                <a:cs typeface="Calibri" pitchFamily="34" charset="-120"/>
-              </a:rPr>
-              <a:t>Limitierung · grün</a:t>
-            </a:r>
-            <a:endParaRPr lang="en-US" sz="1100" dirty="0"/>
-          </a:p>
-        </p:txBody>
-      </p:sp>
-      <p:sp>
-        <p:nvSpPr>
-          <p:cNvPr id="44" name="Shape 5"/>
-          <p:cNvSpPr/>
-          <p:nvPr/>
-        </p:nvSpPr>
-        <p:spPr>
-          <a:xfrm>
-            <a:off x="10104120" y="5797296"/>
-            <a:ext cx="1371600" cy="310896"/>
-          </a:xfrm>
-          <a:prstGeom prst="roundRect">
-            <a:avLst>
-              <a:gd name="adj" fmla="val 50000"/>
-            </a:avLst>
-          </a:prstGeom>
-          <a:solidFill>
-            <a:srgbClr val="5D6D7E"/>
-          </a:solidFill>
-          <a:ln/>
-        </p:spPr>
-      </p:sp>
-      <p:sp>
-        <p:nvSpPr>
-          <p:cNvPr id="45" name="Text 6"/>
-          <p:cNvSpPr/>
-          <p:nvPr/>
-        </p:nvSpPr>
-        <p:spPr>
-          <a:xfrm>
-            <a:off x="10104120" y="5797296"/>
+            <a:off x="10104120" y="5568696"/>
             <a:ext cx="1371600" cy="310896"/>
           </a:xfrm>
           <a:prstGeom prst="rect">
@@ -5064,7 +4859,7 @@
                 <a:ea typeface="Calibri" pitchFamily="34" charset="-122"/>
                 <a:cs typeface="Calibri" pitchFamily="34" charset="-120"/>
               </a:rPr>
-              <a:t>Unter jeder Vertragsauslegung falsch: entweder ablehnen oder anhängen – niemals alles ersetzen. Kompletter Datenverlust bis API-Neustart, nicht per API wiederherstellbar – daher bewusst NICHT im automatischen Lauf.</a:t>
+              <a:t>Unter jeder Vertragsauslegung falsch: entweder ablehnen oder anhängen – niemals alles ersetzen. Kompletter Datenverlust bis API-Neustart, nicht per API wiederherstellbar – daher bewusst NICHT im automatischen Lauf. Auslösbar von jeder fremden Webseite: mit Content-Type: text/plain ist es ein Simple Request ohne Preflight – CORS schützt hier nicht.</a:t>
             </a:r>
             <a:endParaRPr lang="en-US" sz="1400" dirty="0"/>
           </a:p>
@@ -5738,7 +5533,7 @@
                 <a:ea typeface="Calibri" pitchFamily="34" charset="-122"/>
                 <a:cs typeface="Calibri" pitchFamily="34" charset="-120"/>
               </a:rPr>
-              <a:t>CORS-Konfiguration und Content-Type-Handling</a:t>
+              <a:t>Content-Type-Handling und undokumentierte Endpunkte</a:t>
             </a:r>
             <a:endParaRPr lang="en-US" sz="1400" dirty="0"/>
           </a:p>
@@ -5865,7 +5660,7 @@
                 <a:ea typeface="Cambria" pitchFamily="34" charset="-122"/>
                 <a:cs typeface="Cambria" pitchFamily="34" charset="-120"/>
               </a:rPr>
-              <a:t>CORS erlaubt jede Origin</a:t>
+              <a:t>Content-Type verwirft Body still</a:t>
             </a:r>
             <a:endParaRPr lang="en-US" sz="1800" dirty="0"/>
           </a:p>
@@ -5929,7 +5724,7 @@
                 <a:ea typeface="Courier New" pitchFamily="34" charset="-122"/>
                 <a:cs typeface="Courier New" pitchFamily="34" charset="-120"/>
               </a:rPr>
-              <a:t>OPTIONS /todos (Request-Method: POST)</a:t>
+              <a:t>Content-Type: text/plain</a:t>
             </a:r>
             <a:endParaRPr lang="en-US" sz="1150" dirty="0"/>
           </a:p>
@@ -5949,7 +5744,7 @@
                 <a:ea typeface="Courier New" pitchFamily="34" charset="-122"/>
                 <a:cs typeface="Courier New" pitchFamily="34" charset="-120"/>
               </a:rPr>
-              <a:t>Origin: http://evil.example</a:t>
+              <a:t>{ "title":"x", "road_fid":42 }</a:t>
             </a:r>
             <a:endParaRPr lang="en-US" sz="1150" dirty="0"/>
           </a:p>
@@ -5969,7 +5764,7 @@
                 <a:ea typeface="Courier New" pitchFamily="34" charset="-122"/>
                 <a:cs typeface="Courier New" pitchFamily="34" charset="-120"/>
               </a:rPr>
-              <a:t>→ 204 · Allow-Origin: http://evil.example</a:t>
+              <a:t>→ 201 Created</a:t>
             </a:r>
             <a:endParaRPr lang="en-US" sz="1150" dirty="0"/>
           </a:p>
@@ -5989,7 +5784,7 @@
                 <a:ea typeface="Courier New" pitchFamily="34" charset="-122"/>
                 <a:cs typeface="Courier New" pitchFamily="34" charset="-120"/>
               </a:rPr>
-              <a:t>→ Allow-Credentials: true</a:t>
+              <a:t>→ { "id": 15 }  // Body weg</a:t>
             </a:r>
             <a:endParaRPr lang="en-US" sz="1150" dirty="0"/>
           </a:p>
@@ -6032,7 +5827,7 @@
                 <a:ea typeface="Calibri" pitchFamily="34" charset="-122"/>
                 <a:cs typeface="Calibri" pitchFamily="34" charset="-120"/>
               </a:rPr>
-              <a:t>Jede Webseite kann per Browser lesen und schreiben – auch POST /roads (#1).</a:t>
+              <a:t>Payload wird stillschweigend ignoriert, leerer Datensatz entsteht.</a:t>
             </a:r>
             <a:endParaRPr lang="en-US" sz="1350" dirty="0"/>
           </a:p>
@@ -6050,7 +5845,7 @@
                 <a:ea typeface="Calibri" pitchFamily="34" charset="-122"/>
                 <a:cs typeface="Calibri" pitchFamily="34" charset="-120"/>
               </a:rPr>
-              <a:t>Erwartet: nur App-Origin :5173. [DEFECT #3] → Test rot.</a:t>
+              <a:t>Erwartet: 415 oder 400. [DEFECT #3] → Test rot.</a:t>
             </a:r>
             <a:endParaRPr lang="en-US" sz="1350" dirty="0"/>
           </a:p>
@@ -6100,7 +5895,7 @@
             </a:avLst>
           </a:prstGeom>
           <a:solidFill>
-            <a:srgbClr val="F1C40F"/>
+            <a:srgbClr val="5D6D7E"/>
           </a:solidFill>
           <a:ln/>
         </p:spPr>
@@ -6138,7 +5933,7 @@
                 <a:ea typeface="Calibri" pitchFamily="34" charset="-122"/>
                 <a:cs typeface="Calibri" pitchFamily="34" charset="-120"/>
               </a:rPr>
-              <a:t>MITTEL</a:t>
+              <a:t>NIEDRIG</a:t>
             </a:r>
             <a:endParaRPr lang="en-US" sz="1100" dirty="0"/>
           </a:p>
@@ -6177,7 +5972,7 @@
                 <a:ea typeface="Cambria" pitchFamily="34" charset="-122"/>
                 <a:cs typeface="Cambria" pitchFamily="34" charset="-120"/>
               </a:rPr>
-              <a:t>Content-Type verwirft Body still</a:t>
+              <a:t>Undokumentierte Schreib-Methoden</a:t>
             </a:r>
             <a:endParaRPr lang="en-US" sz="1800" dirty="0"/>
           </a:p>
@@ -6216,7 +6011,7 @@
                 <a:ea typeface="Courier New" pitchFamily="34" charset="-122"/>
                 <a:cs typeface="Courier New" pitchFamily="34" charset="-120"/>
               </a:rPr>
-              <a:t>POST · Content-Type: text/plain</a:t>
+              <a:t>PUT /todos/:id</a:t>
             </a:r>
             <a:endParaRPr lang="en-US" sz="1400" dirty="0"/>
           </a:p>
@@ -6236,7 +6031,7 @@
                 <a:ea typeface="Courier New" pitchFamily="34" charset="-122"/>
                 <a:cs typeface="Courier New" pitchFamily="34" charset="-120"/>
               </a:rPr>
-              <a:t>{ "title":"x", "road_fid":42 }</a:t>
+              <a:t>200 – ersetzt Datensatz vollständig</a:t>
             </a:r>
             <a:endParaRPr lang="en-US" sz="1400" dirty="0"/>
           </a:p>
@@ -6253,7 +6048,7 @@
                 <a:ea typeface="Courier New" pitchFamily="34" charset="-122"/>
                 <a:cs typeface="Courier New" pitchFamily="34" charset="-120"/>
               </a:rPr>
-              <a:t>Antwort</a:t>
+              <a:t>PATCH /todos/:id</a:t>
             </a:r>
             <a:endParaRPr lang="en-US" sz="1400" dirty="0"/>
           </a:p>
@@ -6273,7 +6068,7 @@
                 <a:ea typeface="Courier New" pitchFamily="34" charset="-122"/>
                 <a:cs typeface="Courier New" pitchFamily="34" charset="-120"/>
               </a:rPr>
-              <a:t>201 · { "id": 15 } – Body weg</a:t>
+              <a:t>200 – partielles Update (merge)</a:t>
             </a:r>
             <a:endParaRPr lang="en-US" sz="1400" dirty="0"/>
           </a:p>
@@ -6290,7 +6085,7 @@
                 <a:ea typeface="Courier New" pitchFamily="34" charset="-122"/>
                 <a:cs typeface="Courier New" pitchFamily="34" charset="-120"/>
               </a:rPr>
-              <a:t>Erwartet</a:t>
+              <a:t>DELETE /todos/:id</a:t>
             </a:r>
             <a:endParaRPr lang="en-US" sz="1400" dirty="0"/>
           </a:p>
@@ -6310,7 +6105,7 @@
                 <a:ea typeface="Courier New" pitchFamily="34" charset="-122"/>
                 <a:cs typeface="Courier New" pitchFamily="34" charset="-120"/>
               </a:rPr>
-              <a:t>415 Unsupported Media Type / 400</a:t>
+              <a:t>200 – löscht Datensatz</a:t>
             </a:r>
             <a:endParaRPr lang="en-US" sz="1400" dirty="0"/>
           </a:p>
@@ -6349,7 +6144,7 @@
                 <a:ea typeface="Calibri" pitchFamily="34" charset="-122"/>
                 <a:cs typeface="Calibri" pitchFamily="34" charset="-120"/>
               </a:rPr>
-              <a:t>Payload still ignoriert, leerer Datensatz entsteht. [DEFECT #4] → Test rot.</a:t>
+              <a:t>Doku nennt nur GET / POST – die Todos-Seite des Frontends hängt aber an diesen undokumentierten Endpunkten. Doku-Lücke, kein API-Fehler → Tests grün.</a:t>
             </a:r>
             <a:endParaRPr lang="en-US" sz="1300" dirty="0"/>
           </a:p>
@@ -6459,7 +6254,7 @@
                 <a:ea typeface="Calibri" pitchFamily="34" charset="-122"/>
                 <a:cs typeface="Calibri" pitchFamily="34" charset="-120"/>
               </a:rPr>
-              <a:t>Fehlersemantik und undokumentierte Methoden</a:t>
+              <a:t>Ressourcen-Limitierung und Fehlersemantik</a:t>
             </a:r>
             <a:endParaRPr lang="en-US" sz="1400" dirty="0"/>
           </a:p>
@@ -6501,7 +6296,7 @@
         <p:spPr>
           <a:xfrm>
             <a:off x="777240" y="1828800"/>
-            <a:ext cx="1371600" cy="310896"/>
+            <a:ext cx="1097280" cy="310896"/>
           </a:xfrm>
           <a:prstGeom prst="roundRect">
             <a:avLst>
@@ -6523,7 +6318,7 @@
         <p:spPr>
           <a:xfrm>
             <a:off x="777240" y="1828800"/>
-            <a:ext cx="1371600" cy="310896"/>
+            <a:ext cx="1097280" cy="310896"/>
           </a:xfrm>
           <a:prstGeom prst="rect">
             <a:avLst/>
@@ -6547,7 +6342,7 @@
                 <a:ea typeface="Calibri" pitchFamily="34" charset="-122"/>
                 <a:cs typeface="Calibri" pitchFamily="34" charset="-120"/>
               </a:rPr>
-              <a:t>NIEDRIG</a:t>
+              <a:t>INFO</a:t>
             </a:r>
             <a:endParaRPr lang="en-US" sz="1100" dirty="0"/>
           </a:p>
@@ -6586,7 +6381,7 @@
                 <a:ea typeface="Cambria" pitchFamily="34" charset="-122"/>
                 <a:cs typeface="Cambria" pitchFamily="34" charset="-120"/>
               </a:rPr>
-              <a:t>Schwache Fehlersemantik</a:t>
+              <a:t>/roads nicht filter-/sortierbar</a:t>
             </a:r>
             <a:endParaRPr lang="en-US" sz="1800" dirty="0"/>
           </a:p>
@@ -6629,7 +6424,7 @@
                 <a:ea typeface="Calibri" pitchFamily="34" charset="-122"/>
                 <a:cs typeface="Calibri" pitchFamily="34" charset="-120"/>
               </a:rPr>
-              <a:t>Doppelte id → 500 „duplicate id" statt 409 Conflict.</a:t>
+              <a:t>/roads ist ein Objekt (FeatureCollection), keine Array-Ressource.</a:t>
             </a:r>
             <a:endParaRPr lang="en-US" sz="1400" dirty="0"/>
           </a:p>
@@ -6650,7 +6445,7 @@
                 <a:ea typeface="Calibri" pitchFamily="34" charset="-122"/>
                 <a:cs typeface="Calibri" pitchFamily="34" charset="-120"/>
               </a:rPr>
-              <a:t>Kaputtes JSON → 400 als HTML-Fehlerseite – Client kann es kaum parsen.</a:t>
+              <a:t>?_page / _limit / _sort / Filter → wirkungslos, immer volle 2,3 MB.</a:t>
             </a:r>
             <a:endParaRPr lang="en-US" sz="1400" dirty="0"/>
           </a:p>
@@ -6671,7 +6466,7 @@
                 <a:ea typeface="Calibri" pitchFamily="34" charset="-122"/>
                 <a:cs typeface="Calibri" pitchFamily="34" charset="-120"/>
               </a:rPr>
-              <a:t>Beide Fehler kommen als text/html statt JSON.</a:t>
+              <a:t>Kein X-Total-Count. GET /roads/:id → 404.</a:t>
             </a:r>
             <a:endParaRPr lang="en-US" sz="1400" dirty="0"/>
           </a:p>
@@ -6689,7 +6484,7 @@
                 <a:ea typeface="Calibri" pitchFamily="34" charset="-122"/>
                 <a:cs typeface="Calibri" pitchFamily="34" charset="-120"/>
               </a:rPr>
-              <a:t>[DEFECT #5]: Soll 409 bzw. JSON-Fehler → 2 Tests rot.</a:t>
+              <a:t>Folge: Frontend lädt jedes Mal alle Straßen komplett.</a:t>
             </a:r>
             <a:endParaRPr lang="en-US" sz="1400" dirty="0"/>
           </a:p>
@@ -6816,7 +6611,7 @@
                 <a:ea typeface="Cambria" pitchFamily="34" charset="-122"/>
                 <a:cs typeface="Cambria" pitchFamily="34" charset="-120"/>
               </a:rPr>
-              <a:t>Undokumentierte Schreib-Methoden</a:t>
+              <a:t>Schwache Fehlersemantik</a:t>
             </a:r>
             <a:endParaRPr lang="en-US" sz="1800" dirty="0"/>
           </a:p>
@@ -6859,7 +6654,7 @@
                 <a:ea typeface="Calibri" pitchFamily="34" charset="-122"/>
                 <a:cs typeface="Calibri" pitchFamily="34" charset="-120"/>
               </a:rPr>
-              <a:t>PUT / PATCH / DELETE /todos/:id → 200, funktionieren korrekt.</a:t>
+              <a:t>Doppelte id → 500 „duplicate id" statt 409 Conflict.</a:t>
             </a:r>
             <a:endParaRPr lang="en-US" sz="1400" dirty="0"/>
           </a:p>
@@ -6880,7 +6675,7 @@
                 <a:ea typeface="Calibri" pitchFamily="34" charset="-122"/>
                 <a:cs typeface="Calibri" pitchFamily="34" charset="-120"/>
               </a:rPr>
-              <a:t>Doku nennt nur GET / POST – das Frontend nutzt aber PUT und DELETE.</a:t>
+              <a:t>Kaputtes JSON → 400 als HTML-Fehlerseite (nicht JSON) – Client kann es kaum parsen.</a:t>
             </a:r>
             <a:endParaRPr lang="en-US" sz="1400" dirty="0"/>
           </a:p>
@@ -6898,7 +6693,7 @@
                 <a:ea typeface="Calibri" pitchFamily="34" charset="-122"/>
                 <a:cs typeface="Calibri" pitchFamily="34" charset="-120"/>
               </a:rPr>
-              <a:t>Doku-Lücke, kein API-Fehler → Tests bleiben grün.</a:t>
+              <a:t>[DEFECT #5]: Soll 409 bzw. JSON-Fehler → 2 Tests rot.</a:t>
             </a:r>
             <a:endParaRPr lang="en-US" sz="1400" dirty="0"/>
           </a:p>
@@ -7953,7 +7748,7 @@
                 <a:ea typeface="Calibri" pitchFamily="34" charset="-122"/>
                 <a:cs typeface="Calibri" pitchFamily="34" charset="-120"/>
               </a:rPr>
-              <a:t>CORS</a:t>
+              <a:t>Fehler-Routen</a:t>
             </a:r>
             <a:endParaRPr lang="en-US" sz="1650" dirty="0"/>
           </a:p>
@@ -7992,7 +7787,7 @@
                 <a:ea typeface="Calibri" pitchFamily="34" charset="-122"/>
                 <a:cs typeface="Calibri" pitchFamily="34" charset="-120"/>
               </a:rPr>
-              <a:t>App-Origin :5173: Preflight 204, POST erlaubt</a:t>
+              <a:t>Unbekannte Route &amp; gelöschte ID → 404</a:t>
             </a:r>
             <a:endParaRPr lang="en-US" sz="1250" dirty="0"/>
           </a:p>
@@ -8222,7 +8017,7 @@
                 <a:ea typeface="Calibri" pitchFamily="34" charset="-122"/>
                 <a:cs typeface="Calibri" pitchFamily="34" charset="-120"/>
               </a:rPr>
-              <a:t>Schreiben auf /roads sperren, CORS auf App-Origin begrenzen (#1, #3).</a:t>
+              <a:t>Schreiben auf /roads sperren; CORS vor Go-Live auf die App-Origin begrenzen (#1).</a:t>
             </a:r>
             <a:endParaRPr lang="en-US" sz="1450" dirty="0"/>
           </a:p>
@@ -8342,7 +8137,7 @@
                 <a:ea typeface="Calibri" pitchFamily="34" charset="-122"/>
                 <a:cs typeface="Calibri" pitchFamily="34" charset="-120"/>
               </a:rPr>
-              <a:t>Pflichtfelder &amp; Schema serverseitig erzwingen (#2, #4).</a:t>
+              <a:t>Pflichtfelder &amp; Schema serverseitig erzwingen (#2, #3).</a:t>
             </a:r>
             <a:endParaRPr lang="en-US" sz="1450" dirty="0"/>
           </a:p>
@@ -8462,7 +8257,7 @@
                 <a:ea typeface="Calibri" pitchFamily="34" charset="-122"/>
                 <a:cs typeface="Calibri" pitchFamily="34" charset="-120"/>
               </a:rPr>
-              <a:t>Alle Methoden dokumentieren, saubere Statuscodes (#5, #6).</a:t>
+              <a:t>Alle Methoden dokumentieren, saubere Statuscodes (#4, #5).</a:t>
             </a:r>
             <a:endParaRPr lang="en-US" sz="1450" dirty="0"/>
           </a:p>
@@ -8582,7 +8377,7 @@
                 <a:ea typeface="Calibri" pitchFamily="34" charset="-122"/>
                 <a:cs typeface="Calibri" pitchFamily="34" charset="-120"/>
               </a:rPr>
-              <a:t>Serverseitige Filterung statt Voll-Download von /roads (#7).</a:t>
+              <a:t>Serverseitige Filterung statt Voll-Download von /roads (#6).</a:t>
             </a:r>
             <a:endParaRPr lang="en-US" sz="1450" dirty="0"/>
           </a:p>

</xml_diff>

<commit_message>
API: validate road references and todo updates, tests for the gaps
New API tests found validation gaps the SUT fix did not cover yet: a todo
for a road that does not exist, PUT with an empty body and PATCH with an
empty title were all accepted.

- server.js: POST and PUT need the road_fid of an existing road (422
  otherwise); PUT validates the replacing body, PATCH only the fields it
  sends; a todo that does not exist still returns 404
- collection: [DEFECT #2] empty title, string road_fid and unknown
  road_fid; [DEFECT #7] PUT {} and PATCH with an empty title; the
  duplicate-id and PUT tests use roads that exist
- report.html regenerated against the fixed API: 35 requests,
  76 assertions, all green
- findings deck: new finding #7, PUT/PATCH /roads under #1, "Was
  funktioniert" names the endpoints
- READMEs updated
</commit_message>
<xml_diff>
--- a/api-tests/road-overview-api-findings.pptx
+++ b/api-tests/road-overview-api-findings.pptx
@@ -12,6 +12,7 @@
     <p:sldId id="260" r:id="rId6"/>
     <p:sldId id="261" r:id="rId7"/>
     <p:sldId id="262" r:id="rId8"/>
+    <p:sldId id="265" r:id="rId16"/>
     <p:sldId id="263" r:id="rId9"/>
     <p:sldId id="264" r:id="rId10"/>
   </p:sldIdLst>
@@ -1759,7 +1760,7 @@
                 <a:ea typeface="Cambria" pitchFamily="34" charset="-122"/>
                 <a:cs typeface="Cambria" pitchFamily="34" charset="-120"/>
               </a:rPr>
-              <a:t>30</a:t>
+              <a:t>35</a:t>
             </a:r>
             <a:endParaRPr lang="en-US" sz="4400" dirty="0"/>
           </a:p>
@@ -1837,7 +1838,7 @@
                 <a:ea typeface="Cambria" pitchFamily="34" charset="-122"/>
                 <a:cs typeface="Cambria" pitchFamily="34" charset="-120"/>
               </a:rPr>
-              <a:t>73</a:t>
+              <a:t>81</a:t>
             </a:r>
             <a:endParaRPr lang="en-US" sz="4400" dirty="0"/>
           </a:p>
@@ -1915,7 +1916,7 @@
                 <a:ea typeface="Cambria" pitchFamily="34" charset="-122"/>
                 <a:cs typeface="Cambria" pitchFamily="34" charset="-120"/>
               </a:rPr>
-              <a:t>6</a:t>
+              <a:t>7</a:t>
             </a:r>
             <a:endParaRPr lang="en-US" sz="4400" dirty="0"/>
           </a:p>
@@ -1993,7 +1994,7 @@
                 <a:ea typeface="Cambria" pitchFamily="34" charset="-122"/>
                 <a:cs typeface="Cambria" pitchFamily="34" charset="-120"/>
               </a:rPr>
-              <a:t>4</a:t>
+              <a:t>9</a:t>
             </a:r>
             <a:endParaRPr lang="en-US" sz="4400" dirty="0"/>
           </a:p>
@@ -2074,6 +2075,570 @@
               <a:t>Newman-verifiziert gegen json-server@0.17.4 · Soll-Assertions, Defekte bewusst rot · self-cleaning</a:t>
             </a:r>
             <a:endParaRPr lang="en-US" sz="1200" dirty="0"/>
+          </a:p>
+        </p:txBody>
+      </p:sp>
+    </p:spTree>
+  </p:cSld>
+  <p:clrMapOvr>
+    <a:masterClrMapping/>
+  </p:clrMapOvr>
+</p:sld>
+</file>
+
+<file path=ppt/slides/slide10.xml><?xml version="1.0" encoding="utf-8"?>
+<p:sld xmlns:a="http://schemas.openxmlformats.org/drawingml/2006/main" xmlns:r="http://schemas.openxmlformats.org/officeDocument/2006/relationships" xmlns:p="http://schemas.openxmlformats.org/presentationml/2006/main">
+  <p:cSld name="Slide 5">
+    <p:bg>
+      <p:bgPr>
+        <a:solidFill>
+          <a:srgbClr val="FFFFFF"/>
+        </a:solidFill>
+      </p:bgPr>
+    </p:bg>
+    <p:spTree>
+      <p:nvGrpSpPr>
+        <p:cNvPr id="1" name=""/>
+        <p:cNvGrpSpPr/>
+        <p:nvPr/>
+      </p:nvGrpSpPr>
+      <p:grpSpPr>
+        <a:xfrm>
+          <a:off x="0" y="0"/>
+          <a:ext cx="0" cy="0"/>
+          <a:chOff x="0" y="0"/>
+          <a:chExt cx="0" cy="0"/>
+        </a:xfrm>
+      </p:grpSpPr>
+      <p:sp>
+        <p:nvSpPr>
+          <p:cNvPr id="2" name="Text 0"/>
+          <p:cNvSpPr/>
+          <p:nvPr/>
+        </p:nvSpPr>
+        <p:spPr>
+          <a:xfrm>
+            <a:off x="548640" y="457200"/>
+            <a:ext cx="5486400" cy="365760"/>
+          </a:xfrm>
+          <a:prstGeom prst="rect">
+            <a:avLst/>
+          </a:prstGeom>
+          <a:noFill/>
+          <a:ln/>
+        </p:spPr>
+        <p:txBody>
+          <a:bodyPr wrap="square" rtlCol="0" anchor="ctr"/>
+          <a:lstStyle/>
+          <a:p>
+            <a:pPr indent="0" marL="0">
+              <a:buNone/>
+            </a:pPr>
+            <a:r>
+              <a:rPr lang="en-US" sz="1500" dirty="0">
+                <a:solidFill>
+                  <a:srgbClr val="5A6483"/>
+                </a:solidFill>
+                <a:latin typeface="Calibri" pitchFamily="34" charset="0"/>
+                <a:ea typeface="Calibri" pitchFamily="34" charset="-122"/>
+                <a:cs typeface="Calibri" pitchFamily="34" charset="-120"/>
+              </a:rPr>
+              <a:t>Finding #7</a:t>
+            </a:r>
+            <a:endParaRPr lang="en-US" sz="1500" dirty="0"/>
+          </a:p>
+        </p:txBody>
+      </p:sp>
+      <p:sp>
+        <p:nvSpPr>
+          <p:cNvPr id="3" name="Shape 1"/>
+          <p:cNvSpPr/>
+          <p:nvPr/>
+        </p:nvSpPr>
+        <p:spPr>
+          <a:xfrm>
+            <a:off x="10241280" y="457200"/>
+            <a:ext cx="1371600" cy="310896"/>
+          </a:xfrm>
+          <a:prstGeom prst="roundRect">
+            <a:avLst>
+              <a:gd name="adj" fmla="val 50000"/>
+            </a:avLst>
+          </a:prstGeom>
+          <a:solidFill>
+            <a:srgbClr val="E67E22"/>
+          </a:solidFill>
+          <a:ln/>
+        </p:spPr>
+      </p:sp>
+      <p:sp>
+        <p:nvSpPr>
+          <p:cNvPr id="4" name="Text 2"/>
+          <p:cNvSpPr/>
+          <p:nvPr/>
+        </p:nvSpPr>
+        <p:spPr>
+          <a:xfrm>
+            <a:off x="10241280" y="457200"/>
+            <a:ext cx="1371600" cy="310896"/>
+          </a:xfrm>
+          <a:prstGeom prst="rect">
+            <a:avLst/>
+          </a:prstGeom>
+          <a:noFill/>
+          <a:ln/>
+        </p:spPr>
+        <p:txBody>
+          <a:bodyPr wrap="square" lIns="0" tIns="0" rIns="0" bIns="0" rtlCol="0" anchor="ctr"/>
+          <a:lstStyle/>
+          <a:p>
+            <a:pPr algn="ctr" indent="0" marL="0">
+              <a:buNone/>
+            </a:pPr>
+            <a:r>
+              <a:rPr lang="en-US" sz="1100" b="1" dirty="0">
+                <a:solidFill>
+                  <a:srgbClr val="FFFFFF"/>
+                </a:solidFill>
+                <a:latin typeface="Calibri" pitchFamily="34" charset="0"/>
+                <a:ea typeface="Calibri" pitchFamily="34" charset="-122"/>
+                <a:cs typeface="Calibri" pitchFamily="34" charset="-120"/>
+              </a:rPr>
+              <a:t>HOCH</a:t>
+            </a:r>
+            <a:endParaRPr lang="en-US" sz="1100" dirty="0"/>
+          </a:p>
+        </p:txBody>
+      </p:sp>
+      <p:sp>
+        <p:nvSpPr>
+          <p:cNvPr id="5" name="Text 3"/>
+          <p:cNvSpPr/>
+          <p:nvPr/>
+        </p:nvSpPr>
+        <p:spPr>
+          <a:xfrm>
+            <a:off x="548640" y="841248"/>
+            <a:ext cx="10972800" cy="731520"/>
+          </a:xfrm>
+          <a:prstGeom prst="rect">
+            <a:avLst/>
+          </a:prstGeom>
+          <a:noFill/>
+          <a:ln/>
+        </p:spPr>
+        <p:txBody>
+          <a:bodyPr wrap="square" rtlCol="0" anchor="ctr"/>
+          <a:lstStyle/>
+          <a:p>
+            <a:pPr indent="0" marL="0">
+              <a:buNone/>
+            </a:pPr>
+            <a:r>
+              <a:rPr lang="en-US" sz="3000" b="1" dirty="0">
+                <a:solidFill>
+                  <a:srgbClr val="1B2340"/>
+                </a:solidFill>
+                <a:latin typeface="Cambria" pitchFamily="34" charset="0"/>
+                <a:ea typeface="Cambria" pitchFamily="34" charset="-122"/>
+                <a:cs typeface="Cambria" pitchFamily="34" charset="-120"/>
+              </a:rPr>
+              <a:t>Keine Validierung bei PUT / PATCH /todos/:id</a:t>
+            </a:r>
+            <a:endParaRPr lang="en-US" sz="3000" dirty="0"/>
+          </a:p>
+        </p:txBody>
+      </p:sp>
+      <p:sp>
+        <p:nvSpPr>
+          <p:cNvPr id="6" name="Shape 4"/>
+          <p:cNvSpPr/>
+          <p:nvPr/>
+        </p:nvSpPr>
+        <p:spPr>
+          <a:xfrm>
+            <a:off x="548640" y="1783080"/>
+            <a:ext cx="6583680" cy="1600200"/>
+          </a:xfrm>
+          <a:prstGeom prst="roundRect">
+            <a:avLst>
+              <a:gd name="adj" fmla="val 3429"/>
+            </a:avLst>
+          </a:prstGeom>
+          <a:solidFill>
+            <a:srgbClr val="1B2340"/>
+          </a:solidFill>
+          <a:ln/>
+        </p:spPr>
+      </p:sp>
+      <p:sp>
+        <p:nvSpPr>
+          <p:cNvPr id="7" name="Text 5"/>
+          <p:cNvSpPr/>
+          <p:nvPr/>
+        </p:nvSpPr>
+        <p:spPr>
+          <a:xfrm>
+            <a:off x="713232" y="1892808"/>
+            <a:ext cx="6254496" cy="1380744"/>
+          </a:xfrm>
+          <a:prstGeom prst="rect">
+            <a:avLst/>
+          </a:prstGeom>
+          <a:noFill/>
+          <a:ln/>
+        </p:spPr>
+        <p:txBody>
+          <a:bodyPr wrap="square" lIns="0" tIns="0" rIns="0" bIns="0" rtlCol="0" anchor="t"/>
+          <a:lstStyle/>
+          <a:p>
+            <a:pPr indent="0" marL="0">
+              <a:lnSpc>
+                <a:spcPct val="112000"/>
+              </a:lnSpc>
+              <a:buNone/>
+            </a:pPr>
+            <a:r>
+              <a:rPr lang="en-US" sz="1150" dirty="0">
+                <a:solidFill>
+                  <a:srgbClr val="D8E2FF"/>
+                </a:solidFill>
+                <a:latin typeface="Courier New" pitchFamily="34" charset="0"/>
+                <a:ea typeface="Courier New" pitchFamily="34" charset="-122"/>
+                <a:cs typeface="Courier New" pitchFamily="34" charset="-120"/>
+              </a:rPr>
+              <a:t>$ curl -X PUT -H 'Content-Type: application/json' \</a:t>
+            </a:r>
+            <a:endParaRPr lang="en-US" sz="1150" dirty="0"/>
+          </a:p>
+          <a:p>
+            <a:pPr indent="0" marL="0">
+              <a:lnSpc>
+                <a:spcPct val="112000"/>
+              </a:lnSpc>
+              <a:buNone/>
+            </a:pPr>
+            <a:r>
+              <a:rPr lang="en-US" sz="1150" dirty="0">
+                <a:solidFill>
+                  <a:srgbClr val="D8E2FF"/>
+                </a:solidFill>
+                <a:latin typeface="Courier New" pitchFamily="34" charset="0"/>
+                <a:ea typeface="Courier New" pitchFamily="34" charset="-122"/>
+                <a:cs typeface="Courier New" pitchFamily="34" charset="-120"/>
+              </a:rPr>
+              <a:t>       -d '{}' http://localhost:3000/todos/2</a:t>
+            </a:r>
+            <a:endParaRPr lang="en-US" sz="1150" dirty="0"/>
+          </a:p>
+          <a:p>
+            <a:pPr indent="0" marL="0">
+              <a:lnSpc>
+                <a:spcPct val="112000"/>
+              </a:lnSpc>
+              <a:buNone/>
+            </a:pPr>
+            <a:r>
+              <a:rPr lang="en-US" sz="1150" dirty="0">
+                <a:solidFill>
+                  <a:srgbClr val="D8E2FF"/>
+                </a:solidFill>
+                <a:latin typeface="Courier New" pitchFamily="34" charset="0"/>
+                <a:ea typeface="Courier New" pitchFamily="34" charset="-122"/>
+                <a:cs typeface="Courier New" pitchFamily="34" charset="-120"/>
+              </a:rPr>
+              <a:t>  200 OK</a:t>
+            </a:r>
+            <a:endParaRPr lang="en-US" sz="1150" dirty="0"/>
+          </a:p>
+          <a:p>
+            <a:pPr indent="0" marL="0">
+              <a:lnSpc>
+                <a:spcPct val="112000"/>
+              </a:lnSpc>
+              <a:buNone/>
+            </a:pPr>
+            <a:r>
+              <a:rPr lang="en-US" sz="1150" dirty="0">
+                <a:solidFill>
+                  <a:srgbClr val="D8E2FF"/>
+                </a:solidFill>
+                <a:latin typeface="Courier New" pitchFamily="34" charset="0"/>
+                <a:ea typeface="Courier New" pitchFamily="34" charset="-122"/>
+                <a:cs typeface="Courier New" pitchFamily="34" charset="-120"/>
+              </a:rPr>
+              <a:t>  { "id": 2 }         // title, status, road_fid weg</a:t>
+            </a:r>
+            <a:endParaRPr lang="en-US" sz="1150" dirty="0"/>
+          </a:p>
+        </p:txBody>
+      </p:sp>
+      <p:sp>
+        <p:nvSpPr>
+          <p:cNvPr id="8" name="Shape 6"/>
+          <p:cNvSpPr/>
+          <p:nvPr/>
+        </p:nvSpPr>
+        <p:spPr>
+          <a:xfrm>
+            <a:off x="7406640" y="1783080"/>
+            <a:ext cx="4206240" cy="1600200"/>
+          </a:xfrm>
+          <a:prstGeom prst="roundRect">
+            <a:avLst>
+              <a:gd name="adj" fmla="val 4571"/>
+            </a:avLst>
+          </a:prstGeom>
+          <a:solidFill>
+            <a:srgbClr val="F4F6FC"/>
+          </a:solidFill>
+          <a:ln w="12700">
+            <a:solidFill>
+              <a:srgbClr val="E3E8F5"/>
+            </a:solidFill>
+            <a:prstDash val="solid"/>
+          </a:ln>
+        </p:spPr>
+      </p:sp>
+      <p:sp>
+        <p:nvSpPr>
+          <p:cNvPr id="9" name="Text 7"/>
+          <p:cNvSpPr/>
+          <p:nvPr/>
+        </p:nvSpPr>
+        <p:spPr>
+          <a:xfrm>
+            <a:off x="7607808" y="1920240"/>
+            <a:ext cx="3840480" cy="320040"/>
+          </a:xfrm>
+          <a:prstGeom prst="rect">
+            <a:avLst/>
+          </a:prstGeom>
+          <a:noFill/>
+          <a:ln/>
+        </p:spPr>
+        <p:txBody>
+          <a:bodyPr wrap="square" rtlCol="0" anchor="ctr"/>
+          <a:lstStyle/>
+          <a:p>
+            <a:pPr indent="0" marL="0">
+              <a:buNone/>
+            </a:pPr>
+            <a:r>
+              <a:rPr lang="en-US" sz="1300" b="1" dirty="0">
+                <a:solidFill>
+                  <a:srgbClr val="E67E22"/>
+                </a:solidFill>
+                <a:latin typeface="Calibri" pitchFamily="34" charset="0"/>
+                <a:ea typeface="Calibri" pitchFamily="34" charset="-122"/>
+                <a:cs typeface="Calibri" pitchFamily="34" charset="-120"/>
+              </a:rPr>
+              <a:t>Befund &amp; Test</a:t>
+            </a:r>
+            <a:endParaRPr lang="en-US" sz="1300" dirty="0"/>
+          </a:p>
+        </p:txBody>
+      </p:sp>
+      <p:sp>
+        <p:nvSpPr>
+          <p:cNvPr id="10" name="Text 8"/>
+          <p:cNvSpPr/>
+          <p:nvPr/>
+        </p:nvSpPr>
+        <p:spPr>
+          <a:xfrm>
+            <a:off x="7607808" y="2286000"/>
+            <a:ext cx="3840480" cy="1005840"/>
+          </a:xfrm>
+          <a:prstGeom prst="rect">
+            <a:avLst/>
+          </a:prstGeom>
+          <a:noFill/>
+          <a:ln/>
+        </p:spPr>
+        <p:txBody>
+          <a:bodyPr wrap="square" rtlCol="0" anchor="t"/>
+          <a:lstStyle/>
+          <a:p>
+            <a:pPr marL="342900" indent="-342900">
+              <a:spcAft>
+                <a:spcPts val="600"/>
+              </a:spcAft>
+              <a:buSzPct val="100000"/>
+              <a:buChar char="•"/>
+            </a:pPr>
+            <a:r>
+              <a:rPr lang="en-US" sz="1350" dirty="0">
+                <a:solidFill>
+                  <a:srgbClr val="1B2340"/>
+                </a:solidFill>
+                <a:latin typeface="Calibri" pitchFamily="34" charset="0"/>
+                <a:ea typeface="Calibri" pitchFamily="34" charset="-122"/>
+                <a:cs typeface="Calibri" pitchFamily="34" charset="-120"/>
+              </a:rPr>
+              <a:t>PUT {} → 200, Todo nur noch {"id": 2}</a:t>
+            </a:r>
+            <a:endParaRPr lang="en-US" sz="1350" dirty="0"/>
+          </a:p>
+          <a:p>
+            <a:pPr marL="342900" indent="-342900">
+              <a:spcAft>
+                <a:spcPts val="600"/>
+              </a:spcAft>
+              <a:buSzPct val="100000"/>
+              <a:buChar char="•"/>
+            </a:pPr>
+            <a:r>
+              <a:rPr lang="en-US" sz="1350" dirty="0">
+                <a:solidFill>
+                  <a:srgbClr val="1B2340"/>
+                </a:solidFill>
+                <a:latin typeface="Calibri" pitchFamily="34" charset="0"/>
+                <a:ea typeface="Calibri" pitchFamily="34" charset="-122"/>
+                <a:cs typeface="Calibri" pitchFamily="34" charset="-120"/>
+              </a:rPr>
+              <a:t>PATCH title "" → 200, leerer Titel gespeichert</a:t>
+            </a:r>
+            <a:endParaRPr lang="en-US" sz="1350" dirty="0"/>
+          </a:p>
+          <a:p>
+            <a:pPr marL="342900" indent="-342900">
+              <a:buSzPct val="100000"/>
+              <a:buChar char="•"/>
+            </a:pPr>
+            <a:r>
+              <a:rPr lang="en-US" sz="1350" dirty="0">
+                <a:solidFill>
+                  <a:srgbClr val="1B2340"/>
+                </a:solidFill>
+                <a:latin typeface="Calibri" pitchFamily="34" charset="0"/>
+                <a:ea typeface="Calibri" pitchFamily="34" charset="-122"/>
+                <a:cs typeface="Calibri" pitchFamily="34" charset="-120"/>
+              </a:rPr>
+              <a:t>[DEFECT #7]: Soll 400 → 2 Tests rot</a:t>
+            </a:r>
+            <a:endParaRPr lang="en-US" sz="1350" dirty="0"/>
+          </a:p>
+        </p:txBody>
+      </p:sp>
+      <p:sp>
+        <p:nvSpPr>
+          <p:cNvPr id="11" name="Text 9"/>
+          <p:cNvSpPr/>
+          <p:nvPr/>
+        </p:nvSpPr>
+        <p:spPr>
+          <a:xfrm>
+            <a:off x="548640" y="3749040"/>
+            <a:ext cx="10972800" cy="365760"/>
+          </a:xfrm>
+          <a:prstGeom prst="rect">
+            <a:avLst/>
+          </a:prstGeom>
+          <a:noFill/>
+          <a:ln/>
+        </p:spPr>
+        <p:txBody>
+          <a:bodyPr wrap="square" rtlCol="0" anchor="ctr"/>
+          <a:lstStyle/>
+          <a:p>
+            <a:pPr indent="0" marL="0">
+              <a:buNone/>
+            </a:pPr>
+            <a:r>
+              <a:rPr lang="en-US" sz="1800" b="1" dirty="0">
+                <a:solidFill>
+                  <a:srgbClr val="1E2761"/>
+                </a:solidFill>
+                <a:latin typeface="Cambria" pitchFamily="34" charset="0"/>
+                <a:ea typeface="Cambria" pitchFamily="34" charset="-122"/>
+                <a:cs typeface="Cambria" pitchFamily="34" charset="-120"/>
+              </a:rPr>
+              <a:t>Warum es zählt</a:t>
+            </a:r>
+            <a:endParaRPr lang="en-US" sz="1800" dirty="0"/>
+          </a:p>
+        </p:txBody>
+      </p:sp>
+      <p:sp>
+        <p:nvSpPr>
+          <p:cNvPr id="12" name="Text 10"/>
+          <p:cNvSpPr/>
+          <p:nvPr/>
+        </p:nvSpPr>
+        <p:spPr>
+          <a:xfrm>
+            <a:off x="640080" y="4160520"/>
+            <a:ext cx="10972800" cy="2011680"/>
+          </a:xfrm>
+          <a:prstGeom prst="rect">
+            <a:avLst/>
+          </a:prstGeom>
+          <a:noFill/>
+          <a:ln/>
+        </p:spPr>
+        <p:txBody>
+          <a:bodyPr wrap="square" rtlCol="0" anchor="t"/>
+          <a:lstStyle/>
+          <a:p>
+            <a:pPr marL="342900" indent="-342900">
+              <a:spcAft>
+                <a:spcPts val="800"/>
+              </a:spcAft>
+              <a:buSzPct val="100000"/>
+              <a:buChar char="•"/>
+            </a:pPr>
+            <a:r>
+              <a:rPr lang="en-US" sz="1500" dirty="0">
+                <a:solidFill>
+                  <a:srgbClr val="1B2340"/>
+                </a:solidFill>
+                <a:latin typeface="Calibri" pitchFamily="34" charset="0"/>
+                <a:ea typeface="Calibri" pitchFamily="34" charset="-122"/>
+                <a:cs typeface="Calibri" pitchFamily="34" charset="-120"/>
+              </a:rPr>
+              <a:t>Die Todos-Seite des Frontends speichert Änderungen per PUT – ein fehlerhafter Request löscht die Maßnahme still.</a:t>
+            </a:r>
+            <a:endParaRPr lang="en-US" sz="1500" dirty="0"/>
+          </a:p>
+          <a:p>
+            <a:pPr marL="342900" indent="-342900">
+              <a:spcAft>
+                <a:spcPts val="800"/>
+              </a:spcAft>
+              <a:buSzPct val="100000"/>
+              <a:buChar char="•"/>
+            </a:pPr>
+            <a:r>
+              <a:rPr lang="en-US" sz="1500" dirty="0">
+                <a:solidFill>
+                  <a:srgbClr val="1B2340"/>
+                </a:solidFill>
+                <a:latin typeface="Calibri" pitchFamily="34" charset="0"/>
+                <a:ea typeface="Calibri" pitchFamily="34" charset="-122"/>
+                <a:cs typeface="Calibri" pitchFamily="34" charset="-120"/>
+              </a:rPr>
+              <a:t>Gleiche Lücke wie #2, nur beim Ändern: Pflichtfelder gelten nach dem Anlegen nicht mehr.</a:t>
+            </a:r>
+            <a:endParaRPr lang="en-US" sz="1500" dirty="0"/>
+          </a:p>
+          <a:p>
+            <a:pPr marL="342900" indent="-342900">
+              <a:buSzPct val="100000"/>
+              <a:buChar char="•"/>
+            </a:pPr>
+            <a:r>
+              <a:rPr lang="en-US" sz="1500" dirty="0">
+                <a:solidFill>
+                  <a:srgbClr val="1B2340"/>
+                </a:solidFill>
+                <a:latin typeface="Calibri" pitchFamily="34" charset="0"/>
+                <a:ea typeface="Calibri" pitchFamily="34" charset="-122"/>
+                <a:cs typeface="Calibri" pitchFamily="34" charset="-120"/>
+              </a:rPr>
+              <a:t>Eine echte API sollte ungültige Updates mit 400 Bad Request ablehnen.</a:t>
+            </a:r>
+            <a:endParaRPr lang="en-US" sz="1500" dirty="0"/>
           </a:p>
         </p:txBody>
       </p:sp>
@@ -2729,7 +3294,7 @@
                 <a:ea typeface="Calibri" pitchFamily="34" charset="-122"/>
                 <a:cs typeface="Calibri" pitchFamily="34" charset="-120"/>
               </a:rPr>
-              <a:t>Newman: 30 Requests / 73 Assertions / 4 rot = bekannte Defekte. Self-cleaning bestätigt.</a:t>
+              <a:t>Newman: 35 Requests / 81 Assertions / 9 rot = bekannte Defekte. Self-cleaning bestätigt.</a:t>
             </a:r>
             <a:endParaRPr lang="en-US" sz="1350" dirty="0"/>
           </a:p>
@@ -2943,7 +3508,7 @@
                 <a:ea typeface="Calibri" pitchFamily="34" charset="-122"/>
                 <a:cs typeface="Calibri" pitchFamily="34" charset="-120"/>
               </a:rPr>
-              <a:t>POST /todos – Negativ &amp; Edge</a:t>
+              <a:t>POST /todos – Validierung &amp; Edge</a:t>
             </a:r>
             <a:endParaRPr lang="en-US" sz="1350" dirty="0"/>
           </a:p>
@@ -2964,7 +3529,7 @@
                 <a:ea typeface="Calibri" pitchFamily="34" charset="-122"/>
                 <a:cs typeface="Calibri" pitchFamily="34" charset="-120"/>
               </a:rPr>
-              <a:t>PUT / PATCH / DELETE (undokumentiert)</a:t>
+              <a:t>PUT / PATCH / DELETE /todos/:id</a:t>
             </a:r>
             <a:endParaRPr lang="en-US" sz="1350" dirty="0"/>
           </a:p>
@@ -3109,8 +3674,8 @@
         </p:nvSpPr>
         <p:spPr>
           <a:xfrm>
-            <a:off x="548640" y="1600200"/>
-            <a:ext cx="11064240" cy="658368"/>
+            <a:off x="548640" y="1554480"/>
+            <a:ext cx="11064240" cy="603504"/>
           </a:xfrm>
           <a:prstGeom prst="roundRect">
             <a:avLst>
@@ -3136,8 +3701,8 @@
         </p:nvSpPr>
         <p:spPr>
           <a:xfrm>
-            <a:off x="713232" y="1600200"/>
-            <a:ext cx="548640" cy="658368"/>
+            <a:off x="713232" y="1554480"/>
+            <a:ext cx="548640" cy="603504"/>
           </a:xfrm>
           <a:prstGeom prst="rect">
             <a:avLst/>
@@ -3175,8 +3740,8 @@
         </p:nvSpPr>
         <p:spPr>
           <a:xfrm>
-            <a:off x="1417320" y="1600200"/>
-            <a:ext cx="6583680" cy="658368"/>
+            <a:off x="1417320" y="1554480"/>
+            <a:ext cx="6583680" cy="603504"/>
           </a:xfrm>
           <a:prstGeom prst="rect">
             <a:avLst/>
@@ -3200,7 +3765,7 @@
                 <a:ea typeface="Calibri" pitchFamily="34" charset="-122"/>
                 <a:cs typeface="Calibri" pitchFamily="34" charset="-120"/>
               </a:rPr>
-              <a:t>POST /roads überschreibt komplette FeatureCollection</a:t>
+              <a:t>POST / PUT / PATCH /roads überschreiben bzw. verändern Straßendaten</a:t>
             </a:r>
             <a:endParaRPr lang="en-US" sz="1550" dirty="0"/>
           </a:p>
@@ -3214,8 +3779,8 @@
         </p:nvSpPr>
         <p:spPr>
           <a:xfrm>
-            <a:off x="8092440" y="1600200"/>
-            <a:ext cx="1920240" cy="658368"/>
+            <a:off x="8092440" y="1554480"/>
+            <a:ext cx="1920240" cy="603504"/>
           </a:xfrm>
           <a:prstGeom prst="rect">
             <a:avLst/>
@@ -3253,7 +3818,7 @@
         </p:nvSpPr>
         <p:spPr>
           <a:xfrm>
-            <a:off x="10104120" y="1773936"/>
+            <a:off x="10104120" y="1700784"/>
             <a:ext cx="1371600" cy="310896"/>
           </a:xfrm>
           <a:prstGeom prst="roundRect">
@@ -3275,7 +3840,7 @@
         </p:nvSpPr>
         <p:spPr>
           <a:xfrm>
-            <a:off x="10104120" y="1773936"/>
+            <a:off x="10104120" y="1700784"/>
             <a:ext cx="1371600" cy="310896"/>
           </a:xfrm>
           <a:prstGeom prst="rect">
@@ -3314,8 +3879,8 @@
         </p:nvSpPr>
         <p:spPr>
           <a:xfrm>
-            <a:off x="548640" y="2359152"/>
-            <a:ext cx="11064240" cy="658368"/>
+            <a:off x="548640" y="2231136"/>
+            <a:ext cx="11064240" cy="603504"/>
           </a:xfrm>
           <a:prstGeom prst="roundRect">
             <a:avLst>
@@ -3341,8 +3906,8 @@
         </p:nvSpPr>
         <p:spPr>
           <a:xfrm>
-            <a:off x="713232" y="2359152"/>
-            <a:ext cx="548640" cy="658368"/>
+            <a:off x="713232" y="2231136"/>
+            <a:ext cx="548640" cy="603504"/>
           </a:xfrm>
           <a:prstGeom prst="rect">
             <a:avLst/>
@@ -3380,8 +3945,8 @@
         </p:nvSpPr>
         <p:spPr>
           <a:xfrm>
-            <a:off x="1417320" y="2359152"/>
-            <a:ext cx="6583680" cy="658368"/>
+            <a:off x="1417320" y="2231136"/>
+            <a:ext cx="6583680" cy="603504"/>
           </a:xfrm>
           <a:prstGeom prst="rect">
             <a:avLst/>
@@ -3405,7 +3970,7 @@
                 <a:ea typeface="Calibri" pitchFamily="34" charset="-122"/>
                 <a:cs typeface="Calibri" pitchFamily="34" charset="-120"/>
               </a:rPr>
-              <a:t>POST /todos ohne jede Eingabevalidierung</a:t>
+              <a:t>POST /todos ohne Eingabevalidierung (leer, Typ, road_fid-Bezug)</a:t>
             </a:r>
             <a:endParaRPr lang="en-US" sz="1550" dirty="0"/>
           </a:p>
@@ -3419,8 +3984,8 @@
         </p:nvSpPr>
         <p:spPr>
           <a:xfrm>
-            <a:off x="8092440" y="2359152"/>
-            <a:ext cx="1920240" cy="658368"/>
+            <a:off x="8092440" y="2231136"/>
+            <a:ext cx="1920240" cy="603504"/>
           </a:xfrm>
           <a:prstGeom prst="rect">
             <a:avLst/>
@@ -3444,7 +4009,7 @@
                 <a:ea typeface="Calibri" pitchFamily="34" charset="-122"/>
                 <a:cs typeface="Calibri" pitchFamily="34" charset="-120"/>
               </a:rPr>
-              <a:t>Test rot</a:t>
+              <a:t>Test rot (4×)</a:t>
             </a:r>
             <a:endParaRPr lang="en-US" sz="1100" dirty="0"/>
           </a:p>
@@ -3458,7 +4023,7 @@
         </p:nvSpPr>
         <p:spPr>
           <a:xfrm>
-            <a:off x="10104120" y="2532888"/>
+            <a:off x="10104120" y="2377440"/>
             <a:ext cx="1371600" cy="310896"/>
           </a:xfrm>
           <a:prstGeom prst="roundRect">
@@ -3480,7 +4045,7 @@
         </p:nvSpPr>
         <p:spPr>
           <a:xfrm>
-            <a:off x="10104120" y="2532888"/>
+            <a:off x="10104120" y="2377440"/>
             <a:ext cx="1371600" cy="310896"/>
           </a:xfrm>
           <a:prstGeom prst="rect">
@@ -3513,14 +4078,14 @@
       </p:sp>
       <p:sp>
         <p:nvSpPr>
-          <p:cNvPr id="16" name="Shape 2"/>
-          <p:cNvSpPr/>
-          <p:nvPr/>
-        </p:nvSpPr>
-        <p:spPr>
-          <a:xfrm>
-            <a:off x="548640" y="3118104"/>
-            <a:ext cx="11064240" cy="658368"/>
+          <p:cNvPr id="40" name="Shape 2"/>
+          <p:cNvSpPr/>
+          <p:nvPr/>
+        </p:nvSpPr>
+        <p:spPr>
+          <a:xfrm>
+            <a:off x="548640" y="2907792"/>
+            <a:ext cx="11064240" cy="603504"/>
           </a:xfrm>
           <a:prstGeom prst="roundRect">
             <a:avLst>
@@ -3540,14 +4105,14 @@
       </p:sp>
       <p:sp>
         <p:nvSpPr>
-          <p:cNvPr id="17" name="Text 3"/>
-          <p:cNvSpPr/>
-          <p:nvPr/>
-        </p:nvSpPr>
-        <p:spPr>
-          <a:xfrm>
-            <a:off x="713232" y="3118104"/>
-            <a:ext cx="548640" cy="658368"/>
+          <p:cNvPr id="41" name="Text 3"/>
+          <p:cNvSpPr/>
+          <p:nvPr/>
+        </p:nvSpPr>
+        <p:spPr>
+          <a:xfrm>
+            <a:off x="713232" y="2907792"/>
+            <a:ext cx="548640" cy="603504"/>
           </a:xfrm>
           <a:prstGeom prst="rect">
             <a:avLst/>
@@ -3565,13 +4130,13 @@
             <a:r>
               <a:rPr lang="en-US" sz="2200" b="1" dirty="0">
                 <a:solidFill>
-                  <a:srgbClr val="F1C40F"/>
+                  <a:srgbClr val="E67E22"/>
                 </a:solidFill>
                 <a:latin typeface="Cambria" pitchFamily="34" charset="0"/>
                 <a:ea typeface="Cambria" pitchFamily="34" charset="-122"/>
                 <a:cs typeface="Cambria" pitchFamily="34" charset="-120"/>
               </a:rPr>
-              <a:t>3</a:t>
+              <a:t>7</a:t>
             </a:r>
             <a:endParaRPr lang="en-US" sz="2200" dirty="0"/>
           </a:p>
@@ -3579,14 +4144,14 @@
       </p:sp>
       <p:sp>
         <p:nvSpPr>
-          <p:cNvPr id="18" name="Text 4"/>
-          <p:cNvSpPr/>
-          <p:nvPr/>
-        </p:nvSpPr>
-        <p:spPr>
-          <a:xfrm>
-            <a:off x="1417320" y="3118104"/>
-            <a:ext cx="6583680" cy="658368"/>
+          <p:cNvPr id="42" name="Text 4"/>
+          <p:cNvSpPr/>
+          <p:nvPr/>
+        </p:nvSpPr>
+        <p:spPr>
+          <a:xfrm>
+            <a:off x="1417320" y="2907792"/>
+            <a:ext cx="6583680" cy="603504"/>
           </a:xfrm>
           <a:prstGeom prst="rect">
             <a:avLst/>
@@ -3610,7 +4175,7 @@
                 <a:ea typeface="Calibri" pitchFamily="34" charset="-122"/>
                 <a:cs typeface="Calibri" pitchFamily="34" charset="-120"/>
               </a:rPr>
-              <a:t>Falscher Content-Type → Body still verworfen</a:t>
+              <a:t>PUT / PATCH /todos/:id ohne Validierung – PUT {} löscht alle Felder</a:t>
             </a:r>
             <a:endParaRPr lang="en-US" sz="1550" dirty="0"/>
           </a:p>
@@ -3618,14 +4183,14 @@
       </p:sp>
       <p:sp>
         <p:nvSpPr>
-          <p:cNvPr id="19" name="Text 4"/>
-          <p:cNvSpPr/>
-          <p:nvPr/>
-        </p:nvSpPr>
-        <p:spPr>
-          <a:xfrm>
-            <a:off x="8092440" y="3118104"/>
-            <a:ext cx="1920240" cy="658368"/>
+          <p:cNvPr id="43" name="Text 4"/>
+          <p:cNvSpPr/>
+          <p:nvPr/>
+        </p:nvSpPr>
+        <p:spPr>
+          <a:xfrm>
+            <a:off x="8092440" y="2907792"/>
+            <a:ext cx="1920240" cy="603504"/>
           </a:xfrm>
           <a:prstGeom prst="rect">
             <a:avLst/>
@@ -3649,7 +4214,7 @@
                 <a:ea typeface="Calibri" pitchFamily="34" charset="-122"/>
                 <a:cs typeface="Calibri" pitchFamily="34" charset="-120"/>
               </a:rPr>
-              <a:t>Test rot</a:t>
+              <a:t>Test rot (2×)</a:t>
             </a:r>
             <a:endParaRPr lang="en-US" sz="1100" dirty="0"/>
           </a:p>
@@ -3657,13 +4222,13 @@
       </p:sp>
       <p:sp>
         <p:nvSpPr>
-          <p:cNvPr id="20" name="Shape 5"/>
-          <p:cNvSpPr/>
-          <p:nvPr/>
-        </p:nvSpPr>
-        <p:spPr>
-          <a:xfrm>
-            <a:off x="10104120" y="3291840"/>
+          <p:cNvPr id="44" name="Shape 5"/>
+          <p:cNvSpPr/>
+          <p:nvPr/>
+        </p:nvSpPr>
+        <p:spPr>
+          <a:xfrm>
+            <a:off x="10104120" y="3054096"/>
             <a:ext cx="1371600" cy="310896"/>
           </a:xfrm>
           <a:prstGeom prst="roundRect">
@@ -3672,20 +4237,20 @@
             </a:avLst>
           </a:prstGeom>
           <a:solidFill>
-            <a:srgbClr val="F1C40F"/>
+            <a:srgbClr val="E67E22"/>
           </a:solidFill>
           <a:ln/>
         </p:spPr>
       </p:sp>
       <p:sp>
         <p:nvSpPr>
-          <p:cNvPr id="21" name="Text 6"/>
-          <p:cNvSpPr/>
-          <p:nvPr/>
-        </p:nvSpPr>
-        <p:spPr>
-          <a:xfrm>
-            <a:off x="10104120" y="3291840"/>
+          <p:cNvPr id="45" name="Text 6"/>
+          <p:cNvSpPr/>
+          <p:nvPr/>
+        </p:nvSpPr>
+        <p:spPr>
+          <a:xfrm>
+            <a:off x="10104120" y="3054096"/>
             <a:ext cx="1371600" cy="310896"/>
           </a:xfrm>
           <a:prstGeom prst="rect">
@@ -3710,7 +4275,7 @@
                 <a:ea typeface="Calibri" pitchFamily="34" charset="-122"/>
                 <a:cs typeface="Calibri" pitchFamily="34" charset="-120"/>
               </a:rPr>
-              <a:t>Mittel</a:t>
+              <a:t>Hoch</a:t>
             </a:r>
             <a:endParaRPr lang="en-US" sz="1100" dirty="0"/>
           </a:p>
@@ -3718,14 +4283,14 @@
       </p:sp>
       <p:sp>
         <p:nvSpPr>
-          <p:cNvPr id="22" name="Shape 2"/>
-          <p:cNvSpPr/>
-          <p:nvPr/>
-        </p:nvSpPr>
-        <p:spPr>
-          <a:xfrm>
-            <a:off x="548640" y="3877056"/>
-            <a:ext cx="11064240" cy="658368"/>
+          <p:cNvPr id="16" name="Shape 2"/>
+          <p:cNvSpPr/>
+          <p:nvPr/>
+        </p:nvSpPr>
+        <p:spPr>
+          <a:xfrm>
+            <a:off x="548640" y="3584448"/>
+            <a:ext cx="11064240" cy="603504"/>
           </a:xfrm>
           <a:prstGeom prst="roundRect">
             <a:avLst>
@@ -3745,14 +4310,14 @@
       </p:sp>
       <p:sp>
         <p:nvSpPr>
-          <p:cNvPr id="23" name="Text 3"/>
-          <p:cNvSpPr/>
-          <p:nvPr/>
-        </p:nvSpPr>
-        <p:spPr>
-          <a:xfrm>
-            <a:off x="713232" y="3877056"/>
-            <a:ext cx="548640" cy="658368"/>
+          <p:cNvPr id="17" name="Text 3"/>
+          <p:cNvSpPr/>
+          <p:nvPr/>
+        </p:nvSpPr>
+        <p:spPr>
+          <a:xfrm>
+            <a:off x="713232" y="3584448"/>
+            <a:ext cx="548640" cy="603504"/>
           </a:xfrm>
           <a:prstGeom prst="rect">
             <a:avLst/>
@@ -3770,13 +4335,13 @@
             <a:r>
               <a:rPr lang="en-US" sz="2200" b="1" dirty="0">
                 <a:solidFill>
-                  <a:srgbClr val="5D6D7E"/>
+                  <a:srgbClr val="F1C40F"/>
                 </a:solidFill>
                 <a:latin typeface="Cambria" pitchFamily="34" charset="0"/>
                 <a:ea typeface="Cambria" pitchFamily="34" charset="-122"/>
                 <a:cs typeface="Cambria" pitchFamily="34" charset="-120"/>
               </a:rPr>
-              <a:t>4</a:t>
+              <a:t>3</a:t>
             </a:r>
             <a:endParaRPr lang="en-US" sz="2200" dirty="0"/>
           </a:p>
@@ -3784,14 +4349,14 @@
       </p:sp>
       <p:sp>
         <p:nvSpPr>
-          <p:cNvPr id="24" name="Text 4"/>
-          <p:cNvSpPr/>
-          <p:nvPr/>
-        </p:nvSpPr>
-        <p:spPr>
-          <a:xfrm>
-            <a:off x="1417320" y="3877056"/>
-            <a:ext cx="6583680" cy="658368"/>
+          <p:cNvPr id="18" name="Text 4"/>
+          <p:cNvSpPr/>
+          <p:nvPr/>
+        </p:nvSpPr>
+        <p:spPr>
+          <a:xfrm>
+            <a:off x="1417320" y="3584448"/>
+            <a:ext cx="6583680" cy="603504"/>
           </a:xfrm>
           <a:prstGeom prst="rect">
             <a:avLst/>
@@ -3815,7 +4380,7 @@
                 <a:ea typeface="Calibri" pitchFamily="34" charset="-122"/>
                 <a:cs typeface="Calibri" pitchFamily="34" charset="-120"/>
               </a:rPr>
-              <a:t>PUT / PATCH / DELETE verfügbar, aber undokumentiert</a:t>
+              <a:t>Falscher Content-Type → Body still verworfen</a:t>
             </a:r>
             <a:endParaRPr lang="en-US" sz="1550" dirty="0"/>
           </a:p>
@@ -3823,14 +4388,14 @@
       </p:sp>
       <p:sp>
         <p:nvSpPr>
-          <p:cNvPr id="25" name="Text 4"/>
-          <p:cNvSpPr/>
-          <p:nvPr/>
-        </p:nvSpPr>
-        <p:spPr>
-          <a:xfrm>
-            <a:off x="8092440" y="3877056"/>
-            <a:ext cx="1920240" cy="658368"/>
+          <p:cNvPr id="19" name="Text 4"/>
+          <p:cNvSpPr/>
+          <p:nvPr/>
+        </p:nvSpPr>
+        <p:spPr>
+          <a:xfrm>
+            <a:off x="8092440" y="3584448"/>
+            <a:ext cx="1920240" cy="603504"/>
           </a:xfrm>
           <a:prstGeom prst="rect">
             <a:avLst/>
@@ -3846,15 +4411,15 @@
               <a:buNone/>
             </a:pPr>
             <a:r>
-              <a:rPr lang="en-US" sz="1100" i="1" dirty="0">
-                <a:solidFill>
-                  <a:srgbClr val="5A6483"/>
-                </a:solidFill>
-                <a:latin typeface="Calibri" pitchFamily="34" charset="0"/>
-                <a:ea typeface="Calibri" pitchFamily="34" charset="-122"/>
-                <a:cs typeface="Calibri" pitchFamily="34" charset="-120"/>
-              </a:rPr>
-              <a:t>Doku-Lücke · grün</a:t>
+              <a:rPr lang="en-US" sz="1100" b="1" dirty="0">
+                <a:solidFill>
+                  <a:srgbClr val="C0392B"/>
+                </a:solidFill>
+                <a:latin typeface="Calibri" pitchFamily="34" charset="0"/>
+                <a:ea typeface="Calibri" pitchFamily="34" charset="-122"/>
+                <a:cs typeface="Calibri" pitchFamily="34" charset="-120"/>
+              </a:rPr>
+              <a:t>Test rot</a:t>
             </a:r>
             <a:endParaRPr lang="en-US" sz="1100" dirty="0"/>
           </a:p>
@@ -3862,13 +4427,13 @@
       </p:sp>
       <p:sp>
         <p:nvSpPr>
-          <p:cNvPr id="26" name="Shape 5"/>
-          <p:cNvSpPr/>
-          <p:nvPr/>
-        </p:nvSpPr>
-        <p:spPr>
-          <a:xfrm>
-            <a:off x="10104120" y="4050792"/>
+          <p:cNvPr id="20" name="Shape 5"/>
+          <p:cNvSpPr/>
+          <p:nvPr/>
+        </p:nvSpPr>
+        <p:spPr>
+          <a:xfrm>
+            <a:off x="10104120" y="3730752"/>
             <a:ext cx="1371600" cy="310896"/>
           </a:xfrm>
           <a:prstGeom prst="roundRect">
@@ -3877,20 +4442,20 @@
             </a:avLst>
           </a:prstGeom>
           <a:solidFill>
-            <a:srgbClr val="5D6D7E"/>
+            <a:srgbClr val="F1C40F"/>
           </a:solidFill>
           <a:ln/>
         </p:spPr>
       </p:sp>
       <p:sp>
         <p:nvSpPr>
-          <p:cNvPr id="27" name="Text 6"/>
-          <p:cNvSpPr/>
-          <p:nvPr/>
-        </p:nvSpPr>
-        <p:spPr>
-          <a:xfrm>
-            <a:off x="10104120" y="4050792"/>
+          <p:cNvPr id="21" name="Text 6"/>
+          <p:cNvSpPr/>
+          <p:nvPr/>
+        </p:nvSpPr>
+        <p:spPr>
+          <a:xfrm>
+            <a:off x="10104120" y="3730752"/>
             <a:ext cx="1371600" cy="310896"/>
           </a:xfrm>
           <a:prstGeom prst="rect">
@@ -3915,7 +4480,7 @@
                 <a:ea typeface="Calibri" pitchFamily="34" charset="-122"/>
                 <a:cs typeface="Calibri" pitchFamily="34" charset="-120"/>
               </a:rPr>
-              <a:t>Niedrig</a:t>
+              <a:t>Mittel</a:t>
             </a:r>
             <a:endParaRPr lang="en-US" sz="1100" dirty="0"/>
           </a:p>
@@ -3923,14 +4488,14 @@
       </p:sp>
       <p:sp>
         <p:nvSpPr>
-          <p:cNvPr id="28" name="Shape 2"/>
-          <p:cNvSpPr/>
-          <p:nvPr/>
-        </p:nvSpPr>
-        <p:spPr>
-          <a:xfrm>
-            <a:off x="548640" y="4636008"/>
-            <a:ext cx="11064240" cy="658368"/>
+          <p:cNvPr id="22" name="Shape 2"/>
+          <p:cNvSpPr/>
+          <p:nvPr/>
+        </p:nvSpPr>
+        <p:spPr>
+          <a:xfrm>
+            <a:off x="548640" y="4261104"/>
+            <a:ext cx="11064240" cy="603504"/>
           </a:xfrm>
           <a:prstGeom prst="roundRect">
             <a:avLst>
@@ -3950,14 +4515,14 @@
       </p:sp>
       <p:sp>
         <p:nvSpPr>
-          <p:cNvPr id="29" name="Text 3"/>
-          <p:cNvSpPr/>
-          <p:nvPr/>
-        </p:nvSpPr>
-        <p:spPr>
-          <a:xfrm>
-            <a:off x="713232" y="4636008"/>
-            <a:ext cx="548640" cy="658368"/>
+          <p:cNvPr id="23" name="Text 3"/>
+          <p:cNvSpPr/>
+          <p:nvPr/>
+        </p:nvSpPr>
+        <p:spPr>
+          <a:xfrm>
+            <a:off x="713232" y="4261104"/>
+            <a:ext cx="548640" cy="603504"/>
           </a:xfrm>
           <a:prstGeom prst="rect">
             <a:avLst/>
@@ -3981,7 +4546,7 @@
                 <a:ea typeface="Cambria" pitchFamily="34" charset="-122"/>
                 <a:cs typeface="Cambria" pitchFamily="34" charset="-120"/>
               </a:rPr>
-              <a:t>5</a:t>
+              <a:t>4</a:t>
             </a:r>
             <a:endParaRPr lang="en-US" sz="2200" dirty="0"/>
           </a:p>
@@ -3989,14 +4554,14 @@
       </p:sp>
       <p:sp>
         <p:nvSpPr>
-          <p:cNvPr id="30" name="Text 4"/>
-          <p:cNvSpPr/>
-          <p:nvPr/>
-        </p:nvSpPr>
-        <p:spPr>
-          <a:xfrm>
-            <a:off x="1417320" y="4636008"/>
-            <a:ext cx="6583680" cy="658368"/>
+          <p:cNvPr id="24" name="Text 4"/>
+          <p:cNvSpPr/>
+          <p:nvPr/>
+        </p:nvSpPr>
+        <p:spPr>
+          <a:xfrm>
+            <a:off x="1417320" y="4261104"/>
+            <a:ext cx="6583680" cy="603504"/>
           </a:xfrm>
           <a:prstGeom prst="rect">
             <a:avLst/>
@@ -4020,7 +4585,7 @@
                 <a:ea typeface="Calibri" pitchFamily="34" charset="-122"/>
                 <a:cs typeface="Calibri" pitchFamily="34" charset="-120"/>
               </a:rPr>
-              <a:t>Schwache Fehlersemantik (500 statt 409, HTML statt JSON)</a:t>
+              <a:t>PUT / PATCH / DELETE verfügbar, aber undokumentiert</a:t>
             </a:r>
             <a:endParaRPr lang="en-US" sz="1550" dirty="0"/>
           </a:p>
@@ -4028,14 +4593,14 @@
       </p:sp>
       <p:sp>
         <p:nvSpPr>
-          <p:cNvPr id="31" name="Text 4"/>
-          <p:cNvSpPr/>
-          <p:nvPr/>
-        </p:nvSpPr>
-        <p:spPr>
-          <a:xfrm>
-            <a:off x="8092440" y="4636008"/>
-            <a:ext cx="1920240" cy="658368"/>
+          <p:cNvPr id="25" name="Text 4"/>
+          <p:cNvSpPr/>
+          <p:nvPr/>
+        </p:nvSpPr>
+        <p:spPr>
+          <a:xfrm>
+            <a:off x="8092440" y="4261104"/>
+            <a:ext cx="1920240" cy="603504"/>
           </a:xfrm>
           <a:prstGeom prst="rect">
             <a:avLst/>
@@ -4051,15 +4616,15 @@
               <a:buNone/>
             </a:pPr>
             <a:r>
-              <a:rPr lang="en-US" sz="1100" b="1" dirty="0">
-                <a:solidFill>
-                  <a:srgbClr val="C0392B"/>
-                </a:solidFill>
-                <a:latin typeface="Calibri" pitchFamily="34" charset="0"/>
-                <a:ea typeface="Calibri" pitchFamily="34" charset="-122"/>
-                <a:cs typeface="Calibri" pitchFamily="34" charset="-120"/>
-              </a:rPr>
-              <a:t>Test rot (2×)</a:t>
+              <a:rPr lang="en-US" sz="1100" i="1" dirty="0">
+                <a:solidFill>
+                  <a:srgbClr val="5A6483"/>
+                </a:solidFill>
+                <a:latin typeface="Calibri" pitchFamily="34" charset="0"/>
+                <a:ea typeface="Calibri" pitchFamily="34" charset="-122"/>
+                <a:cs typeface="Calibri" pitchFamily="34" charset="-120"/>
+              </a:rPr>
+              <a:t>Doku-Lücke · grün</a:t>
             </a:r>
             <a:endParaRPr lang="en-US" sz="1100" dirty="0"/>
           </a:p>
@@ -4067,13 +4632,13 @@
       </p:sp>
       <p:sp>
         <p:nvSpPr>
-          <p:cNvPr id="32" name="Shape 5"/>
-          <p:cNvSpPr/>
-          <p:nvPr/>
-        </p:nvSpPr>
-        <p:spPr>
-          <a:xfrm>
-            <a:off x="10104120" y="4809744"/>
+          <p:cNvPr id="26" name="Shape 5"/>
+          <p:cNvSpPr/>
+          <p:nvPr/>
+        </p:nvSpPr>
+        <p:spPr>
+          <a:xfrm>
+            <a:off x="10104120" y="4407408"/>
             <a:ext cx="1371600" cy="310896"/>
           </a:xfrm>
           <a:prstGeom prst="roundRect">
@@ -4089,13 +4654,13 @@
       </p:sp>
       <p:sp>
         <p:nvSpPr>
-          <p:cNvPr id="33" name="Text 6"/>
-          <p:cNvSpPr/>
-          <p:nvPr/>
-        </p:nvSpPr>
-        <p:spPr>
-          <a:xfrm>
-            <a:off x="10104120" y="4809744"/>
+          <p:cNvPr id="27" name="Text 6"/>
+          <p:cNvSpPr/>
+          <p:nvPr/>
+        </p:nvSpPr>
+        <p:spPr>
+          <a:xfrm>
+            <a:off x="10104120" y="4407408"/>
             <a:ext cx="1371600" cy="310896"/>
           </a:xfrm>
           <a:prstGeom prst="rect">
@@ -4128,14 +4693,14 @@
       </p:sp>
       <p:sp>
         <p:nvSpPr>
-          <p:cNvPr id="34" name="Shape 2"/>
-          <p:cNvSpPr/>
-          <p:nvPr/>
-        </p:nvSpPr>
-        <p:spPr>
-          <a:xfrm>
-            <a:off x="548640" y="5394960"/>
-            <a:ext cx="11064240" cy="658368"/>
+          <p:cNvPr id="28" name="Shape 2"/>
+          <p:cNvSpPr/>
+          <p:nvPr/>
+        </p:nvSpPr>
+        <p:spPr>
+          <a:xfrm>
+            <a:off x="548640" y="4937760"/>
+            <a:ext cx="11064240" cy="603504"/>
           </a:xfrm>
           <a:prstGeom prst="roundRect">
             <a:avLst>
@@ -4155,14 +4720,14 @@
       </p:sp>
       <p:sp>
         <p:nvSpPr>
-          <p:cNvPr id="35" name="Text 3"/>
-          <p:cNvSpPr/>
-          <p:nvPr/>
-        </p:nvSpPr>
-        <p:spPr>
-          <a:xfrm>
-            <a:off x="713232" y="5394960"/>
-            <a:ext cx="548640" cy="658368"/>
+          <p:cNvPr id="29" name="Text 3"/>
+          <p:cNvSpPr/>
+          <p:nvPr/>
+        </p:nvSpPr>
+        <p:spPr>
+          <a:xfrm>
+            <a:off x="713232" y="4937760"/>
+            <a:ext cx="548640" cy="603504"/>
           </a:xfrm>
           <a:prstGeom prst="rect">
             <a:avLst/>
@@ -4186,7 +4751,7 @@
                 <a:ea typeface="Cambria" pitchFamily="34" charset="-122"/>
                 <a:cs typeface="Cambria" pitchFamily="34" charset="-120"/>
               </a:rPr>
-              <a:t>6</a:t>
+              <a:t>5</a:t>
             </a:r>
             <a:endParaRPr lang="en-US" sz="2200" dirty="0"/>
           </a:p>
@@ -4194,14 +4759,14 @@
       </p:sp>
       <p:sp>
         <p:nvSpPr>
-          <p:cNvPr id="36" name="Text 4"/>
-          <p:cNvSpPr/>
-          <p:nvPr/>
-        </p:nvSpPr>
-        <p:spPr>
-          <a:xfrm>
-            <a:off x="1417320" y="5394960"/>
-            <a:ext cx="6583680" cy="658368"/>
+          <p:cNvPr id="30" name="Text 4"/>
+          <p:cNvSpPr/>
+          <p:nvPr/>
+        </p:nvSpPr>
+        <p:spPr>
+          <a:xfrm>
+            <a:off x="1417320" y="4937760"/>
+            <a:ext cx="6583680" cy="603504"/>
           </a:xfrm>
           <a:prstGeom prst="rect">
             <a:avLst/>
@@ -4225,7 +4790,7 @@
                 <a:ea typeface="Calibri" pitchFamily="34" charset="-122"/>
                 <a:cs typeface="Calibri" pitchFamily="34" charset="-120"/>
               </a:rPr>
-              <a:t>/roads: Filter/Sort/Pagination wirkungslos</a:t>
+              <a:t>Schwache Fehlersemantik (500 statt 409, HTML statt JSON)</a:t>
             </a:r>
             <a:endParaRPr lang="en-US" sz="1550" dirty="0"/>
           </a:p>
@@ -4233,14 +4798,14 @@
       </p:sp>
       <p:sp>
         <p:nvSpPr>
-          <p:cNvPr id="37" name="Text 4"/>
-          <p:cNvSpPr/>
-          <p:nvPr/>
-        </p:nvSpPr>
-        <p:spPr>
-          <a:xfrm>
-            <a:off x="8092440" y="5394960"/>
-            <a:ext cx="1920240" cy="658368"/>
+          <p:cNvPr id="31" name="Text 4"/>
+          <p:cNvSpPr/>
+          <p:nvPr/>
+        </p:nvSpPr>
+        <p:spPr>
+          <a:xfrm>
+            <a:off x="8092440" y="4937760"/>
+            <a:ext cx="1920240" cy="603504"/>
           </a:xfrm>
           <a:prstGeom prst="rect">
             <a:avLst/>
@@ -4256,15 +4821,15 @@
               <a:buNone/>
             </a:pPr>
             <a:r>
-              <a:rPr lang="en-US" sz="1100" i="1" dirty="0">
-                <a:solidFill>
-                  <a:srgbClr val="5A6483"/>
-                </a:solidFill>
-                <a:latin typeface="Calibri" pitchFamily="34" charset="0"/>
-                <a:ea typeface="Calibri" pitchFamily="34" charset="-122"/>
-                <a:cs typeface="Calibri" pitchFamily="34" charset="-120"/>
-              </a:rPr>
-              <a:t>Limitierung · grün</a:t>
+              <a:rPr lang="en-US" sz="1100" b="1" dirty="0">
+                <a:solidFill>
+                  <a:srgbClr val="C0392B"/>
+                </a:solidFill>
+                <a:latin typeface="Calibri" pitchFamily="34" charset="0"/>
+                <a:ea typeface="Calibri" pitchFamily="34" charset="-122"/>
+                <a:cs typeface="Calibri" pitchFamily="34" charset="-120"/>
+              </a:rPr>
+              <a:t>Test rot (2×)</a:t>
             </a:r>
             <a:endParaRPr lang="en-US" sz="1100" dirty="0"/>
           </a:p>
@@ -4272,13 +4837,13 @@
       </p:sp>
       <p:sp>
         <p:nvSpPr>
-          <p:cNvPr id="38" name="Shape 5"/>
-          <p:cNvSpPr/>
-          <p:nvPr/>
-        </p:nvSpPr>
-        <p:spPr>
-          <a:xfrm>
-            <a:off x="10104120" y="5568696"/>
+          <p:cNvPr id="32" name="Shape 5"/>
+          <p:cNvSpPr/>
+          <p:nvPr/>
+        </p:nvSpPr>
+        <p:spPr>
+          <a:xfrm>
+            <a:off x="10104120" y="5084064"/>
             <a:ext cx="1371600" cy="310896"/>
           </a:xfrm>
           <a:prstGeom prst="roundRect">
@@ -4294,13 +4859,218 @@
       </p:sp>
       <p:sp>
         <p:nvSpPr>
+          <p:cNvPr id="33" name="Text 6"/>
+          <p:cNvSpPr/>
+          <p:nvPr/>
+        </p:nvSpPr>
+        <p:spPr>
+          <a:xfrm>
+            <a:off x="10104120" y="5084064"/>
+            <a:ext cx="1371600" cy="310896"/>
+          </a:xfrm>
+          <a:prstGeom prst="rect">
+            <a:avLst/>
+          </a:prstGeom>
+          <a:noFill/>
+          <a:ln/>
+        </p:spPr>
+        <p:txBody>
+          <a:bodyPr wrap="square" lIns="0" tIns="0" rIns="0" bIns="0" rtlCol="0" anchor="ctr"/>
+          <a:lstStyle/>
+          <a:p>
+            <a:pPr algn="ctr" indent="0" marL="0">
+              <a:buNone/>
+            </a:pPr>
+            <a:r>
+              <a:rPr lang="en-US" sz="1100" b="1" dirty="0">
+                <a:solidFill>
+                  <a:srgbClr val="FFFFFF"/>
+                </a:solidFill>
+                <a:latin typeface="Calibri" pitchFamily="34" charset="0"/>
+                <a:ea typeface="Calibri" pitchFamily="34" charset="-122"/>
+                <a:cs typeface="Calibri" pitchFamily="34" charset="-120"/>
+              </a:rPr>
+              <a:t>Niedrig</a:t>
+            </a:r>
+            <a:endParaRPr lang="en-US" sz="1100" dirty="0"/>
+          </a:p>
+        </p:txBody>
+      </p:sp>
+      <p:sp>
+        <p:nvSpPr>
+          <p:cNvPr id="34" name="Shape 2"/>
+          <p:cNvSpPr/>
+          <p:nvPr/>
+        </p:nvSpPr>
+        <p:spPr>
+          <a:xfrm>
+            <a:off x="548640" y="5614416"/>
+            <a:ext cx="11064240" cy="603504"/>
+          </a:xfrm>
+          <a:prstGeom prst="roundRect">
+            <a:avLst>
+              <a:gd name="adj" fmla="val 8333"/>
+            </a:avLst>
+          </a:prstGeom>
+          <a:solidFill>
+            <a:srgbClr val="F4F6FC"/>
+          </a:solidFill>
+          <a:ln w="12700">
+            <a:solidFill>
+              <a:srgbClr val="E3E8F5"/>
+            </a:solidFill>
+            <a:prstDash val="solid"/>
+          </a:ln>
+        </p:spPr>
+      </p:sp>
+      <p:sp>
+        <p:nvSpPr>
+          <p:cNvPr id="35" name="Text 3"/>
+          <p:cNvSpPr/>
+          <p:nvPr/>
+        </p:nvSpPr>
+        <p:spPr>
+          <a:xfrm>
+            <a:off x="713232" y="5614416"/>
+            <a:ext cx="548640" cy="603504"/>
+          </a:xfrm>
+          <a:prstGeom prst="rect">
+            <a:avLst/>
+          </a:prstGeom>
+          <a:noFill/>
+          <a:ln/>
+        </p:spPr>
+        <p:txBody>
+          <a:bodyPr wrap="square" lIns="0" tIns="0" rIns="0" bIns="0" rtlCol="0" anchor="ctr"/>
+          <a:lstStyle/>
+          <a:p>
+            <a:pPr algn="ctr" indent="0" marL="0">
+              <a:buNone/>
+            </a:pPr>
+            <a:r>
+              <a:rPr lang="en-US" sz="2200" b="1" dirty="0">
+                <a:solidFill>
+                  <a:srgbClr val="5D6D7E"/>
+                </a:solidFill>
+                <a:latin typeface="Cambria" pitchFamily="34" charset="0"/>
+                <a:ea typeface="Cambria" pitchFamily="34" charset="-122"/>
+                <a:cs typeface="Cambria" pitchFamily="34" charset="-120"/>
+              </a:rPr>
+              <a:t>6</a:t>
+            </a:r>
+            <a:endParaRPr lang="en-US" sz="2200" dirty="0"/>
+          </a:p>
+        </p:txBody>
+      </p:sp>
+      <p:sp>
+        <p:nvSpPr>
+          <p:cNvPr id="36" name="Text 4"/>
+          <p:cNvSpPr/>
+          <p:nvPr/>
+        </p:nvSpPr>
+        <p:spPr>
+          <a:xfrm>
+            <a:off x="1417320" y="5614416"/>
+            <a:ext cx="6583680" cy="603504"/>
+          </a:xfrm>
+          <a:prstGeom prst="rect">
+            <a:avLst/>
+          </a:prstGeom>
+          <a:noFill/>
+          <a:ln/>
+        </p:spPr>
+        <p:txBody>
+          <a:bodyPr wrap="square" lIns="0" tIns="0" rIns="0" bIns="0" rtlCol="0" anchor="ctr"/>
+          <a:lstStyle/>
+          <a:p>
+            <a:pPr indent="0" marL="0">
+              <a:buNone/>
+            </a:pPr>
+            <a:r>
+              <a:rPr lang="en-US" sz="1550" dirty="0">
+                <a:solidFill>
+                  <a:srgbClr val="1B2340"/>
+                </a:solidFill>
+                <a:latin typeface="Calibri" pitchFamily="34" charset="0"/>
+                <a:ea typeface="Calibri" pitchFamily="34" charset="-122"/>
+                <a:cs typeface="Calibri" pitchFamily="34" charset="-120"/>
+              </a:rPr>
+              <a:t>/roads: Filter/Sort/Pagination wirkungslos</a:t>
+            </a:r>
+            <a:endParaRPr lang="en-US" sz="1550" dirty="0"/>
+          </a:p>
+        </p:txBody>
+      </p:sp>
+      <p:sp>
+        <p:nvSpPr>
+          <p:cNvPr id="37" name="Text 4"/>
+          <p:cNvSpPr/>
+          <p:nvPr/>
+        </p:nvSpPr>
+        <p:spPr>
+          <a:xfrm>
+            <a:off x="8092440" y="5614416"/>
+            <a:ext cx="1920240" cy="603504"/>
+          </a:xfrm>
+          <a:prstGeom prst="rect">
+            <a:avLst/>
+          </a:prstGeom>
+          <a:noFill/>
+          <a:ln/>
+        </p:spPr>
+        <p:txBody>
+          <a:bodyPr wrap="square" lIns="0" tIns="0" rIns="0" bIns="0" rtlCol="0" anchor="ctr"/>
+          <a:lstStyle/>
+          <a:p>
+            <a:pPr indent="0" marL="0">
+              <a:buNone/>
+            </a:pPr>
+            <a:r>
+              <a:rPr lang="en-US" sz="1100" i="1" dirty="0">
+                <a:solidFill>
+                  <a:srgbClr val="5A6483"/>
+                </a:solidFill>
+                <a:latin typeface="Calibri" pitchFamily="34" charset="0"/>
+                <a:ea typeface="Calibri" pitchFamily="34" charset="-122"/>
+                <a:cs typeface="Calibri" pitchFamily="34" charset="-120"/>
+              </a:rPr>
+              <a:t>Limitierung · grün</a:t>
+            </a:r>
+            <a:endParaRPr lang="en-US" sz="1100" dirty="0"/>
+          </a:p>
+        </p:txBody>
+      </p:sp>
+      <p:sp>
+        <p:nvSpPr>
+          <p:cNvPr id="38" name="Shape 5"/>
+          <p:cNvSpPr/>
+          <p:nvPr/>
+        </p:nvSpPr>
+        <p:spPr>
+          <a:xfrm>
+            <a:off x="10104120" y="5760720"/>
+            <a:ext cx="1371600" cy="310896"/>
+          </a:xfrm>
+          <a:prstGeom prst="roundRect">
+            <a:avLst>
+              <a:gd name="adj" fmla="val 50000"/>
+            </a:avLst>
+          </a:prstGeom>
+          <a:solidFill>
+            <a:srgbClr val="5D6D7E"/>
+          </a:solidFill>
+          <a:ln/>
+        </p:spPr>
+      </p:sp>
+      <p:sp>
+        <p:nvSpPr>
           <p:cNvPr id="39" name="Text 6"/>
           <p:cNvSpPr/>
           <p:nvPr/>
         </p:nvSpPr>
         <p:spPr>
           <a:xfrm>
-            <a:off x="10104120" y="5568696"/>
+            <a:off x="10104120" y="5760720"/>
             <a:ext cx="1371600" cy="310896"/>
           </a:xfrm>
           <a:prstGeom prst="rect">
@@ -4496,7 +5266,7 @@
                 <a:ea typeface="Cambria" pitchFamily="34" charset="-122"/>
                 <a:cs typeface="Cambria" pitchFamily="34" charset="-120"/>
               </a:rPr>
-              <a:t>POST /roads zerstört alle Straßendaten</a:t>
+              <a:t>POST / PUT /roads zerstören alle Straßendaten</a:t>
             </a:r>
             <a:endParaRPr lang="en-US" sz="3400" dirty="0"/>
           </a:p>
@@ -4696,7 +5466,7 @@
                 <a:ea typeface="Calibri" pitchFamily="34" charset="-122"/>
                 <a:cs typeface="Calibri" pitchFamily="34" charset="-120"/>
               </a:rPr>
-              <a:t>201 – gesamte FeatureCollection überschrieben, alle 773 Straßen weg (kein Append, kein Merge)</a:t>
+              <a:t>POST 201 / PUT 200 – FeatureCollection überschrieben, alle 773 Straßen weg. PATCH 200 – Felder hineingemischt</a:t>
             </a:r>
             <a:endParaRPr lang="en-US" sz="1300" dirty="0"/>
           </a:p>
@@ -5263,7 +6033,7 @@
                 <a:ea typeface="Calibri" pitchFamily="34" charset="-122"/>
                 <a:cs typeface="Calibri" pitchFamily="34" charset="-120"/>
               </a:rPr>
-              <a:t>kein title, kein road_fid – trotzdem 201</a:t>
+              <a:t>{}, leerer title, road_fid "abc" – trotzdem 201</a:t>
             </a:r>
             <a:endParaRPr lang="en-US" sz="1350" dirty="0"/>
           </a:p>
@@ -5284,7 +6054,7 @@
                 <a:ea typeface="Calibri" pitchFamily="34" charset="-122"/>
                 <a:cs typeface="Calibri" pitchFamily="34" charset="-120"/>
               </a:rPr>
-              <a:t>road_fid ist Pflichtbezug (Anforderung 7)</a:t>
+              <a:t>road_fid 999999 (Straße fehlt) – trotzdem 201</a:t>
             </a:r>
             <a:endParaRPr lang="en-US" sz="1350" dirty="0"/>
           </a:p>
@@ -5302,7 +6072,7 @@
                 <a:ea typeface="Calibri" pitchFamily="34" charset="-122"/>
                 <a:cs typeface="Calibri" pitchFamily="34" charset="-120"/>
               </a:rPr>
-              <a:t>[DEFECT #2]: Soll 400 → Test rot</a:t>
+              <a:t>[DEFECT #2]: Soll 400 / 422 → 4 Tests rot</a:t>
             </a:r>
             <a:endParaRPr lang="en-US" sz="1350" dirty="0"/>
           </a:p>
@@ -6144,7 +6914,7 @@
                 <a:ea typeface="Calibri" pitchFamily="34" charset="-122"/>
                 <a:cs typeface="Calibri" pitchFamily="34" charset="-120"/>
               </a:rPr>
-              <a:t>Doku nennt nur GET / POST – die Todos-Seite des Frontends hängt aber an diesen undokumentierten Endpunkten. Doku-Lücke, kein API-Fehler → Tests grün.</a:t>
+              <a:t>Doku nennt nur GET / POST – die Todos-Seite des Frontends hängt aber an diesen undokumentierten Endpunkten. Mit gültigem Body korrekt → Tests grün; fehlende Validierung siehe #7.</a:t>
             </a:r>
             <a:endParaRPr lang="en-US" sz="1300" dirty="0"/>
           </a:p>
@@ -6803,7 +7573,7 @@
                 <a:ea typeface="Calibri" pitchFamily="34" charset="-122"/>
                 <a:cs typeface="Calibri" pitchFamily="34" charset="-120"/>
               </a:rPr>
-              <a:t>Positiv-Belege – korrekt verifiziert</a:t>
+              <a:t>Positiv-Belege je Endpunkt, per Newman verifiziert · Filter, Sortierung &amp; Pagination gelten nur für /todos (nicht /roads, #6)</a:t>
             </a:r>
             <a:endParaRPr lang="en-US" sz="1400" dirty="0"/>
           </a:p>
@@ -6928,7 +7698,7 @@
                 <a:ea typeface="Calibri" pitchFamily="34" charset="-122"/>
                 <a:cs typeface="Calibri" pitchFamily="34" charset="-120"/>
               </a:rPr>
-              <a:t>Filter &amp; Operatoren</a:t>
+              <a:t>GET /roads – Lesen</a:t>
             </a:r>
             <a:endParaRPr lang="en-US" sz="1650" dirty="0"/>
           </a:p>
@@ -6967,7 +7737,7 @@
                 <a:ea typeface="Calibri" pitchFamily="34" charset="-122"/>
                 <a:cs typeface="Calibri" pitchFamily="34" charset="-120"/>
               </a:rPr>
-              <a:t>?feld=, _gte, _like – exakt &amp; korrekt</a:t>
+              <a:t>200, gültige FeatureCollection mit allen 773 Straßen</a:t>
             </a:r>
             <a:endParaRPr lang="en-US" sz="1250" dirty="0"/>
           </a:p>
@@ -7092,7 +7862,7 @@
                 <a:ea typeface="Calibri" pitchFamily="34" charset="-122"/>
                 <a:cs typeface="Calibri" pitchFamily="34" charset="-120"/>
               </a:rPr>
-              <a:t>Volltextsuche</a:t>
+              <a:t>GET /todos – Filter &amp; Suche</a:t>
             </a:r>
             <a:endParaRPr lang="en-US" sz="1650" dirty="0"/>
           </a:p>
@@ -7131,7 +7901,7 @@
                 <a:ea typeface="Calibri" pitchFamily="34" charset="-122"/>
                 <a:cs typeface="Calibri" pitchFamily="34" charset="-120"/>
               </a:rPr>
-              <a:t>?q= durchsucht alle Felder</a:t>
+              <a:t>?status=, ?road_fid=, _gte, _like, Volltext ?q= – exakt &amp; korrekt</a:t>
             </a:r>
             <a:endParaRPr lang="en-US" sz="1250" dirty="0"/>
           </a:p>
@@ -7256,7 +8026,7 @@
                 <a:ea typeface="Calibri" pitchFamily="34" charset="-122"/>
                 <a:cs typeface="Calibri" pitchFamily="34" charset="-120"/>
               </a:rPr>
-              <a:t>Sortierung</a:t>
+              <a:t>GET /todos – Sortierung &amp; Pagination</a:t>
             </a:r>
             <a:endParaRPr lang="en-US" sz="1650" dirty="0"/>
           </a:p>
@@ -7295,7 +8065,7 @@
                 <a:ea typeface="Calibri" pitchFamily="34" charset="-122"/>
                 <a:cs typeface="Calibri" pitchFamily="34" charset="-120"/>
               </a:rPr>
-              <a:t>_sort / _order aufsteigend &amp; absteigend</a:t>
+              <a:t>_sort / _order, _page / _limit mit X-Total-Count &amp; Link, _start / _end</a:t>
             </a:r>
             <a:endParaRPr lang="en-US" sz="1250" dirty="0"/>
           </a:p>
@@ -7420,7 +8190,7 @@
                 <a:ea typeface="Calibri" pitchFamily="34" charset="-122"/>
                 <a:cs typeface="Calibri" pitchFamily="34" charset="-120"/>
               </a:rPr>
-              <a:t>Pagination</a:t>
+              <a:t>POST /todos – Anlegen</a:t>
             </a:r>
             <a:endParaRPr lang="en-US" sz="1650" dirty="0"/>
           </a:p>
@@ -7459,7 +8229,7 @@
                 <a:ea typeface="Calibri" pitchFamily="34" charset="-122"/>
                 <a:cs typeface="Calibri" pitchFamily="34" charset="-120"/>
               </a:rPr>
-              <a:t>_page / _limit mit X-Total-Count &amp; Link-Header</a:t>
+              <a:t>201, Location-Header, Auto-Increment-ID; danach per GET lesbar, per DELETE löschbar</a:t>
             </a:r>
             <a:endParaRPr lang="en-US" sz="1250" dirty="0"/>
           </a:p>
@@ -7584,7 +8354,7 @@
                 <a:ea typeface="Calibri" pitchFamily="34" charset="-122"/>
                 <a:cs typeface="Calibri" pitchFamily="34" charset="-120"/>
               </a:rPr>
-              <a:t>POST Happy Path</a:t>
+              <a:t>PUT / PATCH / DELETE /todos/:id</a:t>
             </a:r>
             <a:endParaRPr lang="en-US" sz="1650" dirty="0"/>
           </a:p>
@@ -7623,7 +8393,7 @@
                 <a:ea typeface="Calibri" pitchFamily="34" charset="-122"/>
                 <a:cs typeface="Calibri" pitchFamily="34" charset="-120"/>
               </a:rPr>
-              <a:t>201, Location-Header, Auto-Increment-ID</a:t>
+              <a:t>Mit gültigem Body korrekt: ersetzen, teilweise ändern, löschen (undokumentiert, #4)</a:t>
             </a:r>
             <a:endParaRPr lang="en-US" sz="1250" dirty="0"/>
           </a:p>
@@ -7748,7 +8518,7 @@
                 <a:ea typeface="Calibri" pitchFamily="34" charset="-122"/>
                 <a:cs typeface="Calibri" pitchFamily="34" charset="-120"/>
               </a:rPr>
-              <a:t>Fehler-Routen</a:t>
+              <a:t>404 für Unbekanntes</a:t>
             </a:r>
             <a:endParaRPr lang="en-US" sz="1650" dirty="0"/>
           </a:p>
@@ -7787,7 +8557,7 @@
                 <a:ea typeface="Calibri" pitchFamily="34" charset="-122"/>
                 <a:cs typeface="Calibri" pitchFamily="34" charset="-120"/>
               </a:rPr>
-              <a:t>Unbekannte Route &amp; gelöschte ID → 404</a:t>
+              <a:t>GET /nonexistent, /todos/999999, gelöschte ID; PUT /todos/888888 legt nichts an</a:t>
             </a:r>
             <a:endParaRPr lang="en-US" sz="1250" dirty="0"/>
           </a:p>
@@ -8017,7 +8787,7 @@
                 <a:ea typeface="Calibri" pitchFamily="34" charset="-122"/>
                 <a:cs typeface="Calibri" pitchFamily="34" charset="-120"/>
               </a:rPr>
-              <a:t>Schreiben auf /roads sperren; CORS vor Go-Live auf die App-Origin begrenzen (#1).</a:t>
+              <a:t>POST / PUT / PATCH auf /roads sperren; CORS auf App-Origin begrenzen (#1).</a:t>
             </a:r>
             <a:endParaRPr lang="en-US" sz="1450" dirty="0"/>
           </a:p>
@@ -8137,7 +8907,7 @@
                 <a:ea typeface="Calibri" pitchFamily="34" charset="-122"/>
                 <a:cs typeface="Calibri" pitchFamily="34" charset="-120"/>
               </a:rPr>
-              <a:t>Pflichtfelder &amp; Schema serverseitig erzwingen (#2, #3).</a:t>
+              <a:t>Pflichtfelder, Typen &amp; road_fid-Bezug prüfen – auch bei PUT / PATCH (#2, #3, #7).</a:t>
             </a:r>
             <a:endParaRPr lang="en-US" sz="1450" dirty="0"/>
           </a:p>

</xml_diff>

<commit_message>
API tests: cover more validation gaps and writes to /roads
- collection: [DEFECT #2] empty title, string road_fid and unknown
  road_fid; [DEFECT #7] PUT {} and PATCH with an empty title (all
  self-cleaning); the duplicate-id and PUT tests use roads that exist
- report.html regenerated against the original API: 40 requests,
  81 assertions, 9 red [DEFECT #n]
- findings deck: new finding #7, PUT/PATCH /roads under #1 (manual,
  destructive), "Was funktioniert" names the endpoints
- README: counts, findings and defect tables
</commit_message>
<xml_diff>
--- a/api-tests/road-overview-api-findings.pptx
+++ b/api-tests/road-overview-api-findings.pptx
@@ -12,6 +12,7 @@
     <p:sldId id="260" r:id="rId6"/>
     <p:sldId id="261" r:id="rId7"/>
     <p:sldId id="262" r:id="rId8"/>
+    <p:sldId id="265" r:id="rId16"/>
     <p:sldId id="263" r:id="rId9"/>
     <p:sldId id="264" r:id="rId10"/>
   </p:sldIdLst>
@@ -1759,7 +1760,7 @@
                 <a:ea typeface="Cambria" pitchFamily="34" charset="-122"/>
                 <a:cs typeface="Cambria" pitchFamily="34" charset="-120"/>
               </a:rPr>
-              <a:t>30</a:t>
+              <a:t>35</a:t>
             </a:r>
             <a:endParaRPr lang="en-US" sz="4400" dirty="0"/>
           </a:p>
@@ -1837,7 +1838,7 @@
                 <a:ea typeface="Cambria" pitchFamily="34" charset="-122"/>
                 <a:cs typeface="Cambria" pitchFamily="34" charset="-120"/>
               </a:rPr>
-              <a:t>73</a:t>
+              <a:t>81</a:t>
             </a:r>
             <a:endParaRPr lang="en-US" sz="4400" dirty="0"/>
           </a:p>
@@ -1915,7 +1916,7 @@
                 <a:ea typeface="Cambria" pitchFamily="34" charset="-122"/>
                 <a:cs typeface="Cambria" pitchFamily="34" charset="-120"/>
               </a:rPr>
-              <a:t>6</a:t>
+              <a:t>7</a:t>
             </a:r>
             <a:endParaRPr lang="en-US" sz="4400" dirty="0"/>
           </a:p>
@@ -1993,7 +1994,7 @@
                 <a:ea typeface="Cambria" pitchFamily="34" charset="-122"/>
                 <a:cs typeface="Cambria" pitchFamily="34" charset="-120"/>
               </a:rPr>
-              <a:t>4</a:t>
+              <a:t>9</a:t>
             </a:r>
             <a:endParaRPr lang="en-US" sz="4400" dirty="0"/>
           </a:p>
@@ -2074,6 +2075,570 @@
               <a:t>Newman-verifiziert gegen json-server@0.17.4 · Soll-Assertions, Defekte bewusst rot · self-cleaning</a:t>
             </a:r>
             <a:endParaRPr lang="en-US" sz="1200" dirty="0"/>
+          </a:p>
+        </p:txBody>
+      </p:sp>
+    </p:spTree>
+  </p:cSld>
+  <p:clrMapOvr>
+    <a:masterClrMapping/>
+  </p:clrMapOvr>
+</p:sld>
+</file>
+
+<file path=ppt/slides/slide10.xml><?xml version="1.0" encoding="utf-8"?>
+<p:sld xmlns:a="http://schemas.openxmlformats.org/drawingml/2006/main" xmlns:r="http://schemas.openxmlformats.org/officeDocument/2006/relationships" xmlns:p="http://schemas.openxmlformats.org/presentationml/2006/main">
+  <p:cSld name="Slide 5">
+    <p:bg>
+      <p:bgPr>
+        <a:solidFill>
+          <a:srgbClr val="FFFFFF"/>
+        </a:solidFill>
+      </p:bgPr>
+    </p:bg>
+    <p:spTree>
+      <p:nvGrpSpPr>
+        <p:cNvPr id="1" name=""/>
+        <p:cNvGrpSpPr/>
+        <p:nvPr/>
+      </p:nvGrpSpPr>
+      <p:grpSpPr>
+        <a:xfrm>
+          <a:off x="0" y="0"/>
+          <a:ext cx="0" cy="0"/>
+          <a:chOff x="0" y="0"/>
+          <a:chExt cx="0" cy="0"/>
+        </a:xfrm>
+      </p:grpSpPr>
+      <p:sp>
+        <p:nvSpPr>
+          <p:cNvPr id="2" name="Text 0"/>
+          <p:cNvSpPr/>
+          <p:nvPr/>
+        </p:nvSpPr>
+        <p:spPr>
+          <a:xfrm>
+            <a:off x="548640" y="457200"/>
+            <a:ext cx="5486400" cy="365760"/>
+          </a:xfrm>
+          <a:prstGeom prst="rect">
+            <a:avLst/>
+          </a:prstGeom>
+          <a:noFill/>
+          <a:ln/>
+        </p:spPr>
+        <p:txBody>
+          <a:bodyPr wrap="square" rtlCol="0" anchor="ctr"/>
+          <a:lstStyle/>
+          <a:p>
+            <a:pPr indent="0" marL="0">
+              <a:buNone/>
+            </a:pPr>
+            <a:r>
+              <a:rPr lang="en-US" sz="1500" dirty="0">
+                <a:solidFill>
+                  <a:srgbClr val="5A6483"/>
+                </a:solidFill>
+                <a:latin typeface="Calibri" pitchFamily="34" charset="0"/>
+                <a:ea typeface="Calibri" pitchFamily="34" charset="-122"/>
+                <a:cs typeface="Calibri" pitchFamily="34" charset="-120"/>
+              </a:rPr>
+              <a:t>Finding #7</a:t>
+            </a:r>
+            <a:endParaRPr lang="en-US" sz="1500" dirty="0"/>
+          </a:p>
+        </p:txBody>
+      </p:sp>
+      <p:sp>
+        <p:nvSpPr>
+          <p:cNvPr id="3" name="Shape 1"/>
+          <p:cNvSpPr/>
+          <p:nvPr/>
+        </p:nvSpPr>
+        <p:spPr>
+          <a:xfrm>
+            <a:off x="10241280" y="457200"/>
+            <a:ext cx="1371600" cy="310896"/>
+          </a:xfrm>
+          <a:prstGeom prst="roundRect">
+            <a:avLst>
+              <a:gd name="adj" fmla="val 50000"/>
+            </a:avLst>
+          </a:prstGeom>
+          <a:solidFill>
+            <a:srgbClr val="E67E22"/>
+          </a:solidFill>
+          <a:ln/>
+        </p:spPr>
+      </p:sp>
+      <p:sp>
+        <p:nvSpPr>
+          <p:cNvPr id="4" name="Text 2"/>
+          <p:cNvSpPr/>
+          <p:nvPr/>
+        </p:nvSpPr>
+        <p:spPr>
+          <a:xfrm>
+            <a:off x="10241280" y="457200"/>
+            <a:ext cx="1371600" cy="310896"/>
+          </a:xfrm>
+          <a:prstGeom prst="rect">
+            <a:avLst/>
+          </a:prstGeom>
+          <a:noFill/>
+          <a:ln/>
+        </p:spPr>
+        <p:txBody>
+          <a:bodyPr wrap="square" lIns="0" tIns="0" rIns="0" bIns="0" rtlCol="0" anchor="ctr"/>
+          <a:lstStyle/>
+          <a:p>
+            <a:pPr algn="ctr" indent="0" marL="0">
+              <a:buNone/>
+            </a:pPr>
+            <a:r>
+              <a:rPr lang="en-US" sz="1100" b="1" dirty="0">
+                <a:solidFill>
+                  <a:srgbClr val="FFFFFF"/>
+                </a:solidFill>
+                <a:latin typeface="Calibri" pitchFamily="34" charset="0"/>
+                <a:ea typeface="Calibri" pitchFamily="34" charset="-122"/>
+                <a:cs typeface="Calibri" pitchFamily="34" charset="-120"/>
+              </a:rPr>
+              <a:t>HOCH</a:t>
+            </a:r>
+            <a:endParaRPr lang="en-US" sz="1100" dirty="0"/>
+          </a:p>
+        </p:txBody>
+      </p:sp>
+      <p:sp>
+        <p:nvSpPr>
+          <p:cNvPr id="5" name="Text 3"/>
+          <p:cNvSpPr/>
+          <p:nvPr/>
+        </p:nvSpPr>
+        <p:spPr>
+          <a:xfrm>
+            <a:off x="548640" y="841248"/>
+            <a:ext cx="10972800" cy="731520"/>
+          </a:xfrm>
+          <a:prstGeom prst="rect">
+            <a:avLst/>
+          </a:prstGeom>
+          <a:noFill/>
+          <a:ln/>
+        </p:spPr>
+        <p:txBody>
+          <a:bodyPr wrap="square" rtlCol="0" anchor="ctr"/>
+          <a:lstStyle/>
+          <a:p>
+            <a:pPr indent="0" marL="0">
+              <a:buNone/>
+            </a:pPr>
+            <a:r>
+              <a:rPr lang="en-US" sz="3000" b="1" dirty="0">
+                <a:solidFill>
+                  <a:srgbClr val="1B2340"/>
+                </a:solidFill>
+                <a:latin typeface="Cambria" pitchFamily="34" charset="0"/>
+                <a:ea typeface="Cambria" pitchFamily="34" charset="-122"/>
+                <a:cs typeface="Cambria" pitchFamily="34" charset="-120"/>
+              </a:rPr>
+              <a:t>Keine Validierung bei PUT / PATCH /todos/:id</a:t>
+            </a:r>
+            <a:endParaRPr lang="en-US" sz="3000" dirty="0"/>
+          </a:p>
+        </p:txBody>
+      </p:sp>
+      <p:sp>
+        <p:nvSpPr>
+          <p:cNvPr id="6" name="Shape 4"/>
+          <p:cNvSpPr/>
+          <p:nvPr/>
+        </p:nvSpPr>
+        <p:spPr>
+          <a:xfrm>
+            <a:off x="548640" y="1783080"/>
+            <a:ext cx="6583680" cy="1600200"/>
+          </a:xfrm>
+          <a:prstGeom prst="roundRect">
+            <a:avLst>
+              <a:gd name="adj" fmla="val 3429"/>
+            </a:avLst>
+          </a:prstGeom>
+          <a:solidFill>
+            <a:srgbClr val="1B2340"/>
+          </a:solidFill>
+          <a:ln/>
+        </p:spPr>
+      </p:sp>
+      <p:sp>
+        <p:nvSpPr>
+          <p:cNvPr id="7" name="Text 5"/>
+          <p:cNvSpPr/>
+          <p:nvPr/>
+        </p:nvSpPr>
+        <p:spPr>
+          <a:xfrm>
+            <a:off x="713232" y="1892808"/>
+            <a:ext cx="6254496" cy="1380744"/>
+          </a:xfrm>
+          <a:prstGeom prst="rect">
+            <a:avLst/>
+          </a:prstGeom>
+          <a:noFill/>
+          <a:ln/>
+        </p:spPr>
+        <p:txBody>
+          <a:bodyPr wrap="square" lIns="0" tIns="0" rIns="0" bIns="0" rtlCol="0" anchor="t"/>
+          <a:lstStyle/>
+          <a:p>
+            <a:pPr indent="0" marL="0">
+              <a:lnSpc>
+                <a:spcPct val="112000"/>
+              </a:lnSpc>
+              <a:buNone/>
+            </a:pPr>
+            <a:r>
+              <a:rPr lang="en-US" sz="1150" dirty="0">
+                <a:solidFill>
+                  <a:srgbClr val="D8E2FF"/>
+                </a:solidFill>
+                <a:latin typeface="Courier New" pitchFamily="34" charset="0"/>
+                <a:ea typeface="Courier New" pitchFamily="34" charset="-122"/>
+                <a:cs typeface="Courier New" pitchFamily="34" charset="-120"/>
+              </a:rPr>
+              <a:t>$ curl -X PUT -H 'Content-Type: application/json' \</a:t>
+            </a:r>
+            <a:endParaRPr lang="en-US" sz="1150" dirty="0"/>
+          </a:p>
+          <a:p>
+            <a:pPr indent="0" marL="0">
+              <a:lnSpc>
+                <a:spcPct val="112000"/>
+              </a:lnSpc>
+              <a:buNone/>
+            </a:pPr>
+            <a:r>
+              <a:rPr lang="en-US" sz="1150" dirty="0">
+                <a:solidFill>
+                  <a:srgbClr val="D8E2FF"/>
+                </a:solidFill>
+                <a:latin typeface="Courier New" pitchFamily="34" charset="0"/>
+                <a:ea typeface="Courier New" pitchFamily="34" charset="-122"/>
+                <a:cs typeface="Courier New" pitchFamily="34" charset="-120"/>
+              </a:rPr>
+              <a:t>       -d '{}' http://localhost:3000/todos/2</a:t>
+            </a:r>
+            <a:endParaRPr lang="en-US" sz="1150" dirty="0"/>
+          </a:p>
+          <a:p>
+            <a:pPr indent="0" marL="0">
+              <a:lnSpc>
+                <a:spcPct val="112000"/>
+              </a:lnSpc>
+              <a:buNone/>
+            </a:pPr>
+            <a:r>
+              <a:rPr lang="en-US" sz="1150" dirty="0">
+                <a:solidFill>
+                  <a:srgbClr val="D8E2FF"/>
+                </a:solidFill>
+                <a:latin typeface="Courier New" pitchFamily="34" charset="0"/>
+                <a:ea typeface="Courier New" pitchFamily="34" charset="-122"/>
+                <a:cs typeface="Courier New" pitchFamily="34" charset="-120"/>
+              </a:rPr>
+              <a:t>  200 OK</a:t>
+            </a:r>
+            <a:endParaRPr lang="en-US" sz="1150" dirty="0"/>
+          </a:p>
+          <a:p>
+            <a:pPr indent="0" marL="0">
+              <a:lnSpc>
+                <a:spcPct val="112000"/>
+              </a:lnSpc>
+              <a:buNone/>
+            </a:pPr>
+            <a:r>
+              <a:rPr lang="en-US" sz="1150" dirty="0">
+                <a:solidFill>
+                  <a:srgbClr val="D8E2FF"/>
+                </a:solidFill>
+                <a:latin typeface="Courier New" pitchFamily="34" charset="0"/>
+                <a:ea typeface="Courier New" pitchFamily="34" charset="-122"/>
+                <a:cs typeface="Courier New" pitchFamily="34" charset="-120"/>
+              </a:rPr>
+              <a:t>  { "id": 2 }         // title, status, road_fid weg</a:t>
+            </a:r>
+            <a:endParaRPr lang="en-US" sz="1150" dirty="0"/>
+          </a:p>
+        </p:txBody>
+      </p:sp>
+      <p:sp>
+        <p:nvSpPr>
+          <p:cNvPr id="8" name="Shape 6"/>
+          <p:cNvSpPr/>
+          <p:nvPr/>
+        </p:nvSpPr>
+        <p:spPr>
+          <a:xfrm>
+            <a:off x="7406640" y="1783080"/>
+            <a:ext cx="4206240" cy="1600200"/>
+          </a:xfrm>
+          <a:prstGeom prst="roundRect">
+            <a:avLst>
+              <a:gd name="adj" fmla="val 4571"/>
+            </a:avLst>
+          </a:prstGeom>
+          <a:solidFill>
+            <a:srgbClr val="F4F6FC"/>
+          </a:solidFill>
+          <a:ln w="12700">
+            <a:solidFill>
+              <a:srgbClr val="E3E8F5"/>
+            </a:solidFill>
+            <a:prstDash val="solid"/>
+          </a:ln>
+        </p:spPr>
+      </p:sp>
+      <p:sp>
+        <p:nvSpPr>
+          <p:cNvPr id="9" name="Text 7"/>
+          <p:cNvSpPr/>
+          <p:nvPr/>
+        </p:nvSpPr>
+        <p:spPr>
+          <a:xfrm>
+            <a:off x="7607808" y="1920240"/>
+            <a:ext cx="3840480" cy="320040"/>
+          </a:xfrm>
+          <a:prstGeom prst="rect">
+            <a:avLst/>
+          </a:prstGeom>
+          <a:noFill/>
+          <a:ln/>
+        </p:spPr>
+        <p:txBody>
+          <a:bodyPr wrap="square" rtlCol="0" anchor="ctr"/>
+          <a:lstStyle/>
+          <a:p>
+            <a:pPr indent="0" marL="0">
+              <a:buNone/>
+            </a:pPr>
+            <a:r>
+              <a:rPr lang="en-US" sz="1300" b="1" dirty="0">
+                <a:solidFill>
+                  <a:srgbClr val="E67E22"/>
+                </a:solidFill>
+                <a:latin typeface="Calibri" pitchFamily="34" charset="0"/>
+                <a:ea typeface="Calibri" pitchFamily="34" charset="-122"/>
+                <a:cs typeface="Calibri" pitchFamily="34" charset="-120"/>
+              </a:rPr>
+              <a:t>Befund &amp; Test</a:t>
+            </a:r>
+            <a:endParaRPr lang="en-US" sz="1300" dirty="0"/>
+          </a:p>
+        </p:txBody>
+      </p:sp>
+      <p:sp>
+        <p:nvSpPr>
+          <p:cNvPr id="10" name="Text 8"/>
+          <p:cNvSpPr/>
+          <p:nvPr/>
+        </p:nvSpPr>
+        <p:spPr>
+          <a:xfrm>
+            <a:off x="7607808" y="2286000"/>
+            <a:ext cx="3840480" cy="1005840"/>
+          </a:xfrm>
+          <a:prstGeom prst="rect">
+            <a:avLst/>
+          </a:prstGeom>
+          <a:noFill/>
+          <a:ln/>
+        </p:spPr>
+        <p:txBody>
+          <a:bodyPr wrap="square" rtlCol="0" anchor="t"/>
+          <a:lstStyle/>
+          <a:p>
+            <a:pPr marL="342900" indent="-342900">
+              <a:spcAft>
+                <a:spcPts val="600"/>
+              </a:spcAft>
+              <a:buSzPct val="100000"/>
+              <a:buChar char="•"/>
+            </a:pPr>
+            <a:r>
+              <a:rPr lang="en-US" sz="1350" dirty="0">
+                <a:solidFill>
+                  <a:srgbClr val="1B2340"/>
+                </a:solidFill>
+                <a:latin typeface="Calibri" pitchFamily="34" charset="0"/>
+                <a:ea typeface="Calibri" pitchFamily="34" charset="-122"/>
+                <a:cs typeface="Calibri" pitchFamily="34" charset="-120"/>
+              </a:rPr>
+              <a:t>PUT {} → 200, Todo nur noch {"id": 2}</a:t>
+            </a:r>
+            <a:endParaRPr lang="en-US" sz="1350" dirty="0"/>
+          </a:p>
+          <a:p>
+            <a:pPr marL="342900" indent="-342900">
+              <a:spcAft>
+                <a:spcPts val="600"/>
+              </a:spcAft>
+              <a:buSzPct val="100000"/>
+              <a:buChar char="•"/>
+            </a:pPr>
+            <a:r>
+              <a:rPr lang="en-US" sz="1350" dirty="0">
+                <a:solidFill>
+                  <a:srgbClr val="1B2340"/>
+                </a:solidFill>
+                <a:latin typeface="Calibri" pitchFamily="34" charset="0"/>
+                <a:ea typeface="Calibri" pitchFamily="34" charset="-122"/>
+                <a:cs typeface="Calibri" pitchFamily="34" charset="-120"/>
+              </a:rPr>
+              <a:t>PATCH title "" → 200, leerer Titel gespeichert</a:t>
+            </a:r>
+            <a:endParaRPr lang="en-US" sz="1350" dirty="0"/>
+          </a:p>
+          <a:p>
+            <a:pPr marL="342900" indent="-342900">
+              <a:buSzPct val="100000"/>
+              <a:buChar char="•"/>
+            </a:pPr>
+            <a:r>
+              <a:rPr lang="en-US" sz="1350" dirty="0">
+                <a:solidFill>
+                  <a:srgbClr val="1B2340"/>
+                </a:solidFill>
+                <a:latin typeface="Calibri" pitchFamily="34" charset="0"/>
+                <a:ea typeface="Calibri" pitchFamily="34" charset="-122"/>
+                <a:cs typeface="Calibri" pitchFamily="34" charset="-120"/>
+              </a:rPr>
+              <a:t>[DEFECT #7]: Soll 400 → 2 Tests rot</a:t>
+            </a:r>
+            <a:endParaRPr lang="en-US" sz="1350" dirty="0"/>
+          </a:p>
+        </p:txBody>
+      </p:sp>
+      <p:sp>
+        <p:nvSpPr>
+          <p:cNvPr id="11" name="Text 9"/>
+          <p:cNvSpPr/>
+          <p:nvPr/>
+        </p:nvSpPr>
+        <p:spPr>
+          <a:xfrm>
+            <a:off x="548640" y="3749040"/>
+            <a:ext cx="10972800" cy="365760"/>
+          </a:xfrm>
+          <a:prstGeom prst="rect">
+            <a:avLst/>
+          </a:prstGeom>
+          <a:noFill/>
+          <a:ln/>
+        </p:spPr>
+        <p:txBody>
+          <a:bodyPr wrap="square" rtlCol="0" anchor="ctr"/>
+          <a:lstStyle/>
+          <a:p>
+            <a:pPr indent="0" marL="0">
+              <a:buNone/>
+            </a:pPr>
+            <a:r>
+              <a:rPr lang="en-US" sz="1800" b="1" dirty="0">
+                <a:solidFill>
+                  <a:srgbClr val="1E2761"/>
+                </a:solidFill>
+                <a:latin typeface="Cambria" pitchFamily="34" charset="0"/>
+                <a:ea typeface="Cambria" pitchFamily="34" charset="-122"/>
+                <a:cs typeface="Cambria" pitchFamily="34" charset="-120"/>
+              </a:rPr>
+              <a:t>Warum es zählt</a:t>
+            </a:r>
+            <a:endParaRPr lang="en-US" sz="1800" dirty="0"/>
+          </a:p>
+        </p:txBody>
+      </p:sp>
+      <p:sp>
+        <p:nvSpPr>
+          <p:cNvPr id="12" name="Text 10"/>
+          <p:cNvSpPr/>
+          <p:nvPr/>
+        </p:nvSpPr>
+        <p:spPr>
+          <a:xfrm>
+            <a:off x="640080" y="4160520"/>
+            <a:ext cx="10972800" cy="2011680"/>
+          </a:xfrm>
+          <a:prstGeom prst="rect">
+            <a:avLst/>
+          </a:prstGeom>
+          <a:noFill/>
+          <a:ln/>
+        </p:spPr>
+        <p:txBody>
+          <a:bodyPr wrap="square" rtlCol="0" anchor="t"/>
+          <a:lstStyle/>
+          <a:p>
+            <a:pPr marL="342900" indent="-342900">
+              <a:spcAft>
+                <a:spcPts val="800"/>
+              </a:spcAft>
+              <a:buSzPct val="100000"/>
+              <a:buChar char="•"/>
+            </a:pPr>
+            <a:r>
+              <a:rPr lang="en-US" sz="1500" dirty="0">
+                <a:solidFill>
+                  <a:srgbClr val="1B2340"/>
+                </a:solidFill>
+                <a:latin typeface="Calibri" pitchFamily="34" charset="0"/>
+                <a:ea typeface="Calibri" pitchFamily="34" charset="-122"/>
+                <a:cs typeface="Calibri" pitchFamily="34" charset="-120"/>
+              </a:rPr>
+              <a:t>Die Todos-Seite des Frontends speichert Änderungen per PUT – ein fehlerhafter Request löscht die Maßnahme still.</a:t>
+            </a:r>
+            <a:endParaRPr lang="en-US" sz="1500" dirty="0"/>
+          </a:p>
+          <a:p>
+            <a:pPr marL="342900" indent="-342900">
+              <a:spcAft>
+                <a:spcPts val="800"/>
+              </a:spcAft>
+              <a:buSzPct val="100000"/>
+              <a:buChar char="•"/>
+            </a:pPr>
+            <a:r>
+              <a:rPr lang="en-US" sz="1500" dirty="0">
+                <a:solidFill>
+                  <a:srgbClr val="1B2340"/>
+                </a:solidFill>
+                <a:latin typeface="Calibri" pitchFamily="34" charset="0"/>
+                <a:ea typeface="Calibri" pitchFamily="34" charset="-122"/>
+                <a:cs typeface="Calibri" pitchFamily="34" charset="-120"/>
+              </a:rPr>
+              <a:t>Gleiche Lücke wie #2, nur beim Ändern: Pflichtfelder gelten nach dem Anlegen nicht mehr.</a:t>
+            </a:r>
+            <a:endParaRPr lang="en-US" sz="1500" dirty="0"/>
+          </a:p>
+          <a:p>
+            <a:pPr marL="342900" indent="-342900">
+              <a:buSzPct val="100000"/>
+              <a:buChar char="•"/>
+            </a:pPr>
+            <a:r>
+              <a:rPr lang="en-US" sz="1500" dirty="0">
+                <a:solidFill>
+                  <a:srgbClr val="1B2340"/>
+                </a:solidFill>
+                <a:latin typeface="Calibri" pitchFamily="34" charset="0"/>
+                <a:ea typeface="Calibri" pitchFamily="34" charset="-122"/>
+                <a:cs typeface="Calibri" pitchFamily="34" charset="-120"/>
+              </a:rPr>
+              <a:t>Eine echte API sollte ungültige Updates mit 400 Bad Request ablehnen.</a:t>
+            </a:r>
+            <a:endParaRPr lang="en-US" sz="1500" dirty="0"/>
           </a:p>
         </p:txBody>
       </p:sp>
@@ -2729,7 +3294,7 @@
                 <a:ea typeface="Calibri" pitchFamily="34" charset="-122"/>
                 <a:cs typeface="Calibri" pitchFamily="34" charset="-120"/>
               </a:rPr>
-              <a:t>Newman: 30 Requests / 73 Assertions / 4 rot = bekannte Defekte. Self-cleaning bestätigt.</a:t>
+              <a:t>Newman: 35 Requests / 81 Assertions / 9 rot = bekannte Defekte. Self-cleaning bestätigt.</a:t>
             </a:r>
             <a:endParaRPr lang="en-US" sz="1350" dirty="0"/>
           </a:p>
@@ -2943,7 +3508,7 @@
                 <a:ea typeface="Calibri" pitchFamily="34" charset="-122"/>
                 <a:cs typeface="Calibri" pitchFamily="34" charset="-120"/>
               </a:rPr>
-              <a:t>POST /todos – Negativ &amp; Edge</a:t>
+              <a:t>POST /todos – Validierung &amp; Edge</a:t>
             </a:r>
             <a:endParaRPr lang="en-US" sz="1350" dirty="0"/>
           </a:p>
@@ -2964,7 +3529,7 @@
                 <a:ea typeface="Calibri" pitchFamily="34" charset="-122"/>
                 <a:cs typeface="Calibri" pitchFamily="34" charset="-120"/>
               </a:rPr>
-              <a:t>PUT / PATCH / DELETE (undokumentiert)</a:t>
+              <a:t>PUT / PATCH / DELETE /todos/:id</a:t>
             </a:r>
             <a:endParaRPr lang="en-US" sz="1350" dirty="0"/>
           </a:p>
@@ -3109,8 +3674,8 @@
         </p:nvSpPr>
         <p:spPr>
           <a:xfrm>
-            <a:off x="548640" y="1600200"/>
-            <a:ext cx="11064240" cy="658368"/>
+            <a:off x="548640" y="1554480"/>
+            <a:ext cx="11064240" cy="603504"/>
           </a:xfrm>
           <a:prstGeom prst="roundRect">
             <a:avLst>
@@ -3136,8 +3701,8 @@
         </p:nvSpPr>
         <p:spPr>
           <a:xfrm>
-            <a:off x="713232" y="1600200"/>
-            <a:ext cx="548640" cy="658368"/>
+            <a:off x="713232" y="1554480"/>
+            <a:ext cx="548640" cy="603504"/>
           </a:xfrm>
           <a:prstGeom prst="rect">
             <a:avLst/>
@@ -3175,8 +3740,8 @@
         </p:nvSpPr>
         <p:spPr>
           <a:xfrm>
-            <a:off x="1417320" y="1600200"/>
-            <a:ext cx="6583680" cy="658368"/>
+            <a:off x="1417320" y="1554480"/>
+            <a:ext cx="6583680" cy="603504"/>
           </a:xfrm>
           <a:prstGeom prst="rect">
             <a:avLst/>
@@ -3200,7 +3765,7 @@
                 <a:ea typeface="Calibri" pitchFamily="34" charset="-122"/>
                 <a:cs typeface="Calibri" pitchFamily="34" charset="-120"/>
               </a:rPr>
-              <a:t>POST /roads überschreibt komplette FeatureCollection</a:t>
+              <a:t>POST / PUT / PATCH /roads überschreiben bzw. verändern Straßendaten</a:t>
             </a:r>
             <a:endParaRPr lang="en-US" sz="1550" dirty="0"/>
           </a:p>
@@ -3214,8 +3779,8 @@
         </p:nvSpPr>
         <p:spPr>
           <a:xfrm>
-            <a:off x="8092440" y="1600200"/>
-            <a:ext cx="1920240" cy="658368"/>
+            <a:off x="8092440" y="1554480"/>
+            <a:ext cx="1920240" cy="603504"/>
           </a:xfrm>
           <a:prstGeom prst="rect">
             <a:avLst/>
@@ -3253,7 +3818,7 @@
         </p:nvSpPr>
         <p:spPr>
           <a:xfrm>
-            <a:off x="10104120" y="1773936"/>
+            <a:off x="10104120" y="1700784"/>
             <a:ext cx="1371600" cy="310896"/>
           </a:xfrm>
           <a:prstGeom prst="roundRect">
@@ -3275,7 +3840,7 @@
         </p:nvSpPr>
         <p:spPr>
           <a:xfrm>
-            <a:off x="10104120" y="1773936"/>
+            <a:off x="10104120" y="1700784"/>
             <a:ext cx="1371600" cy="310896"/>
           </a:xfrm>
           <a:prstGeom prst="rect">
@@ -3314,8 +3879,8 @@
         </p:nvSpPr>
         <p:spPr>
           <a:xfrm>
-            <a:off x="548640" y="2359152"/>
-            <a:ext cx="11064240" cy="658368"/>
+            <a:off x="548640" y="2231136"/>
+            <a:ext cx="11064240" cy="603504"/>
           </a:xfrm>
           <a:prstGeom prst="roundRect">
             <a:avLst>
@@ -3341,8 +3906,8 @@
         </p:nvSpPr>
         <p:spPr>
           <a:xfrm>
-            <a:off x="713232" y="2359152"/>
-            <a:ext cx="548640" cy="658368"/>
+            <a:off x="713232" y="2231136"/>
+            <a:ext cx="548640" cy="603504"/>
           </a:xfrm>
           <a:prstGeom prst="rect">
             <a:avLst/>
@@ -3380,8 +3945,8 @@
         </p:nvSpPr>
         <p:spPr>
           <a:xfrm>
-            <a:off x="1417320" y="2359152"/>
-            <a:ext cx="6583680" cy="658368"/>
+            <a:off x="1417320" y="2231136"/>
+            <a:ext cx="6583680" cy="603504"/>
           </a:xfrm>
           <a:prstGeom prst="rect">
             <a:avLst/>
@@ -3405,7 +3970,7 @@
                 <a:ea typeface="Calibri" pitchFamily="34" charset="-122"/>
                 <a:cs typeface="Calibri" pitchFamily="34" charset="-120"/>
               </a:rPr>
-              <a:t>POST /todos ohne jede Eingabevalidierung</a:t>
+              <a:t>POST /todos ohne Eingabevalidierung (leer, Typ, road_fid-Bezug)</a:t>
             </a:r>
             <a:endParaRPr lang="en-US" sz="1550" dirty="0"/>
           </a:p>
@@ -3419,8 +3984,8 @@
         </p:nvSpPr>
         <p:spPr>
           <a:xfrm>
-            <a:off x="8092440" y="2359152"/>
-            <a:ext cx="1920240" cy="658368"/>
+            <a:off x="8092440" y="2231136"/>
+            <a:ext cx="1920240" cy="603504"/>
           </a:xfrm>
           <a:prstGeom prst="rect">
             <a:avLst/>
@@ -3444,7 +4009,7 @@
                 <a:ea typeface="Calibri" pitchFamily="34" charset="-122"/>
                 <a:cs typeface="Calibri" pitchFamily="34" charset="-120"/>
               </a:rPr>
-              <a:t>Test rot</a:t>
+              <a:t>Test rot (4×)</a:t>
             </a:r>
             <a:endParaRPr lang="en-US" sz="1100" dirty="0"/>
           </a:p>
@@ -3458,7 +4023,7 @@
         </p:nvSpPr>
         <p:spPr>
           <a:xfrm>
-            <a:off x="10104120" y="2532888"/>
+            <a:off x="10104120" y="2377440"/>
             <a:ext cx="1371600" cy="310896"/>
           </a:xfrm>
           <a:prstGeom prst="roundRect">
@@ -3480,7 +4045,7 @@
         </p:nvSpPr>
         <p:spPr>
           <a:xfrm>
-            <a:off x="10104120" y="2532888"/>
+            <a:off x="10104120" y="2377440"/>
             <a:ext cx="1371600" cy="310896"/>
           </a:xfrm>
           <a:prstGeom prst="rect">
@@ -3513,14 +4078,14 @@
       </p:sp>
       <p:sp>
         <p:nvSpPr>
-          <p:cNvPr id="16" name="Shape 2"/>
-          <p:cNvSpPr/>
-          <p:nvPr/>
-        </p:nvSpPr>
-        <p:spPr>
-          <a:xfrm>
-            <a:off x="548640" y="3118104"/>
-            <a:ext cx="11064240" cy="658368"/>
+          <p:cNvPr id="40" name="Shape 2"/>
+          <p:cNvSpPr/>
+          <p:nvPr/>
+        </p:nvSpPr>
+        <p:spPr>
+          <a:xfrm>
+            <a:off x="548640" y="2907792"/>
+            <a:ext cx="11064240" cy="603504"/>
           </a:xfrm>
           <a:prstGeom prst="roundRect">
             <a:avLst>
@@ -3540,14 +4105,14 @@
       </p:sp>
       <p:sp>
         <p:nvSpPr>
-          <p:cNvPr id="17" name="Text 3"/>
-          <p:cNvSpPr/>
-          <p:nvPr/>
-        </p:nvSpPr>
-        <p:spPr>
-          <a:xfrm>
-            <a:off x="713232" y="3118104"/>
-            <a:ext cx="548640" cy="658368"/>
+          <p:cNvPr id="41" name="Text 3"/>
+          <p:cNvSpPr/>
+          <p:nvPr/>
+        </p:nvSpPr>
+        <p:spPr>
+          <a:xfrm>
+            <a:off x="713232" y="2907792"/>
+            <a:ext cx="548640" cy="603504"/>
           </a:xfrm>
           <a:prstGeom prst="rect">
             <a:avLst/>
@@ -3565,13 +4130,13 @@
             <a:r>
               <a:rPr lang="en-US" sz="2200" b="1" dirty="0">
                 <a:solidFill>
-                  <a:srgbClr val="F1C40F"/>
+                  <a:srgbClr val="E67E22"/>
                 </a:solidFill>
                 <a:latin typeface="Cambria" pitchFamily="34" charset="0"/>
                 <a:ea typeface="Cambria" pitchFamily="34" charset="-122"/>
                 <a:cs typeface="Cambria" pitchFamily="34" charset="-120"/>
               </a:rPr>
-              <a:t>3</a:t>
+              <a:t>7</a:t>
             </a:r>
             <a:endParaRPr lang="en-US" sz="2200" dirty="0"/>
           </a:p>
@@ -3579,14 +4144,14 @@
       </p:sp>
       <p:sp>
         <p:nvSpPr>
-          <p:cNvPr id="18" name="Text 4"/>
-          <p:cNvSpPr/>
-          <p:nvPr/>
-        </p:nvSpPr>
-        <p:spPr>
-          <a:xfrm>
-            <a:off x="1417320" y="3118104"/>
-            <a:ext cx="6583680" cy="658368"/>
+          <p:cNvPr id="42" name="Text 4"/>
+          <p:cNvSpPr/>
+          <p:nvPr/>
+        </p:nvSpPr>
+        <p:spPr>
+          <a:xfrm>
+            <a:off x="1417320" y="2907792"/>
+            <a:ext cx="6583680" cy="603504"/>
           </a:xfrm>
           <a:prstGeom prst="rect">
             <a:avLst/>
@@ -3610,7 +4175,7 @@
                 <a:ea typeface="Calibri" pitchFamily="34" charset="-122"/>
                 <a:cs typeface="Calibri" pitchFamily="34" charset="-120"/>
               </a:rPr>
-              <a:t>Falscher Content-Type → Body still verworfen</a:t>
+              <a:t>PUT / PATCH /todos/:id ohne Validierung – PUT {} löscht alle Felder</a:t>
             </a:r>
             <a:endParaRPr lang="en-US" sz="1550" dirty="0"/>
           </a:p>
@@ -3618,14 +4183,14 @@
       </p:sp>
       <p:sp>
         <p:nvSpPr>
-          <p:cNvPr id="19" name="Text 4"/>
-          <p:cNvSpPr/>
-          <p:nvPr/>
-        </p:nvSpPr>
-        <p:spPr>
-          <a:xfrm>
-            <a:off x="8092440" y="3118104"/>
-            <a:ext cx="1920240" cy="658368"/>
+          <p:cNvPr id="43" name="Text 4"/>
+          <p:cNvSpPr/>
+          <p:nvPr/>
+        </p:nvSpPr>
+        <p:spPr>
+          <a:xfrm>
+            <a:off x="8092440" y="2907792"/>
+            <a:ext cx="1920240" cy="603504"/>
           </a:xfrm>
           <a:prstGeom prst="rect">
             <a:avLst/>
@@ -3649,7 +4214,7 @@
                 <a:ea typeface="Calibri" pitchFamily="34" charset="-122"/>
                 <a:cs typeface="Calibri" pitchFamily="34" charset="-120"/>
               </a:rPr>
-              <a:t>Test rot</a:t>
+              <a:t>Test rot (2×)</a:t>
             </a:r>
             <a:endParaRPr lang="en-US" sz="1100" dirty="0"/>
           </a:p>
@@ -3657,13 +4222,13 @@
       </p:sp>
       <p:sp>
         <p:nvSpPr>
-          <p:cNvPr id="20" name="Shape 5"/>
-          <p:cNvSpPr/>
-          <p:nvPr/>
-        </p:nvSpPr>
-        <p:spPr>
-          <a:xfrm>
-            <a:off x="10104120" y="3291840"/>
+          <p:cNvPr id="44" name="Shape 5"/>
+          <p:cNvSpPr/>
+          <p:nvPr/>
+        </p:nvSpPr>
+        <p:spPr>
+          <a:xfrm>
+            <a:off x="10104120" y="3054096"/>
             <a:ext cx="1371600" cy="310896"/>
           </a:xfrm>
           <a:prstGeom prst="roundRect">
@@ -3672,20 +4237,20 @@
             </a:avLst>
           </a:prstGeom>
           <a:solidFill>
-            <a:srgbClr val="F1C40F"/>
+            <a:srgbClr val="E67E22"/>
           </a:solidFill>
           <a:ln/>
         </p:spPr>
       </p:sp>
       <p:sp>
         <p:nvSpPr>
-          <p:cNvPr id="21" name="Text 6"/>
-          <p:cNvSpPr/>
-          <p:nvPr/>
-        </p:nvSpPr>
-        <p:spPr>
-          <a:xfrm>
-            <a:off x="10104120" y="3291840"/>
+          <p:cNvPr id="45" name="Text 6"/>
+          <p:cNvSpPr/>
+          <p:nvPr/>
+        </p:nvSpPr>
+        <p:spPr>
+          <a:xfrm>
+            <a:off x="10104120" y="3054096"/>
             <a:ext cx="1371600" cy="310896"/>
           </a:xfrm>
           <a:prstGeom prst="rect">
@@ -3710,7 +4275,7 @@
                 <a:ea typeface="Calibri" pitchFamily="34" charset="-122"/>
                 <a:cs typeface="Calibri" pitchFamily="34" charset="-120"/>
               </a:rPr>
-              <a:t>Mittel</a:t>
+              <a:t>Hoch</a:t>
             </a:r>
             <a:endParaRPr lang="en-US" sz="1100" dirty="0"/>
           </a:p>
@@ -3718,14 +4283,14 @@
       </p:sp>
       <p:sp>
         <p:nvSpPr>
-          <p:cNvPr id="22" name="Shape 2"/>
-          <p:cNvSpPr/>
-          <p:nvPr/>
-        </p:nvSpPr>
-        <p:spPr>
-          <a:xfrm>
-            <a:off x="548640" y="3877056"/>
-            <a:ext cx="11064240" cy="658368"/>
+          <p:cNvPr id="16" name="Shape 2"/>
+          <p:cNvSpPr/>
+          <p:nvPr/>
+        </p:nvSpPr>
+        <p:spPr>
+          <a:xfrm>
+            <a:off x="548640" y="3584448"/>
+            <a:ext cx="11064240" cy="603504"/>
           </a:xfrm>
           <a:prstGeom prst="roundRect">
             <a:avLst>
@@ -3745,14 +4310,14 @@
       </p:sp>
       <p:sp>
         <p:nvSpPr>
-          <p:cNvPr id="23" name="Text 3"/>
-          <p:cNvSpPr/>
-          <p:nvPr/>
-        </p:nvSpPr>
-        <p:spPr>
-          <a:xfrm>
-            <a:off x="713232" y="3877056"/>
-            <a:ext cx="548640" cy="658368"/>
+          <p:cNvPr id="17" name="Text 3"/>
+          <p:cNvSpPr/>
+          <p:nvPr/>
+        </p:nvSpPr>
+        <p:spPr>
+          <a:xfrm>
+            <a:off x="713232" y="3584448"/>
+            <a:ext cx="548640" cy="603504"/>
           </a:xfrm>
           <a:prstGeom prst="rect">
             <a:avLst/>
@@ -3770,13 +4335,13 @@
             <a:r>
               <a:rPr lang="en-US" sz="2200" b="1" dirty="0">
                 <a:solidFill>
-                  <a:srgbClr val="5D6D7E"/>
+                  <a:srgbClr val="F1C40F"/>
                 </a:solidFill>
                 <a:latin typeface="Cambria" pitchFamily="34" charset="0"/>
                 <a:ea typeface="Cambria" pitchFamily="34" charset="-122"/>
                 <a:cs typeface="Cambria" pitchFamily="34" charset="-120"/>
               </a:rPr>
-              <a:t>4</a:t>
+              <a:t>3</a:t>
             </a:r>
             <a:endParaRPr lang="en-US" sz="2200" dirty="0"/>
           </a:p>
@@ -3784,14 +4349,14 @@
       </p:sp>
       <p:sp>
         <p:nvSpPr>
-          <p:cNvPr id="24" name="Text 4"/>
-          <p:cNvSpPr/>
-          <p:nvPr/>
-        </p:nvSpPr>
-        <p:spPr>
-          <a:xfrm>
-            <a:off x="1417320" y="3877056"/>
-            <a:ext cx="6583680" cy="658368"/>
+          <p:cNvPr id="18" name="Text 4"/>
+          <p:cNvSpPr/>
+          <p:nvPr/>
+        </p:nvSpPr>
+        <p:spPr>
+          <a:xfrm>
+            <a:off x="1417320" y="3584448"/>
+            <a:ext cx="6583680" cy="603504"/>
           </a:xfrm>
           <a:prstGeom prst="rect">
             <a:avLst/>
@@ -3815,7 +4380,7 @@
                 <a:ea typeface="Calibri" pitchFamily="34" charset="-122"/>
                 <a:cs typeface="Calibri" pitchFamily="34" charset="-120"/>
               </a:rPr>
-              <a:t>PUT / PATCH / DELETE verfügbar, aber undokumentiert</a:t>
+              <a:t>Falscher Content-Type → Body still verworfen</a:t>
             </a:r>
             <a:endParaRPr lang="en-US" sz="1550" dirty="0"/>
           </a:p>
@@ -3823,14 +4388,14 @@
       </p:sp>
       <p:sp>
         <p:nvSpPr>
-          <p:cNvPr id="25" name="Text 4"/>
-          <p:cNvSpPr/>
-          <p:nvPr/>
-        </p:nvSpPr>
-        <p:spPr>
-          <a:xfrm>
-            <a:off x="8092440" y="3877056"/>
-            <a:ext cx="1920240" cy="658368"/>
+          <p:cNvPr id="19" name="Text 4"/>
+          <p:cNvSpPr/>
+          <p:nvPr/>
+        </p:nvSpPr>
+        <p:spPr>
+          <a:xfrm>
+            <a:off x="8092440" y="3584448"/>
+            <a:ext cx="1920240" cy="603504"/>
           </a:xfrm>
           <a:prstGeom prst="rect">
             <a:avLst/>
@@ -3846,15 +4411,15 @@
               <a:buNone/>
             </a:pPr>
             <a:r>
-              <a:rPr lang="en-US" sz="1100" i="1" dirty="0">
-                <a:solidFill>
-                  <a:srgbClr val="5A6483"/>
-                </a:solidFill>
-                <a:latin typeface="Calibri" pitchFamily="34" charset="0"/>
-                <a:ea typeface="Calibri" pitchFamily="34" charset="-122"/>
-                <a:cs typeface="Calibri" pitchFamily="34" charset="-120"/>
-              </a:rPr>
-              <a:t>Doku-Lücke · grün</a:t>
+              <a:rPr lang="en-US" sz="1100" b="1" dirty="0">
+                <a:solidFill>
+                  <a:srgbClr val="C0392B"/>
+                </a:solidFill>
+                <a:latin typeface="Calibri" pitchFamily="34" charset="0"/>
+                <a:ea typeface="Calibri" pitchFamily="34" charset="-122"/>
+                <a:cs typeface="Calibri" pitchFamily="34" charset="-120"/>
+              </a:rPr>
+              <a:t>Test rot</a:t>
             </a:r>
             <a:endParaRPr lang="en-US" sz="1100" dirty="0"/>
           </a:p>
@@ -3862,13 +4427,13 @@
       </p:sp>
       <p:sp>
         <p:nvSpPr>
-          <p:cNvPr id="26" name="Shape 5"/>
-          <p:cNvSpPr/>
-          <p:nvPr/>
-        </p:nvSpPr>
-        <p:spPr>
-          <a:xfrm>
-            <a:off x="10104120" y="4050792"/>
+          <p:cNvPr id="20" name="Shape 5"/>
+          <p:cNvSpPr/>
+          <p:nvPr/>
+        </p:nvSpPr>
+        <p:spPr>
+          <a:xfrm>
+            <a:off x="10104120" y="3730752"/>
             <a:ext cx="1371600" cy="310896"/>
           </a:xfrm>
           <a:prstGeom prst="roundRect">
@@ -3877,20 +4442,20 @@
             </a:avLst>
           </a:prstGeom>
           <a:solidFill>
-            <a:srgbClr val="5D6D7E"/>
+            <a:srgbClr val="F1C40F"/>
           </a:solidFill>
           <a:ln/>
         </p:spPr>
       </p:sp>
       <p:sp>
         <p:nvSpPr>
-          <p:cNvPr id="27" name="Text 6"/>
-          <p:cNvSpPr/>
-          <p:nvPr/>
-        </p:nvSpPr>
-        <p:spPr>
-          <a:xfrm>
-            <a:off x="10104120" y="4050792"/>
+          <p:cNvPr id="21" name="Text 6"/>
+          <p:cNvSpPr/>
+          <p:nvPr/>
+        </p:nvSpPr>
+        <p:spPr>
+          <a:xfrm>
+            <a:off x="10104120" y="3730752"/>
             <a:ext cx="1371600" cy="310896"/>
           </a:xfrm>
           <a:prstGeom prst="rect">
@@ -3915,7 +4480,7 @@
                 <a:ea typeface="Calibri" pitchFamily="34" charset="-122"/>
                 <a:cs typeface="Calibri" pitchFamily="34" charset="-120"/>
               </a:rPr>
-              <a:t>Niedrig</a:t>
+              <a:t>Mittel</a:t>
             </a:r>
             <a:endParaRPr lang="en-US" sz="1100" dirty="0"/>
           </a:p>
@@ -3923,14 +4488,14 @@
       </p:sp>
       <p:sp>
         <p:nvSpPr>
-          <p:cNvPr id="28" name="Shape 2"/>
-          <p:cNvSpPr/>
-          <p:nvPr/>
-        </p:nvSpPr>
-        <p:spPr>
-          <a:xfrm>
-            <a:off x="548640" y="4636008"/>
-            <a:ext cx="11064240" cy="658368"/>
+          <p:cNvPr id="22" name="Shape 2"/>
+          <p:cNvSpPr/>
+          <p:nvPr/>
+        </p:nvSpPr>
+        <p:spPr>
+          <a:xfrm>
+            <a:off x="548640" y="4261104"/>
+            <a:ext cx="11064240" cy="603504"/>
           </a:xfrm>
           <a:prstGeom prst="roundRect">
             <a:avLst>
@@ -3950,14 +4515,14 @@
       </p:sp>
       <p:sp>
         <p:nvSpPr>
-          <p:cNvPr id="29" name="Text 3"/>
-          <p:cNvSpPr/>
-          <p:nvPr/>
-        </p:nvSpPr>
-        <p:spPr>
-          <a:xfrm>
-            <a:off x="713232" y="4636008"/>
-            <a:ext cx="548640" cy="658368"/>
+          <p:cNvPr id="23" name="Text 3"/>
+          <p:cNvSpPr/>
+          <p:nvPr/>
+        </p:nvSpPr>
+        <p:spPr>
+          <a:xfrm>
+            <a:off x="713232" y="4261104"/>
+            <a:ext cx="548640" cy="603504"/>
           </a:xfrm>
           <a:prstGeom prst="rect">
             <a:avLst/>
@@ -3981,7 +4546,7 @@
                 <a:ea typeface="Cambria" pitchFamily="34" charset="-122"/>
                 <a:cs typeface="Cambria" pitchFamily="34" charset="-120"/>
               </a:rPr>
-              <a:t>5</a:t>
+              <a:t>4</a:t>
             </a:r>
             <a:endParaRPr lang="en-US" sz="2200" dirty="0"/>
           </a:p>
@@ -3989,14 +4554,14 @@
       </p:sp>
       <p:sp>
         <p:nvSpPr>
-          <p:cNvPr id="30" name="Text 4"/>
-          <p:cNvSpPr/>
-          <p:nvPr/>
-        </p:nvSpPr>
-        <p:spPr>
-          <a:xfrm>
-            <a:off x="1417320" y="4636008"/>
-            <a:ext cx="6583680" cy="658368"/>
+          <p:cNvPr id="24" name="Text 4"/>
+          <p:cNvSpPr/>
+          <p:nvPr/>
+        </p:nvSpPr>
+        <p:spPr>
+          <a:xfrm>
+            <a:off x="1417320" y="4261104"/>
+            <a:ext cx="6583680" cy="603504"/>
           </a:xfrm>
           <a:prstGeom prst="rect">
             <a:avLst/>
@@ -4020,7 +4585,7 @@
                 <a:ea typeface="Calibri" pitchFamily="34" charset="-122"/>
                 <a:cs typeface="Calibri" pitchFamily="34" charset="-120"/>
               </a:rPr>
-              <a:t>Schwache Fehlersemantik (500 statt 409, HTML statt JSON)</a:t>
+              <a:t>PUT / PATCH / DELETE verfügbar, aber undokumentiert</a:t>
             </a:r>
             <a:endParaRPr lang="en-US" sz="1550" dirty="0"/>
           </a:p>
@@ -4028,14 +4593,14 @@
       </p:sp>
       <p:sp>
         <p:nvSpPr>
-          <p:cNvPr id="31" name="Text 4"/>
-          <p:cNvSpPr/>
-          <p:nvPr/>
-        </p:nvSpPr>
-        <p:spPr>
-          <a:xfrm>
-            <a:off x="8092440" y="4636008"/>
-            <a:ext cx="1920240" cy="658368"/>
+          <p:cNvPr id="25" name="Text 4"/>
+          <p:cNvSpPr/>
+          <p:nvPr/>
+        </p:nvSpPr>
+        <p:spPr>
+          <a:xfrm>
+            <a:off x="8092440" y="4261104"/>
+            <a:ext cx="1920240" cy="603504"/>
           </a:xfrm>
           <a:prstGeom prst="rect">
             <a:avLst/>
@@ -4051,15 +4616,15 @@
               <a:buNone/>
             </a:pPr>
             <a:r>
-              <a:rPr lang="en-US" sz="1100" b="1" dirty="0">
-                <a:solidFill>
-                  <a:srgbClr val="C0392B"/>
-                </a:solidFill>
-                <a:latin typeface="Calibri" pitchFamily="34" charset="0"/>
-                <a:ea typeface="Calibri" pitchFamily="34" charset="-122"/>
-                <a:cs typeface="Calibri" pitchFamily="34" charset="-120"/>
-              </a:rPr>
-              <a:t>Test rot (2×)</a:t>
+              <a:rPr lang="en-US" sz="1100" i="1" dirty="0">
+                <a:solidFill>
+                  <a:srgbClr val="5A6483"/>
+                </a:solidFill>
+                <a:latin typeface="Calibri" pitchFamily="34" charset="0"/>
+                <a:ea typeface="Calibri" pitchFamily="34" charset="-122"/>
+                <a:cs typeface="Calibri" pitchFamily="34" charset="-120"/>
+              </a:rPr>
+              <a:t>Doku-Lücke · grün</a:t>
             </a:r>
             <a:endParaRPr lang="en-US" sz="1100" dirty="0"/>
           </a:p>
@@ -4067,13 +4632,13 @@
       </p:sp>
       <p:sp>
         <p:nvSpPr>
-          <p:cNvPr id="32" name="Shape 5"/>
-          <p:cNvSpPr/>
-          <p:nvPr/>
-        </p:nvSpPr>
-        <p:spPr>
-          <a:xfrm>
-            <a:off x="10104120" y="4809744"/>
+          <p:cNvPr id="26" name="Shape 5"/>
+          <p:cNvSpPr/>
+          <p:nvPr/>
+        </p:nvSpPr>
+        <p:spPr>
+          <a:xfrm>
+            <a:off x="10104120" y="4407408"/>
             <a:ext cx="1371600" cy="310896"/>
           </a:xfrm>
           <a:prstGeom prst="roundRect">
@@ -4089,13 +4654,13 @@
       </p:sp>
       <p:sp>
         <p:nvSpPr>
-          <p:cNvPr id="33" name="Text 6"/>
-          <p:cNvSpPr/>
-          <p:nvPr/>
-        </p:nvSpPr>
-        <p:spPr>
-          <a:xfrm>
-            <a:off x="10104120" y="4809744"/>
+          <p:cNvPr id="27" name="Text 6"/>
+          <p:cNvSpPr/>
+          <p:nvPr/>
+        </p:nvSpPr>
+        <p:spPr>
+          <a:xfrm>
+            <a:off x="10104120" y="4407408"/>
             <a:ext cx="1371600" cy="310896"/>
           </a:xfrm>
           <a:prstGeom prst="rect">
@@ -4128,14 +4693,14 @@
       </p:sp>
       <p:sp>
         <p:nvSpPr>
-          <p:cNvPr id="34" name="Shape 2"/>
-          <p:cNvSpPr/>
-          <p:nvPr/>
-        </p:nvSpPr>
-        <p:spPr>
-          <a:xfrm>
-            <a:off x="548640" y="5394960"/>
-            <a:ext cx="11064240" cy="658368"/>
+          <p:cNvPr id="28" name="Shape 2"/>
+          <p:cNvSpPr/>
+          <p:nvPr/>
+        </p:nvSpPr>
+        <p:spPr>
+          <a:xfrm>
+            <a:off x="548640" y="4937760"/>
+            <a:ext cx="11064240" cy="603504"/>
           </a:xfrm>
           <a:prstGeom prst="roundRect">
             <a:avLst>
@@ -4155,14 +4720,14 @@
       </p:sp>
       <p:sp>
         <p:nvSpPr>
-          <p:cNvPr id="35" name="Text 3"/>
-          <p:cNvSpPr/>
-          <p:nvPr/>
-        </p:nvSpPr>
-        <p:spPr>
-          <a:xfrm>
-            <a:off x="713232" y="5394960"/>
-            <a:ext cx="548640" cy="658368"/>
+          <p:cNvPr id="29" name="Text 3"/>
+          <p:cNvSpPr/>
+          <p:nvPr/>
+        </p:nvSpPr>
+        <p:spPr>
+          <a:xfrm>
+            <a:off x="713232" y="4937760"/>
+            <a:ext cx="548640" cy="603504"/>
           </a:xfrm>
           <a:prstGeom prst="rect">
             <a:avLst/>
@@ -4186,7 +4751,7 @@
                 <a:ea typeface="Cambria" pitchFamily="34" charset="-122"/>
                 <a:cs typeface="Cambria" pitchFamily="34" charset="-120"/>
               </a:rPr>
-              <a:t>6</a:t>
+              <a:t>5</a:t>
             </a:r>
             <a:endParaRPr lang="en-US" sz="2200" dirty="0"/>
           </a:p>
@@ -4194,14 +4759,14 @@
       </p:sp>
       <p:sp>
         <p:nvSpPr>
-          <p:cNvPr id="36" name="Text 4"/>
-          <p:cNvSpPr/>
-          <p:nvPr/>
-        </p:nvSpPr>
-        <p:spPr>
-          <a:xfrm>
-            <a:off x="1417320" y="5394960"/>
-            <a:ext cx="6583680" cy="658368"/>
+          <p:cNvPr id="30" name="Text 4"/>
+          <p:cNvSpPr/>
+          <p:nvPr/>
+        </p:nvSpPr>
+        <p:spPr>
+          <a:xfrm>
+            <a:off x="1417320" y="4937760"/>
+            <a:ext cx="6583680" cy="603504"/>
           </a:xfrm>
           <a:prstGeom prst="rect">
             <a:avLst/>
@@ -4225,7 +4790,7 @@
                 <a:ea typeface="Calibri" pitchFamily="34" charset="-122"/>
                 <a:cs typeface="Calibri" pitchFamily="34" charset="-120"/>
               </a:rPr>
-              <a:t>/roads: Filter/Sort/Pagination wirkungslos</a:t>
+              <a:t>Schwache Fehlersemantik (500 statt 409, HTML statt JSON)</a:t>
             </a:r>
             <a:endParaRPr lang="en-US" sz="1550" dirty="0"/>
           </a:p>
@@ -4233,14 +4798,14 @@
       </p:sp>
       <p:sp>
         <p:nvSpPr>
-          <p:cNvPr id="37" name="Text 4"/>
-          <p:cNvSpPr/>
-          <p:nvPr/>
-        </p:nvSpPr>
-        <p:spPr>
-          <a:xfrm>
-            <a:off x="8092440" y="5394960"/>
-            <a:ext cx="1920240" cy="658368"/>
+          <p:cNvPr id="31" name="Text 4"/>
+          <p:cNvSpPr/>
+          <p:nvPr/>
+        </p:nvSpPr>
+        <p:spPr>
+          <a:xfrm>
+            <a:off x="8092440" y="4937760"/>
+            <a:ext cx="1920240" cy="603504"/>
           </a:xfrm>
           <a:prstGeom prst="rect">
             <a:avLst/>
@@ -4256,15 +4821,15 @@
               <a:buNone/>
             </a:pPr>
             <a:r>
-              <a:rPr lang="en-US" sz="1100" i="1" dirty="0">
-                <a:solidFill>
-                  <a:srgbClr val="5A6483"/>
-                </a:solidFill>
-                <a:latin typeface="Calibri" pitchFamily="34" charset="0"/>
-                <a:ea typeface="Calibri" pitchFamily="34" charset="-122"/>
-                <a:cs typeface="Calibri" pitchFamily="34" charset="-120"/>
-              </a:rPr>
-              <a:t>Limitierung · grün</a:t>
+              <a:rPr lang="en-US" sz="1100" b="1" dirty="0">
+                <a:solidFill>
+                  <a:srgbClr val="C0392B"/>
+                </a:solidFill>
+                <a:latin typeface="Calibri" pitchFamily="34" charset="0"/>
+                <a:ea typeface="Calibri" pitchFamily="34" charset="-122"/>
+                <a:cs typeface="Calibri" pitchFamily="34" charset="-120"/>
+              </a:rPr>
+              <a:t>Test rot (2×)</a:t>
             </a:r>
             <a:endParaRPr lang="en-US" sz="1100" dirty="0"/>
           </a:p>
@@ -4272,13 +4837,13 @@
       </p:sp>
       <p:sp>
         <p:nvSpPr>
-          <p:cNvPr id="38" name="Shape 5"/>
-          <p:cNvSpPr/>
-          <p:nvPr/>
-        </p:nvSpPr>
-        <p:spPr>
-          <a:xfrm>
-            <a:off x="10104120" y="5568696"/>
+          <p:cNvPr id="32" name="Shape 5"/>
+          <p:cNvSpPr/>
+          <p:nvPr/>
+        </p:nvSpPr>
+        <p:spPr>
+          <a:xfrm>
+            <a:off x="10104120" y="5084064"/>
             <a:ext cx="1371600" cy="310896"/>
           </a:xfrm>
           <a:prstGeom prst="roundRect">
@@ -4294,13 +4859,218 @@
       </p:sp>
       <p:sp>
         <p:nvSpPr>
+          <p:cNvPr id="33" name="Text 6"/>
+          <p:cNvSpPr/>
+          <p:nvPr/>
+        </p:nvSpPr>
+        <p:spPr>
+          <a:xfrm>
+            <a:off x="10104120" y="5084064"/>
+            <a:ext cx="1371600" cy="310896"/>
+          </a:xfrm>
+          <a:prstGeom prst="rect">
+            <a:avLst/>
+          </a:prstGeom>
+          <a:noFill/>
+          <a:ln/>
+        </p:spPr>
+        <p:txBody>
+          <a:bodyPr wrap="square" lIns="0" tIns="0" rIns="0" bIns="0" rtlCol="0" anchor="ctr"/>
+          <a:lstStyle/>
+          <a:p>
+            <a:pPr algn="ctr" indent="0" marL="0">
+              <a:buNone/>
+            </a:pPr>
+            <a:r>
+              <a:rPr lang="en-US" sz="1100" b="1" dirty="0">
+                <a:solidFill>
+                  <a:srgbClr val="FFFFFF"/>
+                </a:solidFill>
+                <a:latin typeface="Calibri" pitchFamily="34" charset="0"/>
+                <a:ea typeface="Calibri" pitchFamily="34" charset="-122"/>
+                <a:cs typeface="Calibri" pitchFamily="34" charset="-120"/>
+              </a:rPr>
+              <a:t>Niedrig</a:t>
+            </a:r>
+            <a:endParaRPr lang="en-US" sz="1100" dirty="0"/>
+          </a:p>
+        </p:txBody>
+      </p:sp>
+      <p:sp>
+        <p:nvSpPr>
+          <p:cNvPr id="34" name="Shape 2"/>
+          <p:cNvSpPr/>
+          <p:nvPr/>
+        </p:nvSpPr>
+        <p:spPr>
+          <a:xfrm>
+            <a:off x="548640" y="5614416"/>
+            <a:ext cx="11064240" cy="603504"/>
+          </a:xfrm>
+          <a:prstGeom prst="roundRect">
+            <a:avLst>
+              <a:gd name="adj" fmla="val 8333"/>
+            </a:avLst>
+          </a:prstGeom>
+          <a:solidFill>
+            <a:srgbClr val="F4F6FC"/>
+          </a:solidFill>
+          <a:ln w="12700">
+            <a:solidFill>
+              <a:srgbClr val="E3E8F5"/>
+            </a:solidFill>
+            <a:prstDash val="solid"/>
+          </a:ln>
+        </p:spPr>
+      </p:sp>
+      <p:sp>
+        <p:nvSpPr>
+          <p:cNvPr id="35" name="Text 3"/>
+          <p:cNvSpPr/>
+          <p:nvPr/>
+        </p:nvSpPr>
+        <p:spPr>
+          <a:xfrm>
+            <a:off x="713232" y="5614416"/>
+            <a:ext cx="548640" cy="603504"/>
+          </a:xfrm>
+          <a:prstGeom prst="rect">
+            <a:avLst/>
+          </a:prstGeom>
+          <a:noFill/>
+          <a:ln/>
+        </p:spPr>
+        <p:txBody>
+          <a:bodyPr wrap="square" lIns="0" tIns="0" rIns="0" bIns="0" rtlCol="0" anchor="ctr"/>
+          <a:lstStyle/>
+          <a:p>
+            <a:pPr algn="ctr" indent="0" marL="0">
+              <a:buNone/>
+            </a:pPr>
+            <a:r>
+              <a:rPr lang="en-US" sz="2200" b="1" dirty="0">
+                <a:solidFill>
+                  <a:srgbClr val="5D6D7E"/>
+                </a:solidFill>
+                <a:latin typeface="Cambria" pitchFamily="34" charset="0"/>
+                <a:ea typeface="Cambria" pitchFamily="34" charset="-122"/>
+                <a:cs typeface="Cambria" pitchFamily="34" charset="-120"/>
+              </a:rPr>
+              <a:t>6</a:t>
+            </a:r>
+            <a:endParaRPr lang="en-US" sz="2200" dirty="0"/>
+          </a:p>
+        </p:txBody>
+      </p:sp>
+      <p:sp>
+        <p:nvSpPr>
+          <p:cNvPr id="36" name="Text 4"/>
+          <p:cNvSpPr/>
+          <p:nvPr/>
+        </p:nvSpPr>
+        <p:spPr>
+          <a:xfrm>
+            <a:off x="1417320" y="5614416"/>
+            <a:ext cx="6583680" cy="603504"/>
+          </a:xfrm>
+          <a:prstGeom prst="rect">
+            <a:avLst/>
+          </a:prstGeom>
+          <a:noFill/>
+          <a:ln/>
+        </p:spPr>
+        <p:txBody>
+          <a:bodyPr wrap="square" lIns="0" tIns="0" rIns="0" bIns="0" rtlCol="0" anchor="ctr"/>
+          <a:lstStyle/>
+          <a:p>
+            <a:pPr indent="0" marL="0">
+              <a:buNone/>
+            </a:pPr>
+            <a:r>
+              <a:rPr lang="en-US" sz="1550" dirty="0">
+                <a:solidFill>
+                  <a:srgbClr val="1B2340"/>
+                </a:solidFill>
+                <a:latin typeface="Calibri" pitchFamily="34" charset="0"/>
+                <a:ea typeface="Calibri" pitchFamily="34" charset="-122"/>
+                <a:cs typeface="Calibri" pitchFamily="34" charset="-120"/>
+              </a:rPr>
+              <a:t>/roads: Filter/Sort/Pagination wirkungslos</a:t>
+            </a:r>
+            <a:endParaRPr lang="en-US" sz="1550" dirty="0"/>
+          </a:p>
+        </p:txBody>
+      </p:sp>
+      <p:sp>
+        <p:nvSpPr>
+          <p:cNvPr id="37" name="Text 4"/>
+          <p:cNvSpPr/>
+          <p:nvPr/>
+        </p:nvSpPr>
+        <p:spPr>
+          <a:xfrm>
+            <a:off x="8092440" y="5614416"/>
+            <a:ext cx="1920240" cy="603504"/>
+          </a:xfrm>
+          <a:prstGeom prst="rect">
+            <a:avLst/>
+          </a:prstGeom>
+          <a:noFill/>
+          <a:ln/>
+        </p:spPr>
+        <p:txBody>
+          <a:bodyPr wrap="square" lIns="0" tIns="0" rIns="0" bIns="0" rtlCol="0" anchor="ctr"/>
+          <a:lstStyle/>
+          <a:p>
+            <a:pPr indent="0" marL="0">
+              <a:buNone/>
+            </a:pPr>
+            <a:r>
+              <a:rPr lang="en-US" sz="1100" i="1" dirty="0">
+                <a:solidFill>
+                  <a:srgbClr val="5A6483"/>
+                </a:solidFill>
+                <a:latin typeface="Calibri" pitchFamily="34" charset="0"/>
+                <a:ea typeface="Calibri" pitchFamily="34" charset="-122"/>
+                <a:cs typeface="Calibri" pitchFamily="34" charset="-120"/>
+              </a:rPr>
+              <a:t>Limitierung · grün</a:t>
+            </a:r>
+            <a:endParaRPr lang="en-US" sz="1100" dirty="0"/>
+          </a:p>
+        </p:txBody>
+      </p:sp>
+      <p:sp>
+        <p:nvSpPr>
+          <p:cNvPr id="38" name="Shape 5"/>
+          <p:cNvSpPr/>
+          <p:nvPr/>
+        </p:nvSpPr>
+        <p:spPr>
+          <a:xfrm>
+            <a:off x="10104120" y="5760720"/>
+            <a:ext cx="1371600" cy="310896"/>
+          </a:xfrm>
+          <a:prstGeom prst="roundRect">
+            <a:avLst>
+              <a:gd name="adj" fmla="val 50000"/>
+            </a:avLst>
+          </a:prstGeom>
+          <a:solidFill>
+            <a:srgbClr val="5D6D7E"/>
+          </a:solidFill>
+          <a:ln/>
+        </p:spPr>
+      </p:sp>
+      <p:sp>
+        <p:nvSpPr>
           <p:cNvPr id="39" name="Text 6"/>
           <p:cNvSpPr/>
           <p:nvPr/>
         </p:nvSpPr>
         <p:spPr>
           <a:xfrm>
-            <a:off x="10104120" y="5568696"/>
+            <a:off x="10104120" y="5760720"/>
             <a:ext cx="1371600" cy="310896"/>
           </a:xfrm>
           <a:prstGeom prst="rect">
@@ -4496,7 +5266,7 @@
                 <a:ea typeface="Cambria" pitchFamily="34" charset="-122"/>
                 <a:cs typeface="Cambria" pitchFamily="34" charset="-120"/>
               </a:rPr>
-              <a:t>POST /roads zerstört alle Straßendaten</a:t>
+              <a:t>POST / PUT /roads zerstören alle Straßendaten</a:t>
             </a:r>
             <a:endParaRPr lang="en-US" sz="3400" dirty="0"/>
           </a:p>
@@ -4696,7 +5466,7 @@
                 <a:ea typeface="Calibri" pitchFamily="34" charset="-122"/>
                 <a:cs typeface="Calibri" pitchFamily="34" charset="-120"/>
               </a:rPr>
-              <a:t>201 – gesamte FeatureCollection überschrieben, alle 773 Straßen weg (kein Append, kein Merge)</a:t>
+              <a:t>POST 201 / PUT 200 – FeatureCollection überschrieben, alle 773 Straßen weg. PATCH 200 – Felder hineingemischt</a:t>
             </a:r>
             <a:endParaRPr lang="en-US" sz="1300" dirty="0"/>
           </a:p>
@@ -5263,7 +6033,7 @@
                 <a:ea typeface="Calibri" pitchFamily="34" charset="-122"/>
                 <a:cs typeface="Calibri" pitchFamily="34" charset="-120"/>
               </a:rPr>
-              <a:t>kein title, kein road_fid – trotzdem 201</a:t>
+              <a:t>{}, leerer title, road_fid "abc" – trotzdem 201</a:t>
             </a:r>
             <a:endParaRPr lang="en-US" sz="1350" dirty="0"/>
           </a:p>
@@ -5284,7 +6054,7 @@
                 <a:ea typeface="Calibri" pitchFamily="34" charset="-122"/>
                 <a:cs typeface="Calibri" pitchFamily="34" charset="-120"/>
               </a:rPr>
-              <a:t>road_fid ist Pflichtbezug (Anforderung 7)</a:t>
+              <a:t>road_fid 999999 (Straße fehlt) – trotzdem 201</a:t>
             </a:r>
             <a:endParaRPr lang="en-US" sz="1350" dirty="0"/>
           </a:p>
@@ -5302,7 +6072,7 @@
                 <a:ea typeface="Calibri" pitchFamily="34" charset="-122"/>
                 <a:cs typeface="Calibri" pitchFamily="34" charset="-120"/>
               </a:rPr>
-              <a:t>[DEFECT #2]: Soll 400 → Test rot</a:t>
+              <a:t>[DEFECT #2]: Soll 400 / 422 → 4 Tests rot</a:t>
             </a:r>
             <a:endParaRPr lang="en-US" sz="1350" dirty="0"/>
           </a:p>
@@ -6144,7 +6914,7 @@
                 <a:ea typeface="Calibri" pitchFamily="34" charset="-122"/>
                 <a:cs typeface="Calibri" pitchFamily="34" charset="-120"/>
               </a:rPr>
-              <a:t>Doku nennt nur GET / POST – die Todos-Seite des Frontends hängt aber an diesen undokumentierten Endpunkten. Doku-Lücke, kein API-Fehler → Tests grün.</a:t>
+              <a:t>Doku nennt nur GET / POST – die Todos-Seite des Frontends hängt aber an diesen undokumentierten Endpunkten. Mit gültigem Body korrekt → Tests grün; fehlende Validierung siehe #7.</a:t>
             </a:r>
             <a:endParaRPr lang="en-US" sz="1300" dirty="0"/>
           </a:p>
@@ -6803,7 +7573,7 @@
                 <a:ea typeface="Calibri" pitchFamily="34" charset="-122"/>
                 <a:cs typeface="Calibri" pitchFamily="34" charset="-120"/>
               </a:rPr>
-              <a:t>Positiv-Belege – korrekt verifiziert</a:t>
+              <a:t>Positiv-Belege je Endpunkt, per Newman verifiziert · Filter, Sortierung &amp; Pagination gelten nur für /todos (nicht /roads, #6)</a:t>
             </a:r>
             <a:endParaRPr lang="en-US" sz="1400" dirty="0"/>
           </a:p>
@@ -6928,7 +7698,7 @@
                 <a:ea typeface="Calibri" pitchFamily="34" charset="-122"/>
                 <a:cs typeface="Calibri" pitchFamily="34" charset="-120"/>
               </a:rPr>
-              <a:t>Filter &amp; Operatoren</a:t>
+              <a:t>GET /roads – Lesen</a:t>
             </a:r>
             <a:endParaRPr lang="en-US" sz="1650" dirty="0"/>
           </a:p>
@@ -6967,7 +7737,7 @@
                 <a:ea typeface="Calibri" pitchFamily="34" charset="-122"/>
                 <a:cs typeface="Calibri" pitchFamily="34" charset="-120"/>
               </a:rPr>
-              <a:t>?feld=, _gte, _like – exakt &amp; korrekt</a:t>
+              <a:t>200, gültige FeatureCollection mit allen 773 Straßen</a:t>
             </a:r>
             <a:endParaRPr lang="en-US" sz="1250" dirty="0"/>
           </a:p>
@@ -7092,7 +7862,7 @@
                 <a:ea typeface="Calibri" pitchFamily="34" charset="-122"/>
                 <a:cs typeface="Calibri" pitchFamily="34" charset="-120"/>
               </a:rPr>
-              <a:t>Volltextsuche</a:t>
+              <a:t>GET /todos – Filter &amp; Suche</a:t>
             </a:r>
             <a:endParaRPr lang="en-US" sz="1650" dirty="0"/>
           </a:p>
@@ -7131,7 +7901,7 @@
                 <a:ea typeface="Calibri" pitchFamily="34" charset="-122"/>
                 <a:cs typeface="Calibri" pitchFamily="34" charset="-120"/>
               </a:rPr>
-              <a:t>?q= durchsucht alle Felder</a:t>
+              <a:t>?status=, ?road_fid=, _gte, _like, Volltext ?q= – exakt &amp; korrekt</a:t>
             </a:r>
             <a:endParaRPr lang="en-US" sz="1250" dirty="0"/>
           </a:p>
@@ -7256,7 +8026,7 @@
                 <a:ea typeface="Calibri" pitchFamily="34" charset="-122"/>
                 <a:cs typeface="Calibri" pitchFamily="34" charset="-120"/>
               </a:rPr>
-              <a:t>Sortierung</a:t>
+              <a:t>GET /todos – Sortierung &amp; Pagination</a:t>
             </a:r>
             <a:endParaRPr lang="en-US" sz="1650" dirty="0"/>
           </a:p>
@@ -7295,7 +8065,7 @@
                 <a:ea typeface="Calibri" pitchFamily="34" charset="-122"/>
                 <a:cs typeface="Calibri" pitchFamily="34" charset="-120"/>
               </a:rPr>
-              <a:t>_sort / _order aufsteigend &amp; absteigend</a:t>
+              <a:t>_sort / _order, _page / _limit mit X-Total-Count &amp; Link, _start / _end</a:t>
             </a:r>
             <a:endParaRPr lang="en-US" sz="1250" dirty="0"/>
           </a:p>
@@ -7420,7 +8190,7 @@
                 <a:ea typeface="Calibri" pitchFamily="34" charset="-122"/>
                 <a:cs typeface="Calibri" pitchFamily="34" charset="-120"/>
               </a:rPr>
-              <a:t>Pagination</a:t>
+              <a:t>POST /todos – Anlegen</a:t>
             </a:r>
             <a:endParaRPr lang="en-US" sz="1650" dirty="0"/>
           </a:p>
@@ -7459,7 +8229,7 @@
                 <a:ea typeface="Calibri" pitchFamily="34" charset="-122"/>
                 <a:cs typeface="Calibri" pitchFamily="34" charset="-120"/>
               </a:rPr>
-              <a:t>_page / _limit mit X-Total-Count &amp; Link-Header</a:t>
+              <a:t>201, Location-Header, Auto-Increment-ID; danach per GET lesbar, per DELETE löschbar</a:t>
             </a:r>
             <a:endParaRPr lang="en-US" sz="1250" dirty="0"/>
           </a:p>
@@ -7584,7 +8354,7 @@
                 <a:ea typeface="Calibri" pitchFamily="34" charset="-122"/>
                 <a:cs typeface="Calibri" pitchFamily="34" charset="-120"/>
               </a:rPr>
-              <a:t>POST Happy Path</a:t>
+              <a:t>PUT / PATCH / DELETE /todos/:id</a:t>
             </a:r>
             <a:endParaRPr lang="en-US" sz="1650" dirty="0"/>
           </a:p>
@@ -7623,7 +8393,7 @@
                 <a:ea typeface="Calibri" pitchFamily="34" charset="-122"/>
                 <a:cs typeface="Calibri" pitchFamily="34" charset="-120"/>
               </a:rPr>
-              <a:t>201, Location-Header, Auto-Increment-ID</a:t>
+              <a:t>Mit gültigem Body korrekt: ersetzen, teilweise ändern, löschen (undokumentiert, #4)</a:t>
             </a:r>
             <a:endParaRPr lang="en-US" sz="1250" dirty="0"/>
           </a:p>
@@ -7748,7 +8518,7 @@
                 <a:ea typeface="Calibri" pitchFamily="34" charset="-122"/>
                 <a:cs typeface="Calibri" pitchFamily="34" charset="-120"/>
               </a:rPr>
-              <a:t>Fehler-Routen</a:t>
+              <a:t>404 für Unbekanntes</a:t>
             </a:r>
             <a:endParaRPr lang="en-US" sz="1650" dirty="0"/>
           </a:p>
@@ -7787,7 +8557,7 @@
                 <a:ea typeface="Calibri" pitchFamily="34" charset="-122"/>
                 <a:cs typeface="Calibri" pitchFamily="34" charset="-120"/>
               </a:rPr>
-              <a:t>Unbekannte Route &amp; gelöschte ID → 404</a:t>
+              <a:t>GET /nonexistent, /todos/999999, gelöschte ID; PUT /todos/888888 legt nichts an</a:t>
             </a:r>
             <a:endParaRPr lang="en-US" sz="1250" dirty="0"/>
           </a:p>
@@ -8017,7 +8787,7 @@
                 <a:ea typeface="Calibri" pitchFamily="34" charset="-122"/>
                 <a:cs typeface="Calibri" pitchFamily="34" charset="-120"/>
               </a:rPr>
-              <a:t>Schreiben auf /roads sperren; CORS vor Go-Live auf die App-Origin begrenzen (#1).</a:t>
+              <a:t>POST / PUT / PATCH auf /roads sperren; CORS auf App-Origin begrenzen (#1).</a:t>
             </a:r>
             <a:endParaRPr lang="en-US" sz="1450" dirty="0"/>
           </a:p>
@@ -8137,7 +8907,7 @@
                 <a:ea typeface="Calibri" pitchFamily="34" charset="-122"/>
                 <a:cs typeface="Calibri" pitchFamily="34" charset="-120"/>
               </a:rPr>
-              <a:t>Pflichtfelder &amp; Schema serverseitig erzwingen (#2, #3).</a:t>
+              <a:t>Pflichtfelder, Typen &amp; road_fid-Bezug prüfen – auch bei PUT / PATCH (#2, #3, #7).</a:t>
             </a:r>
             <a:endParaRPr lang="en-US" sz="1450" dirty="0"/>
           </a:p>

</xml_diff>